<commit_message>
Aggiornate icone presentaizone DiarioDiBordo1_ZeroSixStudio
</commit_message>
<xml_diff>
--- a/src/diari_di_bordo/DiarioDiBordo1_ZeroSixStudio.pptx
+++ b/src/diari_di_bordo/DiarioDiBordo1_ZeroSixStudio.pptx
@@ -142,7 +142,7 @@
       </p:grpSpPr>
       <p:sp>
         <p:nvSpPr>
-          <p:cNvPr id="985785155" name="Header Placeholder 1"/>
+          <p:cNvPr id="1680597095" name="Header Placeholder 1"/>
           <p:cNvSpPr>
             <a:spLocks noGrp="1"/>
           </p:cNvSpPr>
@@ -176,7 +176,7 @@
       </p:sp>
       <p:sp>
         <p:nvSpPr>
-          <p:cNvPr id="461192569" name="Date Placeholder 2"/>
+          <p:cNvPr id="546463927" name="Date Placeholder 2"/>
           <p:cNvSpPr>
             <a:spLocks noGrp="1"/>
           </p:cNvSpPr>
@@ -214,7 +214,7 @@
       </p:sp>
       <p:sp>
         <p:nvSpPr>
-          <p:cNvPr id="1163860604" name="Footer Placeholder 3"/>
+          <p:cNvPr id="208254851" name="Footer Placeholder 3"/>
           <p:cNvSpPr>
             <a:spLocks noGrp="1"/>
           </p:cNvSpPr>
@@ -248,7 +248,7 @@
       </p:sp>
       <p:sp>
         <p:nvSpPr>
-          <p:cNvPr id="259107707" name="Slide Number Placeholder 4"/>
+          <p:cNvPr id="95132235" name="Slide Number Placeholder 4"/>
           <p:cNvSpPr>
             <a:spLocks noGrp="1"/>
           </p:cNvSpPr>
@@ -314,7 +314,7 @@
       </p:grpSpPr>
       <p:sp>
         <p:nvSpPr>
-          <p:cNvPr id="1302927058" name="Header Placeholder 1"/>
+          <p:cNvPr id="1917533724" name="Header Placeholder 1"/>
           <p:cNvSpPr>
             <a:spLocks noGrp="1"/>
           </p:cNvSpPr>
@@ -348,7 +348,7 @@
       </p:sp>
       <p:sp>
         <p:nvSpPr>
-          <p:cNvPr id="1887351866" name="Date Placeholder 2"/>
+          <p:cNvPr id="1796978333" name="Date Placeholder 2"/>
           <p:cNvSpPr>
             <a:spLocks noGrp="1"/>
           </p:cNvSpPr>
@@ -386,7 +386,7 @@
       </p:sp>
       <p:sp>
         <p:nvSpPr>
-          <p:cNvPr id="118826351" name="Slide Image Placeholder 3"/>
+          <p:cNvPr id="1029573240" name="Slide Image Placeholder 3"/>
           <p:cNvSpPr>
             <a:spLocks noChangeAspect="1" noGrp="1" noRot="1"/>
           </p:cNvSpPr>
@@ -422,7 +422,7 @@
       </p:sp>
       <p:sp>
         <p:nvSpPr>
-          <p:cNvPr id="1214321579" name="Notes Placeholder 4"/>
+          <p:cNvPr id="1373723539" name="Notes Placeholder 4"/>
           <p:cNvSpPr>
             <a:spLocks noGrp="1"/>
           </p:cNvSpPr>
@@ -496,7 +496,7 @@
       </p:sp>
       <p:sp>
         <p:nvSpPr>
-          <p:cNvPr id="1999236309" name="Footer Placeholder 5"/>
+          <p:cNvPr id="351681470" name="Footer Placeholder 5"/>
           <p:cNvSpPr>
             <a:spLocks noGrp="1"/>
           </p:cNvSpPr>
@@ -530,7 +530,7 @@
       </p:sp>
       <p:sp>
         <p:nvSpPr>
-          <p:cNvPr id="1432182554" name="Slide Number Placeholder 6"/>
+          <p:cNvPr id="186920074" name="Slide Number Placeholder 6"/>
           <p:cNvSpPr>
             <a:spLocks noGrp="1"/>
           </p:cNvSpPr>
@@ -683,7 +683,7 @@
       </p:grpSpPr>
       <p:sp>
         <p:nvSpPr>
-          <p:cNvPr id="646651869" name="Slide Image Placeholder 1"/>
+          <p:cNvPr id="1850604323" name="Slide Image Placeholder 1"/>
           <p:cNvSpPr>
             <a:spLocks noChangeAspect="1" noGrp="1" noRot="1"/>
           </p:cNvSpPr>
@@ -695,7 +695,7 @@
       </p:sp>
       <p:sp>
         <p:nvSpPr>
-          <p:cNvPr id="741554771" name="Notes Placeholder 2"/>
+          <p:cNvPr id="1229522136" name="Notes Placeholder 2"/>
           <p:cNvSpPr>
             <a:spLocks noGrp="1"/>
           </p:cNvSpPr>
@@ -717,7 +717,7 @@
       </p:sp>
       <p:sp>
         <p:nvSpPr>
-          <p:cNvPr id="410297312" name="Slide Number Placeholder 3"/>
+          <p:cNvPr id="910380205" name="Slide Number Placeholder 3"/>
           <p:cNvSpPr>
             <a:spLocks noGrp="1"/>
           </p:cNvSpPr>
@@ -768,7 +768,7 @@
       </p:grpSpPr>
       <p:sp>
         <p:nvSpPr>
-          <p:cNvPr id="32787955" name="Slide Image Placeholder 1"/>
+          <p:cNvPr id="1827631290" name="Slide Image Placeholder 1"/>
           <p:cNvSpPr>
             <a:spLocks noChangeAspect="1" noGrp="1" noRot="1"/>
           </p:cNvSpPr>
@@ -780,7 +780,7 @@
       </p:sp>
       <p:sp>
         <p:nvSpPr>
-          <p:cNvPr id="1969646922" name="Notes Placeholder 2"/>
+          <p:cNvPr id="1215464762" name="Notes Placeholder 2"/>
           <p:cNvSpPr>
             <a:spLocks noGrp="1"/>
           </p:cNvSpPr>
@@ -802,7 +802,7 @@
       </p:sp>
       <p:sp>
         <p:nvSpPr>
-          <p:cNvPr id="1523514590" name="Slide Number Placeholder 3"/>
+          <p:cNvPr id="1035754318" name="Slide Number Placeholder 3"/>
           <p:cNvSpPr>
             <a:spLocks noGrp="1"/>
           </p:cNvSpPr>
@@ -853,7 +853,7 @@
       </p:grpSpPr>
       <p:sp>
         <p:nvSpPr>
-          <p:cNvPr id="2078714633" name="Slide Image Placeholder 1"/>
+          <p:cNvPr id="1348133705" name="Slide Image Placeholder 1"/>
           <p:cNvSpPr>
             <a:spLocks noChangeAspect="1" noGrp="1" noRot="1"/>
           </p:cNvSpPr>
@@ -865,7 +865,7 @@
       </p:sp>
       <p:sp>
         <p:nvSpPr>
-          <p:cNvPr id="1199246978" name="Notes Placeholder 2"/>
+          <p:cNvPr id="913278784" name="Notes Placeholder 2"/>
           <p:cNvSpPr>
             <a:spLocks noGrp="1"/>
           </p:cNvSpPr>
@@ -887,7 +887,7 @@
       </p:sp>
       <p:sp>
         <p:nvSpPr>
-          <p:cNvPr id="1617196487" name="Slide Number Placeholder 3"/>
+          <p:cNvPr id="807135932" name="Slide Number Placeholder 3"/>
           <p:cNvSpPr>
             <a:spLocks noGrp="1"/>
           </p:cNvSpPr>
@@ -938,7 +938,7 @@
       </p:grpSpPr>
       <p:sp>
         <p:nvSpPr>
-          <p:cNvPr id="301960699" name="Slide Image Placeholder 1"/>
+          <p:cNvPr id="206991420" name="Slide Image Placeholder 1"/>
           <p:cNvSpPr>
             <a:spLocks noChangeAspect="1" noGrp="1" noRot="1"/>
           </p:cNvSpPr>
@@ -950,7 +950,7 @@
       </p:sp>
       <p:sp>
         <p:nvSpPr>
-          <p:cNvPr id="1980457412" name="Notes Placeholder 2"/>
+          <p:cNvPr id="610579485" name="Notes Placeholder 2"/>
           <p:cNvSpPr>
             <a:spLocks noGrp="1"/>
           </p:cNvSpPr>
@@ -972,7 +972,7 @@
       </p:sp>
       <p:sp>
         <p:nvSpPr>
-          <p:cNvPr id="1028717569" name="Slide Number Placeholder 3"/>
+          <p:cNvPr id="136897780" name="Slide Number Placeholder 3"/>
           <p:cNvSpPr>
             <a:spLocks noGrp="1"/>
           </p:cNvSpPr>
@@ -1023,7 +1023,7 @@
       </p:grpSpPr>
       <p:sp>
         <p:nvSpPr>
-          <p:cNvPr id="1486117185" name="Slide Image Placeholder 1"/>
+          <p:cNvPr id="1573253332" name="Slide Image Placeholder 1"/>
           <p:cNvSpPr>
             <a:spLocks noChangeAspect="1" noGrp="1" noRot="1"/>
           </p:cNvSpPr>
@@ -1035,7 +1035,7 @@
       </p:sp>
       <p:sp>
         <p:nvSpPr>
-          <p:cNvPr id="1620081502" name="Notes Placeholder 2"/>
+          <p:cNvPr id="1442387972" name="Notes Placeholder 2"/>
           <p:cNvSpPr>
             <a:spLocks noGrp="1"/>
           </p:cNvSpPr>
@@ -1057,7 +1057,7 @@
       </p:sp>
       <p:sp>
         <p:nvSpPr>
-          <p:cNvPr id="1173342963" name="Slide Number Placeholder 3"/>
+          <p:cNvPr id="1726120834" name="Slide Number Placeholder 3"/>
           <p:cNvSpPr>
             <a:spLocks noGrp="1"/>
           </p:cNvSpPr>
@@ -1108,7 +1108,7 @@
       </p:grpSpPr>
       <p:sp>
         <p:nvSpPr>
-          <p:cNvPr id="2023717913" name="Slide Image Placeholder 1"/>
+          <p:cNvPr id="1644432128" name="Slide Image Placeholder 1"/>
           <p:cNvSpPr>
             <a:spLocks noChangeAspect="1" noGrp="1" noRot="1"/>
           </p:cNvSpPr>
@@ -1120,7 +1120,7 @@
       </p:sp>
       <p:sp>
         <p:nvSpPr>
-          <p:cNvPr id="380425884" name="Notes Placeholder 2"/>
+          <p:cNvPr id="1111735693" name="Notes Placeholder 2"/>
           <p:cNvSpPr>
             <a:spLocks noGrp="1"/>
           </p:cNvSpPr>
@@ -1142,7 +1142,7 @@
       </p:sp>
       <p:sp>
         <p:nvSpPr>
-          <p:cNvPr id="1028984886" name="Slide Number Placeholder 3"/>
+          <p:cNvPr id="162722957" name="Slide Number Placeholder 3"/>
           <p:cNvSpPr>
             <a:spLocks noGrp="1"/>
           </p:cNvSpPr>
@@ -1193,7 +1193,7 @@
       </p:grpSpPr>
       <p:sp>
         <p:nvSpPr>
-          <p:cNvPr id="1928202713" name="Title 1"/>
+          <p:cNvPr id="1852281222" name="Title 1"/>
           <p:cNvSpPr>
             <a:spLocks noGrp="1"/>
           </p:cNvSpPr>
@@ -1228,7 +1228,7 @@
       </p:sp>
       <p:sp>
         <p:nvSpPr>
-          <p:cNvPr id="66052847" name="Subtitle 2"/>
+          <p:cNvPr id="389035758" name="Subtitle 2"/>
           <p:cNvSpPr>
             <a:spLocks noGrp="1"/>
           </p:cNvSpPr>
@@ -1296,7 +1296,7 @@
       </p:sp>
       <p:sp>
         <p:nvSpPr>
-          <p:cNvPr id="824955164" name="Date Placeholder 3"/>
+          <p:cNvPr id="562469946" name="Date Placeholder 3"/>
           <p:cNvSpPr>
             <a:spLocks noGrp="1"/>
           </p:cNvSpPr>
@@ -1322,7 +1322,7 @@
       </p:sp>
       <p:sp>
         <p:nvSpPr>
-          <p:cNvPr id="376335108" name="Footer Placeholder 4"/>
+          <p:cNvPr id="1690731596" name="Footer Placeholder 4"/>
           <p:cNvSpPr>
             <a:spLocks noGrp="1"/>
           </p:cNvSpPr>
@@ -1344,7 +1344,7 @@
       </p:sp>
       <p:sp>
         <p:nvSpPr>
-          <p:cNvPr id="453107427" name="Slide Number Placeholder 5"/>
+          <p:cNvPr id="1851683908" name="Slide Number Placeholder 5"/>
           <p:cNvSpPr>
             <a:spLocks noGrp="1"/>
           </p:cNvSpPr>
@@ -1395,7 +1395,7 @@
       </p:grpSpPr>
       <p:sp>
         <p:nvSpPr>
-          <p:cNvPr id="1940173766" name="Title 1"/>
+          <p:cNvPr id="536409838" name="Title 1"/>
           <p:cNvSpPr>
             <a:spLocks noGrp="1"/>
           </p:cNvSpPr>
@@ -1421,7 +1421,7 @@
       </p:sp>
       <p:sp>
         <p:nvSpPr>
-          <p:cNvPr id="1086475326" name="Vertical Text Placeholder 2"/>
+          <p:cNvPr id="1685135925" name="Vertical Text Placeholder 2"/>
           <p:cNvSpPr>
             <a:spLocks noGrp="1"/>
           </p:cNvSpPr>
@@ -1487,7 +1487,7 @@
       </p:sp>
       <p:sp>
         <p:nvSpPr>
-          <p:cNvPr id="1032765822" name="Date Placeholder 3"/>
+          <p:cNvPr id="2001096622" name="Date Placeholder 3"/>
           <p:cNvSpPr>
             <a:spLocks noGrp="1"/>
           </p:cNvSpPr>
@@ -1513,7 +1513,7 @@
       </p:sp>
       <p:sp>
         <p:nvSpPr>
-          <p:cNvPr id="1692540157" name="Footer Placeholder 4"/>
+          <p:cNvPr id="1064523820" name="Footer Placeholder 4"/>
           <p:cNvSpPr>
             <a:spLocks noGrp="1"/>
           </p:cNvSpPr>
@@ -1535,7 +1535,7 @@
       </p:sp>
       <p:sp>
         <p:nvSpPr>
-          <p:cNvPr id="874872213" name="Slide Number Placeholder 5"/>
+          <p:cNvPr id="119684896" name="Slide Number Placeholder 5"/>
           <p:cNvSpPr>
             <a:spLocks noGrp="1"/>
           </p:cNvSpPr>
@@ -1586,7 +1586,7 @@
       </p:grpSpPr>
       <p:sp>
         <p:nvSpPr>
-          <p:cNvPr id="2006187785" name="Vertical Title 1"/>
+          <p:cNvPr id="1032036824" name="Vertical Title 1"/>
           <p:cNvSpPr>
             <a:spLocks noGrp="1"/>
           </p:cNvSpPr>
@@ -1617,7 +1617,7 @@
       </p:sp>
       <p:sp>
         <p:nvSpPr>
-          <p:cNvPr id="1207700952" name="Vertical Text Placeholder 2"/>
+          <p:cNvPr id="103796755" name="Vertical Text Placeholder 2"/>
           <p:cNvSpPr>
             <a:spLocks noGrp="1"/>
           </p:cNvSpPr>
@@ -1688,7 +1688,7 @@
       </p:sp>
       <p:sp>
         <p:nvSpPr>
-          <p:cNvPr id="1414640922" name="Date Placeholder 3"/>
+          <p:cNvPr id="1354680609" name="Date Placeholder 3"/>
           <p:cNvSpPr>
             <a:spLocks noGrp="1"/>
           </p:cNvSpPr>
@@ -1714,7 +1714,7 @@
       </p:sp>
       <p:sp>
         <p:nvSpPr>
-          <p:cNvPr id="1055516673" name="Footer Placeholder 4"/>
+          <p:cNvPr id="1042115973" name="Footer Placeholder 4"/>
           <p:cNvSpPr>
             <a:spLocks noGrp="1"/>
           </p:cNvSpPr>
@@ -1736,7 +1736,7 @@
       </p:sp>
       <p:sp>
         <p:nvSpPr>
-          <p:cNvPr id="1170068829" name="Slide Number Placeholder 5"/>
+          <p:cNvPr id="1866058036" name="Slide Number Placeholder 5"/>
           <p:cNvSpPr>
             <a:spLocks noGrp="1"/>
           </p:cNvSpPr>
@@ -1787,7 +1787,7 @@
       </p:grpSpPr>
       <p:sp>
         <p:nvSpPr>
-          <p:cNvPr id="938882720" name="Title 1"/>
+          <p:cNvPr id="1164913182" name="Title 1"/>
           <p:cNvSpPr>
             <a:spLocks noGrp="1"/>
           </p:cNvSpPr>
@@ -1813,7 +1813,7 @@
       </p:sp>
       <p:sp>
         <p:nvSpPr>
-          <p:cNvPr id="248867136" name="Content Placeholder 2"/>
+          <p:cNvPr id="1974853652" name="Content Placeholder 2"/>
           <p:cNvSpPr>
             <a:spLocks noGrp="1"/>
           </p:cNvSpPr>
@@ -1879,7 +1879,7 @@
       </p:sp>
       <p:sp>
         <p:nvSpPr>
-          <p:cNvPr id="1922674716" name="Date Placeholder 3"/>
+          <p:cNvPr id="1633313569" name="Date Placeholder 3"/>
           <p:cNvSpPr>
             <a:spLocks noGrp="1"/>
           </p:cNvSpPr>
@@ -1905,7 +1905,7 @@
       </p:sp>
       <p:sp>
         <p:nvSpPr>
-          <p:cNvPr id="6168686" name="Footer Placeholder 4"/>
+          <p:cNvPr id="1573770584" name="Footer Placeholder 4"/>
           <p:cNvSpPr>
             <a:spLocks noGrp="1"/>
           </p:cNvSpPr>
@@ -1927,7 +1927,7 @@
       </p:sp>
       <p:sp>
         <p:nvSpPr>
-          <p:cNvPr id="573796764" name="Slide Number Placeholder 5"/>
+          <p:cNvPr id="495524842" name="Slide Number Placeholder 5"/>
           <p:cNvSpPr>
             <a:spLocks noGrp="1"/>
           </p:cNvSpPr>
@@ -1978,7 +1978,7 @@
       </p:grpSpPr>
       <p:sp>
         <p:nvSpPr>
-          <p:cNvPr id="1466024901" name="Title 1"/>
+          <p:cNvPr id="1632236978" name="Title 1"/>
           <p:cNvSpPr>
             <a:spLocks noGrp="1"/>
           </p:cNvSpPr>
@@ -2013,7 +2013,7 @@
       </p:sp>
       <p:sp>
         <p:nvSpPr>
-          <p:cNvPr id="260548410" name="Text Placeholder 2"/>
+          <p:cNvPr id="2124386698" name="Text Placeholder 2"/>
           <p:cNvSpPr>
             <a:spLocks noGrp="1"/>
           </p:cNvSpPr>
@@ -2135,7 +2135,7 @@
       </p:sp>
       <p:sp>
         <p:nvSpPr>
-          <p:cNvPr id="1770244518" name="Date Placeholder 3"/>
+          <p:cNvPr id="1539697585" name="Date Placeholder 3"/>
           <p:cNvSpPr>
             <a:spLocks noGrp="1"/>
           </p:cNvSpPr>
@@ -2161,7 +2161,7 @@
       </p:sp>
       <p:sp>
         <p:nvSpPr>
-          <p:cNvPr id="1574307512" name="Footer Placeholder 4"/>
+          <p:cNvPr id="1250799297" name="Footer Placeholder 4"/>
           <p:cNvSpPr>
             <a:spLocks noGrp="1"/>
           </p:cNvSpPr>
@@ -2183,7 +2183,7 @@
       </p:sp>
       <p:sp>
         <p:nvSpPr>
-          <p:cNvPr id="2060878015" name="Slide Number Placeholder 5"/>
+          <p:cNvPr id="1181404413" name="Slide Number Placeholder 5"/>
           <p:cNvSpPr>
             <a:spLocks noGrp="1"/>
           </p:cNvSpPr>
@@ -2234,7 +2234,7 @@
       </p:grpSpPr>
       <p:sp>
         <p:nvSpPr>
-          <p:cNvPr id="2093691306" name="Title 1"/>
+          <p:cNvPr id="1826864428" name="Title 1"/>
           <p:cNvSpPr>
             <a:spLocks noGrp="1"/>
           </p:cNvSpPr>
@@ -2260,7 +2260,7 @@
       </p:sp>
       <p:sp>
         <p:nvSpPr>
-          <p:cNvPr id="1483270219" name="Content Placeholder 2"/>
+          <p:cNvPr id="653142336" name="Content Placeholder 2"/>
           <p:cNvSpPr>
             <a:spLocks noGrp="1"/>
           </p:cNvSpPr>
@@ -2331,7 +2331,7 @@
       </p:sp>
       <p:sp>
         <p:nvSpPr>
-          <p:cNvPr id="120732551" name="Content Placeholder 3"/>
+          <p:cNvPr id="610758163" name="Content Placeholder 3"/>
           <p:cNvSpPr>
             <a:spLocks noGrp="1"/>
           </p:cNvSpPr>
@@ -2402,7 +2402,7 @@
       </p:sp>
       <p:sp>
         <p:nvSpPr>
-          <p:cNvPr id="2024801627" name="Date Placeholder 4"/>
+          <p:cNvPr id="896517419" name="Date Placeholder 4"/>
           <p:cNvSpPr>
             <a:spLocks noGrp="1"/>
           </p:cNvSpPr>
@@ -2428,7 +2428,7 @@
       </p:sp>
       <p:sp>
         <p:nvSpPr>
-          <p:cNvPr id="1233432923" name="Footer Placeholder 5"/>
+          <p:cNvPr id="2068598042" name="Footer Placeholder 5"/>
           <p:cNvSpPr>
             <a:spLocks noGrp="1"/>
           </p:cNvSpPr>
@@ -2450,7 +2450,7 @@
       </p:sp>
       <p:sp>
         <p:nvSpPr>
-          <p:cNvPr id="1963392609" name="Slide Number Placeholder 6"/>
+          <p:cNvPr id="1073319697" name="Slide Number Placeholder 6"/>
           <p:cNvSpPr>
             <a:spLocks noGrp="1"/>
           </p:cNvSpPr>
@@ -2501,7 +2501,7 @@
       </p:grpSpPr>
       <p:sp>
         <p:nvSpPr>
-          <p:cNvPr id="1778443374" name="Title 1"/>
+          <p:cNvPr id="1648602741" name="Title 1"/>
           <p:cNvSpPr>
             <a:spLocks noGrp="1"/>
           </p:cNvSpPr>
@@ -2532,7 +2532,7 @@
       </p:sp>
       <p:sp>
         <p:nvSpPr>
-          <p:cNvPr id="1856366945" name="Text Placeholder 2"/>
+          <p:cNvPr id="264829113" name="Text Placeholder 2"/>
           <p:cNvSpPr>
             <a:spLocks noGrp="1"/>
           </p:cNvSpPr>
@@ -2600,7 +2600,7 @@
       </p:sp>
       <p:sp>
         <p:nvSpPr>
-          <p:cNvPr id="462190713" name="Content Placeholder 3"/>
+          <p:cNvPr id="1152967549" name="Content Placeholder 3"/>
           <p:cNvSpPr>
             <a:spLocks noGrp="1"/>
           </p:cNvSpPr>
@@ -2671,7 +2671,7 @@
       </p:sp>
       <p:sp>
         <p:nvSpPr>
-          <p:cNvPr id="1085133048" name="Text Placeholder 4"/>
+          <p:cNvPr id="1814411238" name="Text Placeholder 4"/>
           <p:cNvSpPr>
             <a:spLocks noGrp="1"/>
           </p:cNvSpPr>
@@ -2739,7 +2739,7 @@
       </p:sp>
       <p:sp>
         <p:nvSpPr>
-          <p:cNvPr id="504607825" name="Content Placeholder 5"/>
+          <p:cNvPr id="264063707" name="Content Placeholder 5"/>
           <p:cNvSpPr>
             <a:spLocks noGrp="1"/>
           </p:cNvSpPr>
@@ -2810,7 +2810,7 @@
       </p:sp>
       <p:sp>
         <p:nvSpPr>
-          <p:cNvPr id="370196755" name="Date Placeholder 6"/>
+          <p:cNvPr id="785049252" name="Date Placeholder 6"/>
           <p:cNvSpPr>
             <a:spLocks noGrp="1"/>
           </p:cNvSpPr>
@@ -2836,7 +2836,7 @@
       </p:sp>
       <p:sp>
         <p:nvSpPr>
-          <p:cNvPr id="1772327500" name="Footer Placeholder 7"/>
+          <p:cNvPr id="2046835357" name="Footer Placeholder 7"/>
           <p:cNvSpPr>
             <a:spLocks noGrp="1"/>
           </p:cNvSpPr>
@@ -2858,7 +2858,7 @@
       </p:sp>
       <p:sp>
         <p:nvSpPr>
-          <p:cNvPr id="569050730" name="Slide Number Placeholder 8"/>
+          <p:cNvPr id="25193946" name="Slide Number Placeholder 8"/>
           <p:cNvSpPr>
             <a:spLocks noGrp="1"/>
           </p:cNvSpPr>
@@ -2909,7 +2909,7 @@
       </p:grpSpPr>
       <p:sp>
         <p:nvSpPr>
-          <p:cNvPr id="1650594478" name="Title 1"/>
+          <p:cNvPr id="54493441" name="Title 1"/>
           <p:cNvSpPr>
             <a:spLocks noGrp="1"/>
           </p:cNvSpPr>
@@ -2935,7 +2935,7 @@
       </p:sp>
       <p:sp>
         <p:nvSpPr>
-          <p:cNvPr id="1485666697" name="Date Placeholder 2"/>
+          <p:cNvPr id="1019173843" name="Date Placeholder 2"/>
           <p:cNvSpPr>
             <a:spLocks noGrp="1"/>
           </p:cNvSpPr>
@@ -2961,7 +2961,7 @@
       </p:sp>
       <p:sp>
         <p:nvSpPr>
-          <p:cNvPr id="625886140" name="Footer Placeholder 3"/>
+          <p:cNvPr id="1403747123" name="Footer Placeholder 3"/>
           <p:cNvSpPr>
             <a:spLocks noGrp="1"/>
           </p:cNvSpPr>
@@ -2983,7 +2983,7 @@
       </p:sp>
       <p:sp>
         <p:nvSpPr>
-          <p:cNvPr id="1260366938" name="Slide Number Placeholder 4"/>
+          <p:cNvPr id="2052843892" name="Slide Number Placeholder 4"/>
           <p:cNvSpPr>
             <a:spLocks noGrp="1"/>
           </p:cNvSpPr>
@@ -3034,7 +3034,7 @@
       </p:grpSpPr>
       <p:sp>
         <p:nvSpPr>
-          <p:cNvPr id="690676353" name="Date Placeholder 1"/>
+          <p:cNvPr id="1166136673" name="Date Placeholder 1"/>
           <p:cNvSpPr>
             <a:spLocks noGrp="1"/>
           </p:cNvSpPr>
@@ -3060,7 +3060,7 @@
       </p:sp>
       <p:sp>
         <p:nvSpPr>
-          <p:cNvPr id="2041702" name="Footer Placeholder 2"/>
+          <p:cNvPr id="939473372" name="Footer Placeholder 2"/>
           <p:cNvSpPr>
             <a:spLocks noGrp="1"/>
           </p:cNvSpPr>
@@ -3082,7 +3082,7 @@
       </p:sp>
       <p:sp>
         <p:nvSpPr>
-          <p:cNvPr id="1593459548" name="Slide Number Placeholder 3"/>
+          <p:cNvPr id="1329175972" name="Slide Number Placeholder 3"/>
           <p:cNvSpPr>
             <a:spLocks noGrp="1"/>
           </p:cNvSpPr>
@@ -3133,7 +3133,7 @@
       </p:grpSpPr>
       <p:sp>
         <p:nvSpPr>
-          <p:cNvPr id="1692859874" name="Title 1"/>
+          <p:cNvPr id="1619283044" name="Title 1"/>
           <p:cNvSpPr>
             <a:spLocks noGrp="1"/>
           </p:cNvSpPr>
@@ -3168,7 +3168,7 @@
       </p:sp>
       <p:sp>
         <p:nvSpPr>
-          <p:cNvPr id="2006447122" name="Content Placeholder 2"/>
+          <p:cNvPr id="1547816838" name="Content Placeholder 2"/>
           <p:cNvSpPr>
             <a:spLocks noGrp="1"/>
           </p:cNvSpPr>
@@ -3267,7 +3267,7 @@
       </p:sp>
       <p:sp>
         <p:nvSpPr>
-          <p:cNvPr id="61712521" name="Text Placeholder 3"/>
+          <p:cNvPr id="550504456" name="Text Placeholder 3"/>
           <p:cNvSpPr>
             <a:spLocks noGrp="1"/>
           </p:cNvSpPr>
@@ -3335,7 +3335,7 @@
       </p:sp>
       <p:sp>
         <p:nvSpPr>
-          <p:cNvPr id="1844524074" name="Date Placeholder 4"/>
+          <p:cNvPr id="522092128" name="Date Placeholder 4"/>
           <p:cNvSpPr>
             <a:spLocks noGrp="1"/>
           </p:cNvSpPr>
@@ -3361,7 +3361,7 @@
       </p:sp>
       <p:sp>
         <p:nvSpPr>
-          <p:cNvPr id="737329743" name="Footer Placeholder 5"/>
+          <p:cNvPr id="1788135484" name="Footer Placeholder 5"/>
           <p:cNvSpPr>
             <a:spLocks noGrp="1"/>
           </p:cNvSpPr>
@@ -3383,7 +3383,7 @@
       </p:sp>
       <p:sp>
         <p:nvSpPr>
-          <p:cNvPr id="542162120" name="Slide Number Placeholder 6"/>
+          <p:cNvPr id="896494706" name="Slide Number Placeholder 6"/>
           <p:cNvSpPr>
             <a:spLocks noGrp="1"/>
           </p:cNvSpPr>
@@ -3434,7 +3434,7 @@
       </p:grpSpPr>
       <p:sp>
         <p:nvSpPr>
-          <p:cNvPr id="679457396" name="Title 1"/>
+          <p:cNvPr id="639037918" name="Title 1"/>
           <p:cNvSpPr>
             <a:spLocks noGrp="1"/>
           </p:cNvSpPr>
@@ -3469,7 +3469,7 @@
       </p:sp>
       <p:sp>
         <p:nvSpPr>
-          <p:cNvPr id="348135175" name="Picture Placeholder 2"/>
+          <p:cNvPr id="1168291949" name="Picture Placeholder 2"/>
           <p:cNvSpPr>
             <a:spLocks noChangeAspect="1" noGrp="1"/>
           </p:cNvSpPr>
@@ -3537,7 +3537,7 @@
       </p:sp>
       <p:sp>
         <p:nvSpPr>
-          <p:cNvPr id="1582843658" name="Text Placeholder 3"/>
+          <p:cNvPr id="677715825" name="Text Placeholder 3"/>
           <p:cNvSpPr>
             <a:spLocks noGrp="1"/>
           </p:cNvSpPr>
@@ -3605,7 +3605,7 @@
       </p:sp>
       <p:sp>
         <p:nvSpPr>
-          <p:cNvPr id="1895691344" name="Date Placeholder 4"/>
+          <p:cNvPr id="129206096" name="Date Placeholder 4"/>
           <p:cNvSpPr>
             <a:spLocks noGrp="1"/>
           </p:cNvSpPr>
@@ -3631,7 +3631,7 @@
       </p:sp>
       <p:sp>
         <p:nvSpPr>
-          <p:cNvPr id="1675065704" name="Footer Placeholder 5"/>
+          <p:cNvPr id="11852518" name="Footer Placeholder 5"/>
           <p:cNvSpPr>
             <a:spLocks noGrp="1"/>
           </p:cNvSpPr>
@@ -3653,7 +3653,7 @@
       </p:sp>
       <p:sp>
         <p:nvSpPr>
-          <p:cNvPr id="1280744560" name="Slide Number Placeholder 6"/>
+          <p:cNvPr id="262707852" name="Slide Number Placeholder 6"/>
           <p:cNvSpPr>
             <a:spLocks noGrp="1"/>
           </p:cNvSpPr>
@@ -3722,7 +3722,7 @@
       </p:grpSpPr>
       <p:sp>
         <p:nvSpPr>
-          <p:cNvPr id="902254012" name="Title Placeholder 1"/>
+          <p:cNvPr id="1851724242" name="Title Placeholder 1"/>
           <p:cNvSpPr>
             <a:spLocks noGrp="1"/>
           </p:cNvSpPr>
@@ -3758,7 +3758,7 @@
       </p:sp>
       <p:sp>
         <p:nvSpPr>
-          <p:cNvPr id="306298921" name="Text Placeholder 2"/>
+          <p:cNvPr id="834841791" name="Text Placeholder 2"/>
           <p:cNvSpPr>
             <a:spLocks noGrp="1"/>
           </p:cNvSpPr>
@@ -3834,7 +3834,7 @@
       </p:sp>
       <p:sp>
         <p:nvSpPr>
-          <p:cNvPr id="1780762400" name="Date Placeholder 3"/>
+          <p:cNvPr id="478920496" name="Date Placeholder 3"/>
           <p:cNvSpPr>
             <a:spLocks noGrp="1"/>
           </p:cNvSpPr>
@@ -3878,7 +3878,7 @@
       </p:sp>
       <p:sp>
         <p:nvSpPr>
-          <p:cNvPr id="51327816" name="Footer Placeholder 4"/>
+          <p:cNvPr id="1374045924" name="Footer Placeholder 4"/>
           <p:cNvSpPr>
             <a:spLocks noGrp="1"/>
           </p:cNvSpPr>
@@ -3918,7 +3918,7 @@
       </p:sp>
       <p:sp>
         <p:nvSpPr>
-          <p:cNvPr id="98902238" name="Slide Number Placeholder 5"/>
+          <p:cNvPr id="1687877474" name="Slide Number Placeholder 5"/>
           <p:cNvSpPr>
             <a:spLocks noGrp="1"/>
           </p:cNvSpPr>
@@ -4278,7 +4278,7 @@
       </p:grpSpPr>
       <p:sp>
         <p:nvSpPr>
-          <p:cNvPr id="1576256533" name="Title 1"/>
+          <p:cNvPr id="697860040" name="Title 1"/>
           <p:cNvSpPr>
             <a:spLocks noGrp="1"/>
           </p:cNvSpPr>
@@ -4324,7 +4324,7 @@
       </p:sp>
       <p:sp>
         <p:nvSpPr>
-          <p:cNvPr id="87581731" name="Subtitle 2"/>
+          <p:cNvPr id="2117596412" name="Subtitle 2"/>
           <p:cNvSpPr>
             <a:spLocks noGrp="1"/>
           </p:cNvSpPr>
@@ -4390,7 +4390,7 @@
       </p:sp>
       <p:pic>
         <p:nvPicPr>
-          <p:cNvPr id="1352519171" name=""/>
+          <p:cNvPr id="466567142" name=""/>
           <p:cNvPicPr>
             <a:picLocks noChangeAspect="1"/>
           </p:cNvPicPr>
@@ -4398,12 +4398,11 @@
         </p:nvPicPr>
         <p:blipFill rotWithShape="1">
           <a:blip r:embed="rId3"/>
-          <a:stretch/>
         </p:blipFill>
         <p:spPr bwMode="auto">
           <a:xfrm flipH="0" flipV="0">
-            <a:off x="193591" y="1943520"/>
-            <a:ext cx="4298816" cy="1485479"/>
+            <a:off x="939105" y="2418125"/>
+            <a:ext cx="2807790" cy="929078"/>
           </a:xfrm>
           <a:prstGeom prst="rect">
             <a:avLst/>
@@ -4412,7 +4411,7 @@
       </p:pic>
       <p:sp>
         <p:nvSpPr>
-          <p:cNvPr id="97090709" name="Slide Number Placeholder 5"/>
+          <p:cNvPr id="1808587498" name="Slide Number Placeholder 5"/>
           <p:cNvSpPr>
             <a:spLocks noGrp="1"/>
           </p:cNvSpPr>
@@ -4438,7 +4437,7 @@
       </p:sp>
       <p:sp>
         <p:nvSpPr>
-          <p:cNvPr id="1800736473" name=""/>
+          <p:cNvPr id="1702767056" name=""/>
           <p:cNvSpPr/>
           <p:nvPr/>
         </p:nvSpPr>
@@ -4480,7 +4479,7 @@
       </p:sp>
       <p:sp>
         <p:nvSpPr>
-          <p:cNvPr id="1947743035" name=""/>
+          <p:cNvPr id="268328484" name=""/>
           <p:cNvSpPr/>
           <p:nvPr/>
         </p:nvSpPr>
@@ -4522,7 +4521,7 @@
       </p:sp>
       <p:sp>
         <p:nvSpPr>
-          <p:cNvPr id="1744844491" name=""/>
+          <p:cNvPr id="2057605249" name=""/>
           <p:cNvSpPr/>
           <p:nvPr/>
         </p:nvSpPr>
@@ -4564,7 +4563,7 @@
       </p:sp>
       <p:sp>
         <p:nvSpPr>
-          <p:cNvPr id="1374364718" name=""/>
+          <p:cNvPr id="2003360418" name=""/>
           <p:cNvSpPr/>
           <p:nvPr/>
         </p:nvSpPr>
@@ -4606,7 +4605,7 @@
       </p:sp>
       <p:sp>
         <p:nvSpPr>
-          <p:cNvPr id="262861921" name="Rectangle 9"/>
+          <p:cNvPr id="1284932859" name="Rectangle 9"/>
           <p:cNvSpPr txBox="1"/>
           <p:nvPr/>
         </p:nvSpPr>
@@ -4634,7 +4633,7 @@
       </p:sp>
       <p:sp>
         <p:nvSpPr>
-          <p:cNvPr id="1375867328" name="Rectangle 10"/>
+          <p:cNvPr id="802154972" name="Rectangle 10"/>
           <p:cNvSpPr txBox="1"/>
           <p:nvPr/>
         </p:nvSpPr>
@@ -4680,7 +4679,7 @@
       </p:sp>
       <p:sp>
         <p:nvSpPr>
-          <p:cNvPr id="898444448" name="Rectangle 11"/>
+          <p:cNvPr id="797661599" name="Rectangle 11"/>
           <p:cNvSpPr txBox="1"/>
           <p:nvPr/>
         </p:nvSpPr>
@@ -4726,7 +4725,7 @@
       </p:sp>
       <p:sp>
         <p:nvSpPr>
-          <p:cNvPr id="1817655228" name="Rectangle 12"/>
+          <p:cNvPr id="401349314" name="Rectangle 12"/>
           <p:cNvSpPr txBox="1"/>
           <p:nvPr/>
         </p:nvSpPr>
@@ -4775,7 +4774,7 @@
       </p:sp>
       <p:sp>
         <p:nvSpPr>
-          <p:cNvPr id="302627632" name="Rectangle 13"/>
+          <p:cNvPr id="1939953279" name="Rectangle 13"/>
           <p:cNvSpPr txBox="1"/>
           <p:nvPr/>
         </p:nvSpPr>
@@ -4824,7 +4823,7 @@
       </p:sp>
       <p:sp>
         <p:nvSpPr>
-          <p:cNvPr id="1125981474" name="Flowchart: Alternate process 14"/>
+          <p:cNvPr id="1568389149" name="Flowchart: Alternate process 14"/>
           <p:cNvSpPr/>
           <p:nvPr/>
         </p:nvSpPr>
@@ -4933,13 +4932,117 @@
       </p:sp>
       <p:sp>
         <p:nvSpPr>
-          <p:cNvPr id="225819872" name="Flowchart: Alternate process 14"/>
+          <p:cNvPr id="645227797" name="Flowchart: Alternate process 14"/>
           <p:cNvSpPr/>
           <p:nvPr/>
         </p:nvSpPr>
         <p:spPr bwMode="auto">
           <a:xfrm rot="16199998" flipH="0" flipV="0">
-            <a:off x="4834764" y="2452538"/>
+            <a:off x="4836777" y="2454551"/>
+            <a:ext cx="1124988" cy="656759"/>
+          </a:xfrm>
+          <a:custGeom>
+            <a:avLst>
+              <a:gd name="adj1" fmla="val 16667"/>
+              <a:gd name="adj2" fmla="val 0"/>
+            </a:avLst>
+            <a:gdLst/>
+            <a:ahLst/>
+            <a:cxnLst/>
+            <a:rect l="0" t="0" r="r" b="b"/>
+            <a:pathLst>
+              <a:path w="43200" h="43200" fill="norm" stroke="1" extrusionOk="0">
+                <a:moveTo>
+                  <a:pt x="8020" y="125"/>
+                </a:moveTo>
+                <a:cubicBezTo>
+                  <a:pt x="17916" y="149"/>
+                  <a:pt x="23926" y="441"/>
+                  <a:pt x="36137" y="125"/>
+                </a:cubicBezTo>
+                <a:cubicBezTo>
+                  <a:pt x="40012" y="54"/>
+                  <a:pt x="42994" y="6516"/>
+                  <a:pt x="43167" y="11773"/>
+                </a:cubicBezTo>
+                <a:cubicBezTo>
+                  <a:pt x="43246" y="22503"/>
+                  <a:pt x="43164" y="33018"/>
+                  <a:pt x="43077" y="43200"/>
+                </a:cubicBezTo>
+                <a:lnTo>
+                  <a:pt x="0" y="43200"/>
+                </a:lnTo>
+                <a:lnTo>
+                  <a:pt x="132" y="9898"/>
+                </a:lnTo>
+                <a:cubicBezTo>
+                  <a:pt x="410" y="5021"/>
+                  <a:pt x="4194" y="-378"/>
+                  <a:pt x="8020" y="125"/>
+                </a:cubicBezTo>
+                <a:close/>
+              </a:path>
+            </a:pathLst>
+          </a:custGeom>
+          <a:gradFill>
+            <a:gsLst>
+              <a:gs pos="0">
+                <a:srgbClr val="9551F3">
+                  <a:alpha val="99999"/>
+                </a:srgbClr>
+              </a:gs>
+              <a:gs pos="100000">
+                <a:srgbClr val="002060">
+                  <a:alpha val="99999"/>
+                </a:srgbClr>
+              </a:gs>
+            </a:gsLst>
+            <a:lin ang="2700000" scaled="1"/>
+          </a:gradFill>
+          <a:ln w="6350" cap="flat" cmpd="sng" algn="ctr">
+            <a:solidFill>
+              <a:srgbClr val="0F0F1B"/>
+            </a:solidFill>
+            <a:prstDash val="solid"/>
+            <a:miter lim="800000"/>
+          </a:ln>
+        </p:spPr>
+        <p:style>
+          <a:lnRef idx="2">
+            <a:schemeClr val="accent1">
+              <a:shade val="50000"/>
+            </a:schemeClr>
+          </a:lnRef>
+          <a:fillRef idx="1">
+            <a:schemeClr val="accent1"/>
+          </a:fillRef>
+          <a:effectRef idx="0">
+            <a:schemeClr val="accent1"/>
+          </a:effectRef>
+          <a:fontRef idx="minor">
+            <a:schemeClr val="lt1"/>
+          </a:fontRef>
+        </p:style>
+        <p:txBody>
+          <a:bodyPr anchor="ctr"/>
+          <a:p>
+            <a:pPr algn="ctr">
+              <a:defRPr/>
+            </a:pPr>
+            <a:endParaRPr/>
+          </a:p>
+        </p:txBody>
+      </p:sp>
+      <p:sp>
+        <p:nvSpPr>
+          <p:cNvPr id="1364336091" name="Flowchart: Alternate process 14"/>
+          <p:cNvSpPr/>
+          <p:nvPr/>
+        </p:nvSpPr>
+        <p:spPr bwMode="auto">
+          <a:xfrm rot="16199998" flipH="0" flipV="0">
+            <a:off x="4831345" y="3966364"/>
             <a:ext cx="1129015" cy="656760"/>
           </a:xfrm>
           <a:custGeom>
@@ -5037,111 +5140,7 @@
       </p:sp>
       <p:sp>
         <p:nvSpPr>
-          <p:cNvPr id="1228369645" name="Flowchart: Alternate process 14"/>
-          <p:cNvSpPr/>
-          <p:nvPr/>
-        </p:nvSpPr>
-        <p:spPr bwMode="auto">
-          <a:xfrm rot="16199998" flipH="0" flipV="0">
-            <a:off x="4831345" y="3966364"/>
-            <a:ext cx="1129015" cy="656760"/>
-          </a:xfrm>
-          <a:custGeom>
-            <a:avLst>
-              <a:gd name="adj1" fmla="val 16667"/>
-              <a:gd name="adj2" fmla="val 0"/>
-            </a:avLst>
-            <a:gdLst/>
-            <a:ahLst/>
-            <a:cxnLst/>
-            <a:rect l="0" t="0" r="r" b="b"/>
-            <a:pathLst>
-              <a:path w="43200" h="43200" fill="norm" stroke="1" extrusionOk="0">
-                <a:moveTo>
-                  <a:pt x="7992" y="126"/>
-                </a:moveTo>
-                <a:cubicBezTo>
-                  <a:pt x="17853" y="149"/>
-                  <a:pt x="23841" y="441"/>
-                  <a:pt x="36009" y="126"/>
-                </a:cubicBezTo>
-                <a:cubicBezTo>
-                  <a:pt x="39870" y="54"/>
-                  <a:pt x="43012" y="7398"/>
-                  <a:pt x="43184" y="12655"/>
-                </a:cubicBezTo>
-                <a:cubicBezTo>
-                  <a:pt x="43263" y="23385"/>
-                  <a:pt x="43011" y="33018"/>
-                  <a:pt x="42924" y="43200"/>
-                </a:cubicBezTo>
-                <a:lnTo>
-                  <a:pt x="0" y="43200"/>
-                </a:lnTo>
-                <a:lnTo>
-                  <a:pt x="132" y="9899"/>
-                </a:lnTo>
-                <a:cubicBezTo>
-                  <a:pt x="409" y="5022"/>
-                  <a:pt x="4180" y="-378"/>
-                  <a:pt x="7992" y="126"/>
-                </a:cubicBezTo>
-                <a:close/>
-              </a:path>
-            </a:pathLst>
-          </a:custGeom>
-          <a:gradFill>
-            <a:gsLst>
-              <a:gs pos="0">
-                <a:srgbClr val="9551F3">
-                  <a:alpha val="99999"/>
-                </a:srgbClr>
-              </a:gs>
-              <a:gs pos="100000">
-                <a:srgbClr val="002060">
-                  <a:alpha val="99999"/>
-                </a:srgbClr>
-              </a:gs>
-            </a:gsLst>
-            <a:lin ang="2700000" scaled="1"/>
-          </a:gradFill>
-          <a:ln w="6350" cap="flat" cmpd="sng" algn="ctr">
-            <a:solidFill>
-              <a:srgbClr val="0F0F1B"/>
-            </a:solidFill>
-            <a:prstDash val="solid"/>
-            <a:miter lim="800000"/>
-          </a:ln>
-        </p:spPr>
-        <p:style>
-          <a:lnRef idx="2">
-            <a:schemeClr val="accent1">
-              <a:shade val="50000"/>
-            </a:schemeClr>
-          </a:lnRef>
-          <a:fillRef idx="1">
-            <a:schemeClr val="accent1"/>
-          </a:fillRef>
-          <a:effectRef idx="0">
-            <a:schemeClr val="accent1"/>
-          </a:effectRef>
-          <a:fontRef idx="minor">
-            <a:schemeClr val="lt1"/>
-          </a:fontRef>
-        </p:style>
-        <p:txBody>
-          <a:bodyPr anchor="ctr"/>
-          <a:p>
-            <a:pPr algn="ctr">
-              <a:defRPr/>
-            </a:pPr>
-            <a:endParaRPr/>
-          </a:p>
-        </p:txBody>
-      </p:sp>
-      <p:sp>
-        <p:nvSpPr>
-          <p:cNvPr id="1057576104" name="Flowchart: Alternate process 14"/>
+          <p:cNvPr id="817063639" name="Flowchart: Alternate process 14"/>
           <p:cNvSpPr/>
           <p:nvPr/>
         </p:nvSpPr>
@@ -5248,7 +5247,7 @@
       </p:sp>
       <p:sp>
         <p:nvSpPr>
-          <p:cNvPr id="1034481654" name="Rectangle 18"/>
+          <p:cNvPr id="1093468178" name="Rectangle 18"/>
           <p:cNvSpPr txBox="1"/>
           <p:nvPr/>
         </p:nvSpPr>
@@ -5293,7 +5292,7 @@
       </p:sp>
       <p:sp>
         <p:nvSpPr>
-          <p:cNvPr id="114382343" name="Rectangle 19"/>
+          <p:cNvPr id="504553678" name="Rectangle 19"/>
           <p:cNvSpPr txBox="1"/>
           <p:nvPr/>
         </p:nvSpPr>
@@ -5338,7 +5337,7 @@
       </p:sp>
       <p:sp>
         <p:nvSpPr>
-          <p:cNvPr id="411818749" name="Rectangle 20"/>
+          <p:cNvPr id="680541558" name="Rectangle 20"/>
           <p:cNvSpPr txBox="1"/>
           <p:nvPr/>
         </p:nvSpPr>
@@ -5386,7 +5385,7 @@
       </p:sp>
       <p:sp>
         <p:nvSpPr>
-          <p:cNvPr id="735781963" name="Rectangle 21"/>
+          <p:cNvPr id="1763621809" name="Rectangle 21"/>
           <p:cNvSpPr txBox="1"/>
           <p:nvPr/>
         </p:nvSpPr>
@@ -5481,7 +5480,7 @@
                                           </p:stCondLst>
                                         </p:cTn>
                                         <p:tgtEl>
-                                          <p:spTgt spid="1800736473"/>
+                                          <p:spTgt spid="1702767056"/>
                                         </p:tgtEl>
                                         <p:attrNameLst>
                                           <p:attrName>style.visibility</p:attrName>
@@ -5495,7 +5494,7 @@
                                       <p:cBhvr>
                                         <p:cTn id="54" dur="500"/>
                                         <p:tgtEl>
-                                          <p:spTgt spid="1800736473"/>
+                                          <p:spTgt spid="1702767056"/>
                                         </p:tgtEl>
                                       </p:cBhvr>
                                     </p:animEffect>
@@ -5516,7 +5515,7 @@
                                           </p:stCondLst>
                                         </p:cTn>
                                         <p:tgtEl>
-                                          <p:spTgt spid="1947743035"/>
+                                          <p:spTgt spid="268328484"/>
                                         </p:tgtEl>
                                         <p:attrNameLst>
                                           <p:attrName>style.visibility</p:attrName>
@@ -5530,7 +5529,7 @@
                                       <p:cBhvr>
                                         <p:cTn id="51" dur="500"/>
                                         <p:tgtEl>
-                                          <p:spTgt spid="1947743035"/>
+                                          <p:spTgt spid="268328484"/>
                                         </p:tgtEl>
                                       </p:cBhvr>
                                     </p:animEffect>
@@ -5551,7 +5550,7 @@
                                           </p:stCondLst>
                                         </p:cTn>
                                         <p:tgtEl>
-                                          <p:spTgt spid="1744844491"/>
+                                          <p:spTgt spid="2057605249"/>
                                         </p:tgtEl>
                                         <p:attrNameLst>
                                           <p:attrName>style.visibility</p:attrName>
@@ -5565,7 +5564,7 @@
                                       <p:cBhvr>
                                         <p:cTn id="48" dur="500"/>
                                         <p:tgtEl>
-                                          <p:spTgt spid="1744844491"/>
+                                          <p:spTgt spid="2057605249"/>
                                         </p:tgtEl>
                                       </p:cBhvr>
                                     </p:animEffect>
@@ -5586,7 +5585,7 @@
                                           </p:stCondLst>
                                         </p:cTn>
                                         <p:tgtEl>
-                                          <p:spTgt spid="1374364718"/>
+                                          <p:spTgt spid="2003360418"/>
                                         </p:tgtEl>
                                         <p:attrNameLst>
                                           <p:attrName>style.visibility</p:attrName>
@@ -5600,7 +5599,7 @@
                                       <p:cBhvr>
                                         <p:cTn id="45" dur="500"/>
                                         <p:tgtEl>
-                                          <p:spTgt spid="1374364718"/>
+                                          <p:spTgt spid="2003360418"/>
                                         </p:tgtEl>
                                       </p:cBhvr>
                                     </p:animEffect>
@@ -5621,7 +5620,7 @@
                                           </p:stCondLst>
                                         </p:cTn>
                                         <p:tgtEl>
-                                          <p:spTgt spid="262861921"/>
+                                          <p:spTgt spid="1284932859"/>
                                         </p:tgtEl>
                                         <p:attrNameLst>
                                           <p:attrName>style.visibility</p:attrName>
@@ -5635,7 +5634,7 @@
                                       <p:cBhvr>
                                         <p:cTn id="42" dur="500"/>
                                         <p:tgtEl>
-                                          <p:spTgt spid="262861921"/>
+                                          <p:spTgt spid="1284932859"/>
                                         </p:tgtEl>
                                       </p:cBhvr>
                                     </p:animEffect>
@@ -5656,7 +5655,7 @@
                                           </p:stCondLst>
                                         </p:cTn>
                                         <p:tgtEl>
-                                          <p:spTgt spid="1375867328"/>
+                                          <p:spTgt spid="802154972"/>
                                         </p:tgtEl>
                                         <p:attrNameLst>
                                           <p:attrName>style.visibility</p:attrName>
@@ -5670,7 +5669,7 @@
                                       <p:cBhvr>
                                         <p:cTn id="39" dur="500"/>
                                         <p:tgtEl>
-                                          <p:spTgt spid="1375867328"/>
+                                          <p:spTgt spid="802154972"/>
                                         </p:tgtEl>
                                       </p:cBhvr>
                                     </p:animEffect>
@@ -5691,7 +5690,7 @@
                                           </p:stCondLst>
                                         </p:cTn>
                                         <p:tgtEl>
-                                          <p:spTgt spid="898444448"/>
+                                          <p:spTgt spid="797661599"/>
                                         </p:tgtEl>
                                         <p:attrNameLst>
                                           <p:attrName>style.visibility</p:attrName>
@@ -5705,7 +5704,7 @@
                                       <p:cBhvr>
                                         <p:cTn id="36" dur="500"/>
                                         <p:tgtEl>
-                                          <p:spTgt spid="898444448"/>
+                                          <p:spTgt spid="797661599"/>
                                         </p:tgtEl>
                                       </p:cBhvr>
                                     </p:animEffect>
@@ -5726,7 +5725,7 @@
                                           </p:stCondLst>
                                         </p:cTn>
                                         <p:tgtEl>
-                                          <p:spTgt spid="1817655228"/>
+                                          <p:spTgt spid="401349314"/>
                                         </p:tgtEl>
                                         <p:attrNameLst>
                                           <p:attrName>style.visibility</p:attrName>
@@ -5740,7 +5739,7 @@
                                       <p:cBhvr>
                                         <p:cTn id="33" dur="500"/>
                                         <p:tgtEl>
-                                          <p:spTgt spid="1817655228"/>
+                                          <p:spTgt spid="401349314"/>
                                         </p:tgtEl>
                                       </p:cBhvr>
                                     </p:animEffect>
@@ -5761,7 +5760,7 @@
                                           </p:stCondLst>
                                         </p:cTn>
                                         <p:tgtEl>
-                                          <p:spTgt spid="302627632"/>
+                                          <p:spTgt spid="1939953279"/>
                                         </p:tgtEl>
                                         <p:attrNameLst>
                                           <p:attrName>style.visibility</p:attrName>
@@ -5775,7 +5774,7 @@
                                       <p:cBhvr>
                                         <p:cTn id="30" dur="500"/>
                                         <p:tgtEl>
-                                          <p:spTgt spid="302627632"/>
+                                          <p:spTgt spid="1939953279"/>
                                         </p:tgtEl>
                                       </p:cBhvr>
                                     </p:animEffect>
@@ -5796,7 +5795,7 @@
                                           </p:stCondLst>
                                         </p:cTn>
                                         <p:tgtEl>
-                                          <p:spTgt spid="1125981474"/>
+                                          <p:spTgt spid="1568389149"/>
                                         </p:tgtEl>
                                         <p:attrNameLst>
                                           <p:attrName>style.visibility</p:attrName>
@@ -5810,7 +5809,7 @@
                                       <p:cBhvr>
                                         <p:cTn id="27" dur="500"/>
                                         <p:tgtEl>
-                                          <p:spTgt spid="1125981474"/>
+                                          <p:spTgt spid="1568389149"/>
                                         </p:tgtEl>
                                       </p:cBhvr>
                                     </p:animEffect>
@@ -5831,7 +5830,7 @@
                                           </p:stCondLst>
                                         </p:cTn>
                                         <p:tgtEl>
-                                          <p:spTgt spid="225819872"/>
+                                          <p:spTgt spid="645227797"/>
                                         </p:tgtEl>
                                         <p:attrNameLst>
                                           <p:attrName>style.visibility</p:attrName>
@@ -5845,7 +5844,7 @@
                                       <p:cBhvr>
                                         <p:cTn id="24" dur="500"/>
                                         <p:tgtEl>
-                                          <p:spTgt spid="225819872"/>
+                                          <p:spTgt spid="645227797"/>
                                         </p:tgtEl>
                                       </p:cBhvr>
                                     </p:animEffect>
@@ -5866,7 +5865,7 @@
                                           </p:stCondLst>
                                         </p:cTn>
                                         <p:tgtEl>
-                                          <p:spTgt spid="1228369645"/>
+                                          <p:spTgt spid="1364336091"/>
                                         </p:tgtEl>
                                         <p:attrNameLst>
                                           <p:attrName>style.visibility</p:attrName>
@@ -5880,7 +5879,7 @@
                                       <p:cBhvr>
                                         <p:cTn id="21" dur="500"/>
                                         <p:tgtEl>
-                                          <p:spTgt spid="1228369645"/>
+                                          <p:spTgt spid="1364336091"/>
                                         </p:tgtEl>
                                       </p:cBhvr>
                                     </p:animEffect>
@@ -5901,7 +5900,7 @@
                                           </p:stCondLst>
                                         </p:cTn>
                                         <p:tgtEl>
-                                          <p:spTgt spid="1057576104"/>
+                                          <p:spTgt spid="817063639"/>
                                         </p:tgtEl>
                                         <p:attrNameLst>
                                           <p:attrName>style.visibility</p:attrName>
@@ -5915,7 +5914,7 @@
                                       <p:cBhvr>
                                         <p:cTn id="18" dur="500"/>
                                         <p:tgtEl>
-                                          <p:spTgt spid="1057576104"/>
+                                          <p:spTgt spid="817063639"/>
                                         </p:tgtEl>
                                       </p:cBhvr>
                                     </p:animEffect>
@@ -5936,7 +5935,7 @@
                                           </p:stCondLst>
                                         </p:cTn>
                                         <p:tgtEl>
-                                          <p:spTgt spid="1034481654"/>
+                                          <p:spTgt spid="1093468178"/>
                                         </p:tgtEl>
                                         <p:attrNameLst>
                                           <p:attrName>style.visibility</p:attrName>
@@ -5950,7 +5949,7 @@
                                       <p:cBhvr>
                                         <p:cTn id="15" dur="500"/>
                                         <p:tgtEl>
-                                          <p:spTgt spid="1034481654"/>
+                                          <p:spTgt spid="1093468178"/>
                                         </p:tgtEl>
                                       </p:cBhvr>
                                     </p:animEffect>
@@ -5971,7 +5970,7 @@
                                           </p:stCondLst>
                                         </p:cTn>
                                         <p:tgtEl>
-                                          <p:spTgt spid="114382343"/>
+                                          <p:spTgt spid="504553678"/>
                                         </p:tgtEl>
                                         <p:attrNameLst>
                                           <p:attrName>style.visibility</p:attrName>
@@ -5985,7 +5984,7 @@
                                       <p:cBhvr>
                                         <p:cTn id="12" dur="500"/>
                                         <p:tgtEl>
-                                          <p:spTgt spid="114382343"/>
+                                          <p:spTgt spid="504553678"/>
                                         </p:tgtEl>
                                       </p:cBhvr>
                                     </p:animEffect>
@@ -6006,7 +6005,7 @@
                                           </p:stCondLst>
                                         </p:cTn>
                                         <p:tgtEl>
-                                          <p:spTgt spid="411818749"/>
+                                          <p:spTgt spid="680541558"/>
                                         </p:tgtEl>
                                         <p:attrNameLst>
                                           <p:attrName>style.visibility</p:attrName>
@@ -6020,7 +6019,7 @@
                                       <p:cBhvr>
                                         <p:cTn id="9" dur="500"/>
                                         <p:tgtEl>
-                                          <p:spTgt spid="411818749"/>
+                                          <p:spTgt spid="680541558"/>
                                         </p:tgtEl>
                                       </p:cBhvr>
                                     </p:animEffect>
@@ -6041,7 +6040,7 @@
                                           </p:stCondLst>
                                         </p:cTn>
                                         <p:tgtEl>
-                                          <p:spTgt spid="735781963"/>
+                                          <p:spTgt spid="1763621809"/>
                                         </p:tgtEl>
                                         <p:attrNameLst>
                                           <p:attrName>style.visibility</p:attrName>
@@ -6055,7 +6054,7 @@
                                       <p:cBhvr>
                                         <p:cTn id="6" dur="500"/>
                                         <p:tgtEl>
-                                          <p:spTgt spid="735781963"/>
+                                          <p:spTgt spid="1763621809"/>
                                         </p:tgtEl>
                                       </p:cBhvr>
                                     </p:animEffect>
@@ -6112,7 +6111,7 @@
       </p:grpSpPr>
       <p:sp>
         <p:nvSpPr>
-          <p:cNvPr id="864315419" name="Title 1"/>
+          <p:cNvPr id="1922137123" name="Title 1"/>
           <p:cNvSpPr>
             <a:spLocks noGrp="1"/>
           </p:cNvSpPr>
@@ -6164,7 +6163,7 @@
       </p:sp>
       <p:grpSp>
         <p:nvGrpSpPr>
-          <p:cNvPr id="2089966841" name="Group 62"/>
+          <p:cNvPr id="464793542" name="Group 62"/>
           <p:cNvGrpSpPr/>
           <p:nvPr/>
         </p:nvGrpSpPr>
@@ -6330,7 +6329,7 @@
       </p:grpSp>
       <p:grpSp>
         <p:nvGrpSpPr>
-          <p:cNvPr id="1427821688" name="Group 64"/>
+          <p:cNvPr id="149029921" name="Group 64"/>
           <p:cNvGrpSpPr/>
           <p:nvPr/>
         </p:nvGrpSpPr>
@@ -6496,7 +6495,7 @@
       </p:grpSp>
       <p:grpSp>
         <p:nvGrpSpPr>
-          <p:cNvPr id="1999753003" name="Group 66"/>
+          <p:cNvPr id="1728294586" name="Group 66"/>
           <p:cNvGrpSpPr/>
           <p:nvPr/>
         </p:nvGrpSpPr>
@@ -6662,7 +6661,7 @@
       </p:grpSp>
       <p:grpSp>
         <p:nvGrpSpPr>
-          <p:cNvPr id="835250080" name="Group 68"/>
+          <p:cNvPr id="372098076" name="Group 68"/>
           <p:cNvGrpSpPr/>
           <p:nvPr/>
         </p:nvGrpSpPr>
@@ -6828,7 +6827,7 @@
       </p:grpSp>
       <p:sp>
         <p:nvSpPr>
-          <p:cNvPr id="190128656" name="Rectangle 70"/>
+          <p:cNvPr id="1866511623" name="Rectangle 70"/>
           <p:cNvSpPr txBox="1"/>
           <p:nvPr/>
         </p:nvSpPr>
@@ -6873,7 +6872,7 @@
       </p:sp>
       <p:sp>
         <p:nvSpPr>
-          <p:cNvPr id="640881803" name="Rectangle 71"/>
+          <p:cNvPr id="1682666309" name="Rectangle 71"/>
           <p:cNvSpPr txBox="1"/>
           <p:nvPr/>
         </p:nvSpPr>
@@ -6918,7 +6917,7 @@
       </p:sp>
       <p:sp>
         <p:nvSpPr>
-          <p:cNvPr id="146327239" name="Rectangle 72"/>
+          <p:cNvPr id="734979463" name="Rectangle 72"/>
           <p:cNvSpPr txBox="1"/>
           <p:nvPr/>
         </p:nvSpPr>
@@ -6963,14 +6962,14 @@
       </p:sp>
       <p:sp>
         <p:nvSpPr>
-          <p:cNvPr id="958218608" name="Rectangle 73"/>
+          <p:cNvPr id="976672064" name="Rectangle 73"/>
           <p:cNvSpPr txBox="1"/>
           <p:nvPr/>
         </p:nvSpPr>
         <p:spPr bwMode="auto">
           <a:xfrm rot="0" flipH="0" flipV="0">
             <a:off x="1174131" y="4031649"/>
-            <a:ext cx="4523330" cy="366119"/>
+            <a:ext cx="4523689" cy="366119"/>
           </a:xfrm>
           <a:prstGeom prst="rect">
             <a:avLst/>
@@ -7008,7 +7007,7 @@
       </p:sp>
       <p:grpSp>
         <p:nvGrpSpPr>
-          <p:cNvPr id="1192772700" name="Group 74"/>
+          <p:cNvPr id="1914970234" name="Group 74"/>
           <p:cNvGrpSpPr/>
           <p:nvPr/>
         </p:nvGrpSpPr>
@@ -7174,7 +7173,7 @@
       </p:grpSp>
       <p:sp>
         <p:nvSpPr>
-          <p:cNvPr id="947813721" name="Rectangle 76"/>
+          <p:cNvPr id="588813444" name="Rectangle 76"/>
           <p:cNvSpPr txBox="1"/>
           <p:nvPr/>
         </p:nvSpPr>
@@ -7218,7 +7217,7 @@
       </p:sp>
       <p:grpSp>
         <p:nvGrpSpPr>
-          <p:cNvPr id="1207687651" name="Group 77"/>
+          <p:cNvPr id="277008413" name="Group 77"/>
           <p:cNvGrpSpPr/>
           <p:nvPr/>
         </p:nvGrpSpPr>
@@ -7384,7 +7383,7 @@
       </p:grpSp>
       <p:sp>
         <p:nvSpPr>
-          <p:cNvPr id="407145229" name="Rectangle 79"/>
+          <p:cNvPr id="1926041079" name="Rectangle 79"/>
           <p:cNvSpPr txBox="1"/>
           <p:nvPr/>
         </p:nvSpPr>
@@ -7428,7 +7427,7 @@
       </p:sp>
       <p:grpSp>
         <p:nvGrpSpPr>
-          <p:cNvPr id="1430474631" name="Group 80"/>
+          <p:cNvPr id="958821218" name="Group 80"/>
           <p:cNvGrpSpPr/>
           <p:nvPr/>
         </p:nvGrpSpPr>
@@ -7594,7 +7593,7 @@
       </p:grpSp>
       <p:sp>
         <p:nvSpPr>
-          <p:cNvPr id="872687484" name="Rectangle 82"/>
+          <p:cNvPr id="779891917" name="Rectangle 82"/>
           <p:cNvSpPr txBox="1"/>
           <p:nvPr/>
         </p:nvSpPr>
@@ -7671,7 +7670,7 @@
       </p:sp>
       <p:grpSp>
         <p:nvGrpSpPr>
-          <p:cNvPr id="1137206618" name="Group 83"/>
+          <p:cNvPr id="711436570" name="Group 83"/>
           <p:cNvGrpSpPr/>
           <p:nvPr/>
         </p:nvGrpSpPr>
@@ -7837,7 +7836,7 @@
       </p:grpSp>
       <p:sp>
         <p:nvSpPr>
-          <p:cNvPr id="1546584836" name="Rectangle 85"/>
+          <p:cNvPr id="892797708" name="Rectangle 85"/>
           <p:cNvSpPr txBox="1"/>
           <p:nvPr/>
         </p:nvSpPr>
@@ -7881,7 +7880,7 @@
       </p:sp>
       <p:grpSp>
         <p:nvGrpSpPr>
-          <p:cNvPr id="1957962375" name="Group 86"/>
+          <p:cNvPr id="1915745889" name="Group 86"/>
           <p:cNvGrpSpPr/>
           <p:nvPr/>
         </p:nvGrpSpPr>
@@ -8047,7 +8046,7 @@
       </p:grpSp>
       <p:sp>
         <p:nvSpPr>
-          <p:cNvPr id="1821900029" name="Rectangle 88"/>
+          <p:cNvPr id="1913525597" name="Rectangle 88"/>
           <p:cNvSpPr txBox="1"/>
           <p:nvPr/>
         </p:nvSpPr>
@@ -8092,7 +8091,7 @@
       </p:sp>
       <p:grpSp>
         <p:nvGrpSpPr>
-          <p:cNvPr id="1650391751" name="Group 89"/>
+          <p:cNvPr id="2088253295" name="Group 89"/>
           <p:cNvGrpSpPr/>
           <p:nvPr/>
         </p:nvGrpSpPr>
@@ -8258,7 +8257,7 @@
       </p:grpSp>
       <p:sp>
         <p:nvSpPr>
-          <p:cNvPr id="551164759" name="Rectangle 91"/>
+          <p:cNvPr id="1988027534" name="Rectangle 91"/>
           <p:cNvSpPr txBox="1"/>
           <p:nvPr/>
         </p:nvSpPr>
@@ -8302,13 +8301,13 @@
       </p:sp>
       <p:grpSp>
         <p:nvGrpSpPr>
-          <p:cNvPr id="1736756833" name="Group 92"/>
+          <p:cNvPr id="1315269387" name="Group 92"/>
           <p:cNvGrpSpPr/>
           <p:nvPr/>
         </p:nvGrpSpPr>
         <p:grpSpPr bwMode="auto">
           <a:xfrm flipH="0" flipV="0">
-            <a:off x="6440418" y="5847709"/>
+            <a:off x="6440418" y="5847708"/>
             <a:ext cx="5429269" cy="629307"/>
             <a:chOff x="0" y="0"/>
             <a:chExt cx="5429269" cy="629307"/>
@@ -8468,7 +8467,7 @@
       </p:grpSp>
       <p:sp>
         <p:nvSpPr>
-          <p:cNvPr id="1604520241" name="Rectangle 94"/>
+          <p:cNvPr id="1761750" name="Rectangle 94"/>
           <p:cNvSpPr txBox="1"/>
           <p:nvPr/>
         </p:nvSpPr>
@@ -8510,262 +8509,9 @@
           </a:p>
         </p:txBody>
       </p:sp>
-      <p:pic>
-        <p:nvPicPr>
-          <p:cNvPr id="1517512863" name="Picture 95"/>
-          <p:cNvPicPr>
-            <a:picLocks noChangeAspect="1"/>
-          </p:cNvPicPr>
-          <p:nvPr/>
-        </p:nvPicPr>
-        <p:blipFill rotWithShape="1">
-          <a:blip r:embed="rId6"/>
-          <a:srcRect l="0" t="0" r="43292" b="0"/>
-          <a:stretch/>
-        </p:blipFill>
-        <p:spPr bwMode="auto">
-          <a:xfrm flipH="0" flipV="0">
-            <a:off x="380133" y="1078430"/>
-            <a:ext cx="617432" cy="730034"/>
-          </a:xfrm>
-          <a:prstGeom prst="rect">
-            <a:avLst/>
-          </a:prstGeom>
-        </p:spPr>
-      </p:pic>
-      <p:pic>
-        <p:nvPicPr>
-          <p:cNvPr id="692899693" name="Picture 96"/>
-          <p:cNvPicPr>
-            <a:picLocks noChangeAspect="1"/>
-          </p:cNvPicPr>
-          <p:nvPr/>
-        </p:nvPicPr>
-        <p:blipFill rotWithShape="1">
-          <a:blip r:embed="rId6"/>
-          <a:srcRect l="0" t="0" r="43292" b="0"/>
-          <a:stretch/>
-        </p:blipFill>
-        <p:spPr bwMode="auto">
-          <a:xfrm flipH="0" flipV="0">
-            <a:off x="380133" y="2019232"/>
-            <a:ext cx="617432" cy="730033"/>
-          </a:xfrm>
-          <a:prstGeom prst="rect">
-            <a:avLst/>
-          </a:prstGeom>
-        </p:spPr>
-      </p:pic>
-      <p:pic>
-        <p:nvPicPr>
-          <p:cNvPr id="527621043" name="Picture 97"/>
-          <p:cNvPicPr>
-            <a:picLocks noChangeAspect="1"/>
-          </p:cNvPicPr>
-          <p:nvPr/>
-        </p:nvPicPr>
-        <p:blipFill rotWithShape="1">
-          <a:blip r:embed="rId6"/>
-          <a:srcRect l="0" t="0" r="43292" b="0"/>
-          <a:stretch/>
-        </p:blipFill>
-        <p:spPr bwMode="auto">
-          <a:xfrm flipH="0" flipV="0">
-            <a:off x="380133" y="2880920"/>
-            <a:ext cx="617432" cy="730033"/>
-          </a:xfrm>
-          <a:prstGeom prst="rect">
-            <a:avLst/>
-          </a:prstGeom>
-        </p:spPr>
-      </p:pic>
-      <p:pic>
-        <p:nvPicPr>
-          <p:cNvPr id="1786126831" name="Picture 98"/>
-          <p:cNvPicPr>
-            <a:picLocks noChangeAspect="1"/>
-          </p:cNvPicPr>
-          <p:nvPr/>
-        </p:nvPicPr>
-        <p:blipFill rotWithShape="1">
-          <a:blip r:embed="rId6"/>
-          <a:srcRect l="0" t="0" r="43292" b="0"/>
-          <a:stretch/>
-        </p:blipFill>
-        <p:spPr bwMode="auto">
-          <a:xfrm flipH="0" flipV="0">
-            <a:off x="403944" y="3849689"/>
-            <a:ext cx="617432" cy="730033"/>
-          </a:xfrm>
-          <a:prstGeom prst="rect">
-            <a:avLst/>
-          </a:prstGeom>
-        </p:spPr>
-      </p:pic>
-      <p:pic>
-        <p:nvPicPr>
-          <p:cNvPr id="1268779798" name="Picture 99"/>
-          <p:cNvPicPr>
-            <a:picLocks noChangeAspect="1"/>
-          </p:cNvPicPr>
-          <p:nvPr/>
-        </p:nvPicPr>
-        <p:blipFill rotWithShape="1">
-          <a:blip r:embed="rId6"/>
-          <a:srcRect l="0" t="0" r="43292" b="0"/>
-          <a:stretch/>
-        </p:blipFill>
-        <p:spPr bwMode="auto">
-          <a:xfrm flipH="0" flipV="0">
-            <a:off x="380133" y="4848755"/>
-            <a:ext cx="617432" cy="730033"/>
-          </a:xfrm>
-          <a:prstGeom prst="rect">
-            <a:avLst/>
-          </a:prstGeom>
-        </p:spPr>
-      </p:pic>
-      <p:pic>
-        <p:nvPicPr>
-          <p:cNvPr id="775705204" name="Picture 100"/>
-          <p:cNvPicPr>
-            <a:picLocks noChangeAspect="1"/>
-          </p:cNvPicPr>
-          <p:nvPr/>
-        </p:nvPicPr>
-        <p:blipFill rotWithShape="1">
-          <a:blip r:embed="rId6"/>
-          <a:srcRect l="0" t="0" r="43292" b="0"/>
-          <a:stretch/>
-        </p:blipFill>
-        <p:spPr bwMode="auto">
-          <a:xfrm flipH="0" flipV="0">
-            <a:off x="380133" y="5826654"/>
-            <a:ext cx="617432" cy="730033"/>
-          </a:xfrm>
-          <a:prstGeom prst="rect">
-            <a:avLst/>
-          </a:prstGeom>
-        </p:spPr>
-      </p:pic>
-      <p:pic>
-        <p:nvPicPr>
-          <p:cNvPr id="514485027" name="Picture 101"/>
-          <p:cNvPicPr>
-            <a:picLocks noChangeAspect="1"/>
-          </p:cNvPicPr>
-          <p:nvPr/>
-        </p:nvPicPr>
-        <p:blipFill rotWithShape="1">
-          <a:blip r:embed="rId6"/>
-          <a:srcRect l="0" t="0" r="43292" b="0"/>
-          <a:stretch/>
-        </p:blipFill>
-        <p:spPr bwMode="auto">
-          <a:xfrm flipH="0" flipV="0">
-            <a:off x="6481328" y="1078430"/>
-            <a:ext cx="617432" cy="730033"/>
-          </a:xfrm>
-          <a:prstGeom prst="rect">
-            <a:avLst/>
-          </a:prstGeom>
-        </p:spPr>
-      </p:pic>
-      <p:pic>
-        <p:nvPicPr>
-          <p:cNvPr id="1921808527" name="Picture 102"/>
-          <p:cNvPicPr>
-            <a:picLocks noChangeAspect="1"/>
-          </p:cNvPicPr>
-          <p:nvPr/>
-        </p:nvPicPr>
-        <p:blipFill rotWithShape="1">
-          <a:blip r:embed="rId6"/>
-          <a:srcRect l="0" t="0" r="43292" b="0"/>
-          <a:stretch/>
-        </p:blipFill>
-        <p:spPr bwMode="auto">
-          <a:xfrm flipH="0" flipV="0">
-            <a:off x="6481328" y="2019232"/>
-            <a:ext cx="617432" cy="730033"/>
-          </a:xfrm>
-          <a:prstGeom prst="rect">
-            <a:avLst/>
-          </a:prstGeom>
-        </p:spPr>
-      </p:pic>
-      <p:pic>
-        <p:nvPicPr>
-          <p:cNvPr id="1758978188" name="Picture 103"/>
-          <p:cNvPicPr>
-            <a:picLocks noChangeAspect="1"/>
-          </p:cNvPicPr>
-          <p:nvPr/>
-        </p:nvPicPr>
-        <p:blipFill rotWithShape="1">
-          <a:blip r:embed="rId6"/>
-          <a:srcRect l="0" t="0" r="43292" b="0"/>
-          <a:stretch/>
-        </p:blipFill>
-        <p:spPr bwMode="auto">
-          <a:xfrm flipH="0" flipV="0">
-            <a:off x="6481328" y="2880920"/>
-            <a:ext cx="617432" cy="730033"/>
-          </a:xfrm>
-          <a:prstGeom prst="rect">
-            <a:avLst/>
-          </a:prstGeom>
-        </p:spPr>
-      </p:pic>
-      <p:pic>
-        <p:nvPicPr>
-          <p:cNvPr id="433877431" name="Picture 104"/>
-          <p:cNvPicPr>
-            <a:picLocks noChangeAspect="1"/>
-          </p:cNvPicPr>
-          <p:nvPr/>
-        </p:nvPicPr>
-        <p:blipFill rotWithShape="1">
-          <a:blip r:embed="rId6"/>
-          <a:srcRect l="0" t="0" r="43292" b="0"/>
-          <a:stretch/>
-        </p:blipFill>
-        <p:spPr bwMode="auto">
-          <a:xfrm flipH="0" flipV="0">
-            <a:off x="6481328" y="3849689"/>
-            <a:ext cx="617432" cy="730033"/>
-          </a:xfrm>
-          <a:prstGeom prst="rect">
-            <a:avLst/>
-          </a:prstGeom>
-        </p:spPr>
-      </p:pic>
-      <p:pic>
-        <p:nvPicPr>
-          <p:cNvPr id="1099547216" name="Picture 105"/>
-          <p:cNvPicPr>
-            <a:picLocks noChangeAspect="1"/>
-          </p:cNvPicPr>
-          <p:nvPr/>
-        </p:nvPicPr>
-        <p:blipFill rotWithShape="1">
-          <a:blip r:embed="rId6"/>
-          <a:srcRect l="50000" t="0" r="0" b="0"/>
-          <a:stretch/>
-        </p:blipFill>
-        <p:spPr bwMode="auto">
-          <a:xfrm flipH="0" flipV="0">
-            <a:off x="6481328" y="5783385"/>
-            <a:ext cx="561458" cy="752913"/>
-          </a:xfrm>
-          <a:prstGeom prst="rect">
-            <a:avLst/>
-          </a:prstGeom>
-        </p:spPr>
-      </p:pic>
       <p:grpSp>
         <p:nvGrpSpPr>
-          <p:cNvPr id="1831908010" name="Group 106"/>
+          <p:cNvPr id="1109971024" name="Group 106"/>
           <p:cNvGrpSpPr/>
           <p:nvPr/>
         </p:nvGrpSpPr>
@@ -8931,14 +8677,14 @@
       </p:grpSp>
       <p:sp>
         <p:nvSpPr>
-          <p:cNvPr id="1459181756" name="Rectangle 108"/>
+          <p:cNvPr id="1231005969" name="Rectangle 108"/>
           <p:cNvSpPr txBox="1"/>
           <p:nvPr/>
         </p:nvSpPr>
         <p:spPr bwMode="auto">
           <a:xfrm rot="0" flipH="0" flipV="0">
-            <a:off x="7257872" y="5017485"/>
-            <a:ext cx="4559691" cy="366119"/>
+            <a:off x="7257871" y="5017484"/>
+            <a:ext cx="4560050" cy="366119"/>
           </a:xfrm>
           <a:prstGeom prst="rect">
             <a:avLst/>
@@ -8960,7 +8706,7 @@
                 </a:solidFill>
                 <a:latin typeface="Michroma"/>
                 <a:cs typeface="Michroma"/>
-                <a:hlinkClick r:id="rId7" tooltip=""/>
+                <a:hlinkClick r:id="rId6" tooltip=""/>
               </a:rPr>
               <a:t>Call interna: 2 </a:t>
             </a:r>
@@ -8976,21 +8722,333 @@
       </p:sp>
       <p:pic>
         <p:nvPicPr>
-          <p:cNvPr id="529429840" name="Picture 109"/>
+          <p:cNvPr id="657619679" name="Picture 52"/>
           <p:cNvPicPr>
             <a:picLocks noChangeAspect="1"/>
           </p:cNvPicPr>
           <p:nvPr/>
         </p:nvPicPr>
         <p:blipFill rotWithShape="1">
-          <a:blip r:embed="rId6"/>
-          <a:srcRect l="0" t="0" r="43292" b="0"/>
+          <a:blip r:embed="rId7">
+            <a:extLst>
+              <a:ext uri="{96DAC541-7B7A-43D3-8B79-37D633B846F1}">
+                <asvg:svgBlip xmlns:asvg="http://schemas.microsoft.com/office/drawing/2016/SVG/main" r:embed="rId8"/>
+              </a:ext>
+            </a:extLst>
+          </a:blip>
           <a:stretch/>
         </p:blipFill>
         <p:spPr bwMode="auto">
           <a:xfrm flipH="0" flipV="0">
-            <a:off x="6484899" y="4835526"/>
-            <a:ext cx="617432" cy="730033"/>
+            <a:off x="457333" y="1201664"/>
+            <a:ext cx="467431" cy="467431"/>
+          </a:xfrm>
+          <a:prstGeom prst="rect">
+            <a:avLst/>
+          </a:prstGeom>
+        </p:spPr>
+      </p:pic>
+      <p:pic>
+        <p:nvPicPr>
+          <p:cNvPr id="1444375481" name="Picture 53"/>
+          <p:cNvPicPr>
+            <a:picLocks noChangeAspect="1"/>
+          </p:cNvPicPr>
+          <p:nvPr/>
+        </p:nvPicPr>
+        <p:blipFill rotWithShape="1">
+          <a:blip r:embed="rId7">
+            <a:extLst>
+              <a:ext uri="{96DAC541-7B7A-43D3-8B79-37D633B846F1}">
+                <asvg:svgBlip xmlns:asvg="http://schemas.microsoft.com/office/drawing/2016/SVG/main" r:embed="rId8"/>
+              </a:ext>
+            </a:extLst>
+          </a:blip>
+          <a:stretch/>
+        </p:blipFill>
+        <p:spPr bwMode="auto">
+          <a:xfrm flipH="0" flipV="0">
+            <a:off x="457333" y="2150534"/>
+            <a:ext cx="467430" cy="467430"/>
+          </a:xfrm>
+          <a:prstGeom prst="rect">
+            <a:avLst/>
+          </a:prstGeom>
+        </p:spPr>
+      </p:pic>
+      <p:pic>
+        <p:nvPicPr>
+          <p:cNvPr id="217444960" name="Picture 54"/>
+          <p:cNvPicPr>
+            <a:picLocks noChangeAspect="1"/>
+          </p:cNvPicPr>
+          <p:nvPr/>
+        </p:nvPicPr>
+        <p:blipFill rotWithShape="1">
+          <a:blip r:embed="rId7">
+            <a:extLst>
+              <a:ext uri="{96DAC541-7B7A-43D3-8B79-37D633B846F1}">
+                <asvg:svgBlip xmlns:asvg="http://schemas.microsoft.com/office/drawing/2016/SVG/main" r:embed="rId8"/>
+              </a:ext>
+            </a:extLst>
+          </a:blip>
+          <a:stretch/>
+        </p:blipFill>
+        <p:spPr bwMode="auto">
+          <a:xfrm flipH="0" flipV="0">
+            <a:off x="457333" y="3012223"/>
+            <a:ext cx="467430" cy="467430"/>
+          </a:xfrm>
+          <a:prstGeom prst="rect">
+            <a:avLst/>
+          </a:prstGeom>
+        </p:spPr>
+      </p:pic>
+      <p:pic>
+        <p:nvPicPr>
+          <p:cNvPr id="321598638" name="Picture 55"/>
+          <p:cNvPicPr>
+            <a:picLocks noChangeAspect="1"/>
+          </p:cNvPicPr>
+          <p:nvPr/>
+        </p:nvPicPr>
+        <p:blipFill rotWithShape="1">
+          <a:blip r:embed="rId7">
+            <a:extLst>
+              <a:ext uri="{96DAC541-7B7A-43D3-8B79-37D633B846F1}">
+                <asvg:svgBlip xmlns:asvg="http://schemas.microsoft.com/office/drawing/2016/SVG/main" r:embed="rId8"/>
+              </a:ext>
+            </a:extLst>
+          </a:blip>
+          <a:stretch/>
+        </p:blipFill>
+        <p:spPr bwMode="auto">
+          <a:xfrm flipH="0" flipV="0">
+            <a:off x="467916" y="3980992"/>
+            <a:ext cx="467430" cy="467430"/>
+          </a:xfrm>
+          <a:prstGeom prst="rect">
+            <a:avLst/>
+          </a:prstGeom>
+        </p:spPr>
+      </p:pic>
+      <p:pic>
+        <p:nvPicPr>
+          <p:cNvPr id="1186971665" name="Picture 56"/>
+          <p:cNvPicPr>
+            <a:picLocks noChangeAspect="1"/>
+          </p:cNvPicPr>
+          <p:nvPr/>
+        </p:nvPicPr>
+        <p:blipFill rotWithShape="1">
+          <a:blip r:embed="rId7">
+            <a:extLst>
+              <a:ext uri="{96DAC541-7B7A-43D3-8B79-37D633B846F1}">
+                <asvg:svgBlip xmlns:asvg="http://schemas.microsoft.com/office/drawing/2016/SVG/main" r:embed="rId8"/>
+              </a:ext>
+            </a:extLst>
+          </a:blip>
+          <a:stretch/>
+        </p:blipFill>
+        <p:spPr bwMode="auto">
+          <a:xfrm flipH="0" flipV="0">
+            <a:off x="446750" y="4980057"/>
+            <a:ext cx="467430" cy="467430"/>
+          </a:xfrm>
+          <a:prstGeom prst="rect">
+            <a:avLst/>
+          </a:prstGeom>
+        </p:spPr>
+      </p:pic>
+      <p:pic>
+        <p:nvPicPr>
+          <p:cNvPr id="914360017" name="Picture 57"/>
+          <p:cNvPicPr>
+            <a:picLocks noChangeAspect="1"/>
+          </p:cNvPicPr>
+          <p:nvPr/>
+        </p:nvPicPr>
+        <p:blipFill rotWithShape="1">
+          <a:blip r:embed="rId7">
+            <a:extLst>
+              <a:ext uri="{96DAC541-7B7A-43D3-8B79-37D633B846F1}">
+                <asvg:svgBlip xmlns:asvg="http://schemas.microsoft.com/office/drawing/2016/SVG/main" r:embed="rId8"/>
+              </a:ext>
+            </a:extLst>
+          </a:blip>
+          <a:stretch/>
+        </p:blipFill>
+        <p:spPr bwMode="auto">
+          <a:xfrm flipH="0" flipV="0">
+            <a:off x="446750" y="5966199"/>
+            <a:ext cx="467430" cy="467430"/>
+          </a:xfrm>
+          <a:prstGeom prst="rect">
+            <a:avLst/>
+          </a:prstGeom>
+        </p:spPr>
+      </p:pic>
+      <p:pic>
+        <p:nvPicPr>
+          <p:cNvPr id="1072965399" name="Picture 58"/>
+          <p:cNvPicPr>
+            <a:picLocks noChangeAspect="1"/>
+          </p:cNvPicPr>
+          <p:nvPr/>
+        </p:nvPicPr>
+        <p:blipFill rotWithShape="1">
+          <a:blip r:embed="rId7">
+            <a:extLst>
+              <a:ext uri="{96DAC541-7B7A-43D3-8B79-37D633B846F1}">
+                <asvg:svgBlip xmlns:asvg="http://schemas.microsoft.com/office/drawing/2016/SVG/main" r:embed="rId8"/>
+              </a:ext>
+            </a:extLst>
+          </a:blip>
+          <a:stretch/>
+        </p:blipFill>
+        <p:spPr bwMode="auto">
+          <a:xfrm flipH="0" flipV="0">
+            <a:off x="6549508" y="1201664"/>
+            <a:ext cx="467430" cy="467430"/>
+          </a:xfrm>
+          <a:prstGeom prst="rect">
+            <a:avLst/>
+          </a:prstGeom>
+        </p:spPr>
+      </p:pic>
+      <p:pic>
+        <p:nvPicPr>
+          <p:cNvPr id="360206553" name="Picture 59"/>
+          <p:cNvPicPr>
+            <a:picLocks noChangeAspect="1"/>
+          </p:cNvPicPr>
+          <p:nvPr/>
+        </p:nvPicPr>
+        <p:blipFill rotWithShape="1">
+          <a:blip r:embed="rId7">
+            <a:extLst>
+              <a:ext uri="{96DAC541-7B7A-43D3-8B79-37D633B846F1}">
+                <asvg:svgBlip xmlns:asvg="http://schemas.microsoft.com/office/drawing/2016/SVG/main" r:embed="rId8"/>
+              </a:ext>
+            </a:extLst>
+          </a:blip>
+          <a:stretch/>
+        </p:blipFill>
+        <p:spPr bwMode="auto">
+          <a:xfrm flipH="0" flipV="0">
+            <a:off x="6560091" y="2119873"/>
+            <a:ext cx="467430" cy="467430"/>
+          </a:xfrm>
+          <a:prstGeom prst="rect">
+            <a:avLst/>
+          </a:prstGeom>
+        </p:spPr>
+      </p:pic>
+      <p:pic>
+        <p:nvPicPr>
+          <p:cNvPr id="1588396186" name="Picture 60"/>
+          <p:cNvPicPr>
+            <a:picLocks noChangeAspect="1"/>
+          </p:cNvPicPr>
+          <p:nvPr/>
+        </p:nvPicPr>
+        <p:blipFill rotWithShape="1">
+          <a:blip r:embed="rId7">
+            <a:extLst>
+              <a:ext uri="{96DAC541-7B7A-43D3-8B79-37D633B846F1}">
+                <asvg:svgBlip xmlns:asvg="http://schemas.microsoft.com/office/drawing/2016/SVG/main" r:embed="rId8"/>
+              </a:ext>
+            </a:extLst>
+          </a:blip>
+          <a:stretch/>
+        </p:blipFill>
+        <p:spPr bwMode="auto">
+          <a:xfrm flipH="0" flipV="0">
+            <a:off x="6575355" y="3012223"/>
+            <a:ext cx="467430" cy="467430"/>
+          </a:xfrm>
+          <a:prstGeom prst="rect">
+            <a:avLst/>
+          </a:prstGeom>
+        </p:spPr>
+      </p:pic>
+      <p:pic>
+        <p:nvPicPr>
+          <p:cNvPr id="201742190" name="Picture 61"/>
+          <p:cNvPicPr>
+            <a:picLocks noChangeAspect="1"/>
+          </p:cNvPicPr>
+          <p:nvPr/>
+        </p:nvPicPr>
+        <p:blipFill rotWithShape="1">
+          <a:blip r:embed="rId7">
+            <a:extLst>
+              <a:ext uri="{96DAC541-7B7A-43D3-8B79-37D633B846F1}">
+                <asvg:svgBlip xmlns:asvg="http://schemas.microsoft.com/office/drawing/2016/SVG/main" r:embed="rId8"/>
+              </a:ext>
+            </a:extLst>
+          </a:blip>
+          <a:stretch/>
+        </p:blipFill>
+        <p:spPr bwMode="auto">
+          <a:xfrm flipH="0" flipV="0">
+            <a:off x="6549508" y="3980992"/>
+            <a:ext cx="467430" cy="467430"/>
+          </a:xfrm>
+          <a:prstGeom prst="rect">
+            <a:avLst/>
+          </a:prstGeom>
+        </p:spPr>
+      </p:pic>
+      <p:pic>
+        <p:nvPicPr>
+          <p:cNvPr id="15922105" name="Picture 62"/>
+          <p:cNvPicPr>
+            <a:picLocks noChangeAspect="1"/>
+          </p:cNvPicPr>
+          <p:nvPr/>
+        </p:nvPicPr>
+        <p:blipFill rotWithShape="1">
+          <a:blip r:embed="rId7">
+            <a:extLst>
+              <a:ext uri="{96DAC541-7B7A-43D3-8B79-37D633B846F1}">
+                <asvg:svgBlip xmlns:asvg="http://schemas.microsoft.com/office/drawing/2016/SVG/main" r:embed="rId8"/>
+              </a:ext>
+            </a:extLst>
+          </a:blip>
+          <a:stretch/>
+        </p:blipFill>
+        <p:spPr bwMode="auto">
+          <a:xfrm flipH="0" flipV="0">
+            <a:off x="6560091" y="4980057"/>
+            <a:ext cx="467430" cy="467430"/>
+          </a:xfrm>
+          <a:prstGeom prst="rect">
+            <a:avLst/>
+          </a:prstGeom>
+        </p:spPr>
+      </p:pic>
+      <p:pic>
+        <p:nvPicPr>
+          <p:cNvPr id="990716342" name="Picture 65"/>
+          <p:cNvPicPr>
+            <a:picLocks noChangeAspect="1"/>
+          </p:cNvPicPr>
+          <p:nvPr/>
+        </p:nvPicPr>
+        <p:blipFill rotWithShape="1">
+          <a:blip r:embed="rId9">
+            <a:extLst>
+              <a:ext uri="{96DAC541-7B7A-43D3-8B79-37D633B846F1}">
+                <asvg:svgBlip xmlns:asvg="http://schemas.microsoft.com/office/drawing/2016/SVG/main" r:embed="rId10"/>
+              </a:ext>
+            </a:extLst>
+          </a:blip>
+        </p:blipFill>
+        <p:spPr bwMode="auto">
+          <a:xfrm flipH="0" flipV="0">
+            <a:off x="6549508" y="5936790"/>
+            <a:ext cx="467430" cy="467430"/>
           </a:xfrm>
           <a:prstGeom prst="rect">
             <a:avLst/>
@@ -9037,7 +9095,7 @@
       </p:grpSpPr>
       <p:sp>
         <p:nvSpPr>
-          <p:cNvPr id="1167260803" name="Title 1"/>
+          <p:cNvPr id="712414078" name="Title 1"/>
           <p:cNvSpPr>
             <a:spLocks noGrp="1"/>
           </p:cNvSpPr>
@@ -9089,7 +9147,7 @@
       </p:sp>
       <p:grpSp>
         <p:nvGrpSpPr>
-          <p:cNvPr id="329392342" name="Group 2"/>
+          <p:cNvPr id="829425874" name="Group 2"/>
           <p:cNvGrpSpPr/>
           <p:nvPr/>
         </p:nvGrpSpPr>
@@ -9255,7 +9313,7 @@
       </p:grpSp>
       <p:grpSp>
         <p:nvGrpSpPr>
-          <p:cNvPr id="1304517785" name="Group 5"/>
+          <p:cNvPr id="2124462235" name="Group 5"/>
           <p:cNvGrpSpPr/>
           <p:nvPr/>
         </p:nvGrpSpPr>
@@ -9421,7 +9479,7 @@
       </p:grpSp>
       <p:grpSp>
         <p:nvGrpSpPr>
-          <p:cNvPr id="1903427850" name="Group 8"/>
+          <p:cNvPr id="290627112" name="Group 8"/>
           <p:cNvGrpSpPr/>
           <p:nvPr/>
         </p:nvGrpSpPr>
@@ -9587,7 +9645,7 @@
       </p:grpSp>
       <p:sp>
         <p:nvSpPr>
-          <p:cNvPr id="1475199515" name="Rectangle 14"/>
+          <p:cNvPr id="714007354" name="Rectangle 14"/>
           <p:cNvSpPr txBox="1"/>
           <p:nvPr/>
         </p:nvSpPr>
@@ -9631,7 +9689,7 @@
       </p:sp>
       <p:sp>
         <p:nvSpPr>
-          <p:cNvPr id="1939174329" name="Rectangle 15"/>
+          <p:cNvPr id="846293226" name="Rectangle 15"/>
           <p:cNvSpPr txBox="1"/>
           <p:nvPr/>
         </p:nvSpPr>
@@ -9675,7 +9733,7 @@
       </p:sp>
       <p:sp>
         <p:nvSpPr>
-          <p:cNvPr id="807879020" name="Rectangle 16"/>
+          <p:cNvPr id="1313664251" name="Rectangle 16"/>
           <p:cNvSpPr txBox="1"/>
           <p:nvPr/>
         </p:nvSpPr>
@@ -9725,7 +9783,7 @@
       </p:sp>
       <p:grpSp>
         <p:nvGrpSpPr>
-          <p:cNvPr id="1612400785" name="Group 56"/>
+          <p:cNvPr id="771430268" name="Group 56"/>
           <p:cNvGrpSpPr/>
           <p:nvPr/>
         </p:nvGrpSpPr>
@@ -9891,7 +9949,7 @@
       </p:grpSp>
       <p:sp>
         <p:nvSpPr>
-          <p:cNvPr id="145868224" name="Rectangle 58"/>
+          <p:cNvPr id="1418999668" name="Rectangle 58"/>
           <p:cNvSpPr txBox="1"/>
           <p:nvPr/>
         </p:nvSpPr>
@@ -9936,7 +9994,7 @@
       </p:sp>
       <p:sp>
         <p:nvSpPr>
-          <p:cNvPr id="248014064" name="Flowchart: Alternate process 64"/>
+          <p:cNvPr id="760168387" name="Flowchart: Alternate process 64"/>
           <p:cNvSpPr/>
           <p:nvPr/>
         </p:nvSpPr>
@@ -10030,14 +10088,14 @@
       </p:sp>
       <p:sp>
         <p:nvSpPr>
-          <p:cNvPr id="2079465567" name="Rectangle 65"/>
+          <p:cNvPr id="1121993144" name="Rectangle 65"/>
           <p:cNvSpPr txBox="1"/>
           <p:nvPr/>
         </p:nvSpPr>
         <p:spPr bwMode="auto">
           <a:xfrm rot="0" flipH="0" flipV="0">
-            <a:off x="299017" y="1480790"/>
-            <a:ext cx="825231" cy="701399"/>
+            <a:off x="299016" y="1480789"/>
+            <a:ext cx="825590" cy="701399"/>
           </a:xfrm>
           <a:prstGeom prst="rect">
             <a:avLst/>
@@ -10071,7 +10129,7 @@
               <a:defRPr/>
             </a:pPr>
             <a:r>
-              <a:rPr lang="fr-FR" sz="2800">
+              <a:rPr lang="fr-FR" sz="2800" b="1">
                 <a:solidFill>
                   <a:srgbClr val="FF0000"/>
                 </a:solidFill>
@@ -10084,14 +10142,14 @@
       </p:sp>
       <p:sp>
         <p:nvSpPr>
-          <p:cNvPr id="2068392413" name="Rectangle 66"/>
+          <p:cNvPr id="435909104" name="Rectangle 66"/>
           <p:cNvSpPr txBox="1"/>
           <p:nvPr/>
         </p:nvSpPr>
         <p:spPr bwMode="auto">
           <a:xfrm rot="0" flipH="0" flipV="0">
-            <a:off x="296031" y="2215767"/>
-            <a:ext cx="818751" cy="701399"/>
+            <a:off x="296030" y="2215766"/>
+            <a:ext cx="819110" cy="701399"/>
           </a:xfrm>
           <a:prstGeom prst="rect">
             <a:avLst/>
@@ -10125,27 +10183,27 @@
               <a:defRPr/>
             </a:pPr>
             <a:r>
-              <a:rPr lang="fr-FR" sz="2800">
+              <a:rPr lang="fr-FR" sz="2800" b="1">
                 <a:solidFill>
                   <a:srgbClr val="FF0000"/>
                 </a:solidFill>
               </a:rPr>
               <a:t>30</a:t>
             </a:r>
-            <a:endParaRPr sz="1400"/>
+            <a:endParaRPr sz="1400" b="1"/>
           </a:p>
         </p:txBody>
       </p:sp>
       <p:sp>
         <p:nvSpPr>
-          <p:cNvPr id="1202899423" name="Rectangle 67"/>
+          <p:cNvPr id="1557053405" name="Rectangle 67"/>
           <p:cNvSpPr txBox="1"/>
           <p:nvPr/>
         </p:nvSpPr>
         <p:spPr bwMode="auto">
           <a:xfrm rot="0" flipH="0" flipV="0">
-            <a:off x="312622" y="2929288"/>
-            <a:ext cx="818751" cy="701399"/>
+            <a:off x="312621" y="2929287"/>
+            <a:ext cx="819110" cy="701399"/>
           </a:xfrm>
           <a:prstGeom prst="rect">
             <a:avLst/>
@@ -10179,27 +10237,27 @@
               <a:defRPr/>
             </a:pPr>
             <a:r>
-              <a:rPr lang="fr-FR" sz="2800">
+              <a:rPr lang="fr-FR" sz="2800" b="1">
                 <a:solidFill>
                   <a:srgbClr val="FF0000"/>
                 </a:solidFill>
               </a:rPr>
               <a:t>29</a:t>
             </a:r>
-            <a:endParaRPr sz="1400"/>
+            <a:endParaRPr sz="1400" b="1"/>
           </a:p>
         </p:txBody>
       </p:sp>
       <p:sp>
         <p:nvSpPr>
-          <p:cNvPr id="1603513704" name="Rectangle 68"/>
+          <p:cNvPr id="231262687" name="Rectangle 68"/>
           <p:cNvSpPr txBox="1"/>
           <p:nvPr/>
         </p:nvSpPr>
         <p:spPr bwMode="auto">
           <a:xfrm rot="0" flipH="0" flipV="0">
-            <a:off x="297937" y="3652973"/>
-            <a:ext cx="818751" cy="701399"/>
+            <a:off x="297936" y="3652972"/>
+            <a:ext cx="819110" cy="701399"/>
           </a:xfrm>
           <a:prstGeom prst="rect">
             <a:avLst/>
@@ -10233,20 +10291,20 @@
               <a:defRPr/>
             </a:pPr>
             <a:r>
-              <a:rPr lang="fr-FR" sz="2800">
+              <a:rPr lang="fr-FR" sz="2800" b="1">
                 <a:solidFill>
                   <a:srgbClr val="FF0000"/>
                 </a:solidFill>
               </a:rPr>
               <a:t>30</a:t>
             </a:r>
-            <a:endParaRPr sz="1400"/>
+            <a:endParaRPr sz="1400" b="1"/>
           </a:p>
         </p:txBody>
       </p:sp>
       <p:grpSp>
         <p:nvGrpSpPr>
-          <p:cNvPr id="1297858915" name="Group 69"/>
+          <p:cNvPr id="2051232548" name="Group 69"/>
           <p:cNvGrpSpPr/>
           <p:nvPr/>
         </p:nvGrpSpPr>
@@ -10412,7 +10470,7 @@
       </p:grpSp>
       <p:grpSp>
         <p:nvGrpSpPr>
-          <p:cNvPr id="742257913" name="Group 71"/>
+          <p:cNvPr id="1553870218" name="Group 71"/>
           <p:cNvGrpSpPr/>
           <p:nvPr/>
         </p:nvGrpSpPr>
@@ -10578,7 +10636,7 @@
       </p:grpSp>
       <p:sp>
         <p:nvSpPr>
-          <p:cNvPr id="1298329246" name="Rectangle 75"/>
+          <p:cNvPr id="172462490" name="Rectangle 75"/>
           <p:cNvSpPr txBox="1"/>
           <p:nvPr/>
         </p:nvSpPr>
@@ -10617,7 +10675,7 @@
       </p:sp>
       <p:sp>
         <p:nvSpPr>
-          <p:cNvPr id="164778092" name="Rectangle 76"/>
+          <p:cNvPr id="193520749" name="Rectangle 76"/>
           <p:cNvSpPr txBox="1"/>
           <p:nvPr/>
         </p:nvSpPr>
@@ -10661,14 +10719,14 @@
       </p:sp>
       <p:sp>
         <p:nvSpPr>
-          <p:cNvPr id="1336530540" name="Rectangle 82"/>
+          <p:cNvPr id="1127195306" name="Rectangle 82"/>
           <p:cNvSpPr txBox="1"/>
           <p:nvPr/>
         </p:nvSpPr>
         <p:spPr bwMode="auto">
           <a:xfrm rot="0" flipH="0" flipV="0">
-            <a:off x="6431000" y="1474439"/>
-            <a:ext cx="827031" cy="701399"/>
+            <a:off x="6430999" y="1474438"/>
+            <a:ext cx="827390" cy="701399"/>
           </a:xfrm>
           <a:prstGeom prst="rect">
             <a:avLst/>
@@ -10702,20 +10760,20 @@
               <a:defRPr/>
             </a:pPr>
             <a:r>
-              <a:rPr lang="fr-FR" sz="2800">
+              <a:rPr lang="fr-FR" sz="2800" b="1">
                 <a:solidFill>
                   <a:srgbClr val="FF0000"/>
                 </a:solidFill>
               </a:rPr>
               <a:t> 2</a:t>
             </a:r>
-            <a:endParaRPr sz="1400"/>
+            <a:endParaRPr sz="1400" b="1"/>
           </a:p>
         </p:txBody>
       </p:sp>
       <p:sp>
         <p:nvSpPr>
-          <p:cNvPr id="1277288408" name="Flowchart: Alternate process 103"/>
+          <p:cNvPr id="1323745656" name="Flowchart: Alternate process 103"/>
           <p:cNvSpPr/>
           <p:nvPr/>
         </p:nvSpPr>
@@ -10805,7 +10863,7 @@
       </p:sp>
       <p:grpSp>
         <p:nvGrpSpPr>
-          <p:cNvPr id="1946481036" name="Group 110"/>
+          <p:cNvPr id="706121253" name="Group 110"/>
           <p:cNvGrpSpPr/>
           <p:nvPr/>
         </p:nvGrpSpPr>
@@ -10971,7 +11029,7 @@
       </p:grpSp>
       <p:grpSp>
         <p:nvGrpSpPr>
-          <p:cNvPr id="1213020452" name="Group 112"/>
+          <p:cNvPr id="1133376437" name="Group 112"/>
           <p:cNvGrpSpPr/>
           <p:nvPr/>
         </p:nvGrpSpPr>
@@ -11137,7 +11195,7 @@
       </p:grpSp>
       <p:sp>
         <p:nvSpPr>
-          <p:cNvPr id="1814794617" name="Rectangle 114"/>
+          <p:cNvPr id="1696093517" name="Rectangle 114"/>
           <p:cNvSpPr txBox="1"/>
           <p:nvPr/>
         </p:nvSpPr>
@@ -11188,7 +11246,7 @@
       </p:sp>
       <p:sp>
         <p:nvSpPr>
-          <p:cNvPr id="1849289592" name="Rectangle 115"/>
+          <p:cNvPr id="793804314" name="Rectangle 115"/>
           <p:cNvSpPr txBox="1"/>
           <p:nvPr/>
         </p:nvSpPr>
@@ -11239,14 +11297,14 @@
       </p:sp>
       <p:sp>
         <p:nvSpPr>
-          <p:cNvPr id="818809121" name="Rectangle 116"/>
+          <p:cNvPr id="1572611968" name="Rectangle 116"/>
           <p:cNvSpPr txBox="1"/>
           <p:nvPr/>
         </p:nvSpPr>
         <p:spPr bwMode="auto">
           <a:xfrm rot="0" flipH="0" flipV="0">
-            <a:off x="298521" y="5159637"/>
-            <a:ext cx="828111" cy="701399"/>
+            <a:off x="298520" y="5159637"/>
+            <a:ext cx="828470" cy="701399"/>
           </a:xfrm>
           <a:prstGeom prst="rect">
             <a:avLst/>
@@ -11280,27 +11338,27 @@
               <a:defRPr/>
             </a:pPr>
             <a:r>
-              <a:rPr lang="fr-FR" sz="2800">
+              <a:rPr lang="fr-FR" sz="2800" b="1">
                 <a:solidFill>
                   <a:srgbClr val="FF0000"/>
                 </a:solidFill>
               </a:rPr>
               <a:t> 1</a:t>
             </a:r>
-            <a:endParaRPr sz="1400"/>
+            <a:endParaRPr sz="1400" b="1"/>
           </a:p>
         </p:txBody>
       </p:sp>
       <p:sp>
         <p:nvSpPr>
-          <p:cNvPr id="1910104860" name="Rectangle 117"/>
+          <p:cNvPr id="1620091321" name="Rectangle 117"/>
           <p:cNvSpPr txBox="1"/>
           <p:nvPr/>
         </p:nvSpPr>
         <p:spPr bwMode="auto">
           <a:xfrm rot="0" flipH="0" flipV="0">
-            <a:off x="295535" y="5905197"/>
-            <a:ext cx="823071" cy="701399"/>
+            <a:off x="295534" y="5905197"/>
+            <a:ext cx="823430" cy="701399"/>
           </a:xfrm>
           <a:prstGeom prst="rect">
             <a:avLst/>
@@ -11334,20 +11392,20 @@
               <a:defRPr/>
             </a:pPr>
             <a:r>
-              <a:rPr lang="fr-FR" sz="2800">
+              <a:rPr lang="fr-FR" sz="2800" b="1">
                 <a:solidFill>
                   <a:srgbClr val="FF0000"/>
                 </a:solidFill>
               </a:rPr>
               <a:t> 1</a:t>
             </a:r>
-            <a:endParaRPr sz="1400"/>
+            <a:endParaRPr sz="1400" b="1"/>
           </a:p>
         </p:txBody>
       </p:sp>
       <p:sp>
         <p:nvSpPr>
-          <p:cNvPr id="1793403897" name="Flowchart: Alternate process 118"/>
+          <p:cNvPr id="755871580" name="Flowchart: Alternate process 118"/>
           <p:cNvSpPr/>
           <p:nvPr/>
         </p:nvSpPr>
@@ -11437,14 +11495,14 @@
       </p:sp>
       <p:sp>
         <p:nvSpPr>
-          <p:cNvPr id="685091081" name="Rectangle 119"/>
+          <p:cNvPr id="653857009" name="Rectangle 119"/>
           <p:cNvSpPr txBox="1"/>
           <p:nvPr/>
         </p:nvSpPr>
         <p:spPr bwMode="auto">
           <a:xfrm rot="0" flipH="0" flipV="0">
-            <a:off x="6431000" y="2189644"/>
-            <a:ext cx="828111" cy="701399"/>
+            <a:off x="6430999" y="2189643"/>
+            <a:ext cx="828470" cy="701399"/>
           </a:xfrm>
           <a:prstGeom prst="rect">
             <a:avLst/>
@@ -11478,14 +11536,14 @@
               <a:defRPr/>
             </a:pPr>
             <a:r>
-              <a:rPr lang="fr-FR" sz="2800">
+              <a:rPr lang="fr-FR" sz="2800" b="1">
                 <a:solidFill>
                   <a:srgbClr val="FF0000"/>
                 </a:solidFill>
               </a:rPr>
               <a:t> 3</a:t>
             </a:r>
-            <a:endParaRPr sz="1400"/>
+            <a:endParaRPr sz="1400" b="1"/>
           </a:p>
         </p:txBody>
       </p:sp>
@@ -11528,7 +11586,7 @@
       </p:grpSpPr>
       <p:sp>
         <p:nvSpPr>
-          <p:cNvPr id="1497096974" name="Title 1"/>
+          <p:cNvPr id="329921568" name="Title 1"/>
           <p:cNvSpPr>
             <a:spLocks noGrp="1"/>
           </p:cNvSpPr>
@@ -11580,7 +11638,7 @@
       </p:sp>
       <p:grpSp>
         <p:nvGrpSpPr>
-          <p:cNvPr id="656184688" name="Group 2"/>
+          <p:cNvPr id="453853073" name="Group 2"/>
           <p:cNvGrpSpPr/>
           <p:nvPr/>
         </p:nvGrpSpPr>
@@ -11746,7 +11804,7 @@
       </p:grpSp>
       <p:grpSp>
         <p:nvGrpSpPr>
-          <p:cNvPr id="276200236" name="Group 5"/>
+          <p:cNvPr id="958528873" name="Group 5"/>
           <p:cNvGrpSpPr/>
           <p:nvPr/>
         </p:nvGrpSpPr>
@@ -11912,7 +11970,7 @@
       </p:grpSp>
       <p:grpSp>
         <p:nvGrpSpPr>
-          <p:cNvPr id="879380141" name="Group 8"/>
+          <p:cNvPr id="751916719" name="Group 8"/>
           <p:cNvGrpSpPr/>
           <p:nvPr/>
         </p:nvGrpSpPr>
@@ -12078,7 +12136,7 @@
       </p:grpSp>
       <p:sp>
         <p:nvSpPr>
-          <p:cNvPr id="2100208188" name="Rectangle 14"/>
+          <p:cNvPr id="75505583" name="Rectangle 14"/>
           <p:cNvSpPr txBox="1"/>
           <p:nvPr/>
         </p:nvSpPr>
@@ -12122,7 +12180,7 @@
       </p:sp>
       <p:sp>
         <p:nvSpPr>
-          <p:cNvPr id="534255268" name="Rectangle 15"/>
+          <p:cNvPr id="344010587" name="Rectangle 15"/>
           <p:cNvSpPr txBox="1"/>
           <p:nvPr/>
         </p:nvSpPr>
@@ -12167,7 +12225,7 @@
       </p:sp>
       <p:sp>
         <p:nvSpPr>
-          <p:cNvPr id="1976866735" name="Rectangle 16"/>
+          <p:cNvPr id="120823684" name="Rectangle 16"/>
           <p:cNvSpPr txBox="1"/>
           <p:nvPr/>
         </p:nvSpPr>
@@ -12211,7 +12269,7 @@
       </p:sp>
       <p:grpSp>
         <p:nvGrpSpPr>
-          <p:cNvPr id="1476013443" name="Group 66"/>
+          <p:cNvPr id="187545028" name="Group 66"/>
           <p:cNvGrpSpPr/>
           <p:nvPr/>
         </p:nvGrpSpPr>
@@ -12377,7 +12435,7 @@
       </p:grpSp>
       <p:sp>
         <p:nvSpPr>
-          <p:cNvPr id="1831865806" name="Rectangle 68"/>
+          <p:cNvPr id="1527699410" name="Rectangle 68"/>
           <p:cNvSpPr txBox="1"/>
           <p:nvPr/>
         </p:nvSpPr>
@@ -12421,7 +12479,7 @@
       </p:sp>
       <p:grpSp>
         <p:nvGrpSpPr>
-          <p:cNvPr id="1230626305" name="Group 118"/>
+          <p:cNvPr id="2058855112" name="Group 118"/>
           <p:cNvGrpSpPr/>
           <p:nvPr/>
         </p:nvGrpSpPr>
@@ -12587,7 +12645,7 @@
       </p:grpSp>
       <p:sp>
         <p:nvSpPr>
-          <p:cNvPr id="712852362" name="Rectangle 120"/>
+          <p:cNvPr id="2003696336" name="Rectangle 120"/>
           <p:cNvSpPr txBox="1"/>
           <p:nvPr/>
         </p:nvSpPr>
@@ -12631,20 +12689,25 @@
       </p:sp>
       <p:pic>
         <p:nvPicPr>
-          <p:cNvPr id="2033801309" name="Picture 122"/>
+          <p:cNvPr id="232027022" name="Picture 22"/>
           <p:cNvPicPr>
             <a:picLocks noChangeAspect="1"/>
           </p:cNvPicPr>
           <p:nvPr/>
         </p:nvPicPr>
         <p:blipFill rotWithShape="1">
-          <a:blip r:embed="rId3"/>
-          <a:stretch/>
+          <a:blip r:embed="rId3">
+            <a:extLst>
+              <a:ext uri="{96DAC541-7B7A-43D3-8B79-37D633B846F1}">
+                <asvg:svgBlip xmlns:asvg="http://schemas.microsoft.com/office/drawing/2016/SVG/main" r:embed="rId4"/>
+              </a:ext>
+            </a:extLst>
+          </a:blip>
         </p:blipFill>
         <p:spPr bwMode="auto">
           <a:xfrm flipH="0" flipV="0">
-            <a:off x="3320804" y="1147892"/>
-            <a:ext cx="766528" cy="572341"/>
+            <a:off x="3477816" y="1209734"/>
+            <a:ext cx="467430" cy="467430"/>
           </a:xfrm>
           <a:prstGeom prst="rect">
             <a:avLst/>
@@ -12653,20 +12716,25 @@
       </p:pic>
       <p:pic>
         <p:nvPicPr>
-          <p:cNvPr id="990737872" name="Picture 123"/>
+          <p:cNvPr id="2016503548" name="Picture 25"/>
           <p:cNvPicPr>
             <a:picLocks noChangeAspect="1"/>
           </p:cNvPicPr>
           <p:nvPr/>
         </p:nvPicPr>
         <p:blipFill rotWithShape="1">
-          <a:blip r:embed="rId3"/>
-          <a:stretch/>
+          <a:blip r:embed="rId3">
+            <a:extLst>
+              <a:ext uri="{96DAC541-7B7A-43D3-8B79-37D633B846F1}">
+                <asvg:svgBlip xmlns:asvg="http://schemas.microsoft.com/office/drawing/2016/SVG/main" r:embed="rId4"/>
+              </a:ext>
+            </a:extLst>
+          </a:blip>
         </p:blipFill>
         <p:spPr bwMode="auto">
           <a:xfrm flipH="0" flipV="0">
-            <a:off x="3329001" y="2037848"/>
-            <a:ext cx="766527" cy="572340"/>
+            <a:off x="3488399" y="2097618"/>
+            <a:ext cx="467430" cy="467430"/>
           </a:xfrm>
           <a:prstGeom prst="rect">
             <a:avLst/>
@@ -12675,20 +12743,25 @@
       </p:pic>
       <p:pic>
         <p:nvPicPr>
-          <p:cNvPr id="1219760571" name="Picture 124"/>
+          <p:cNvPr id="1568876101" name="Picture 26"/>
           <p:cNvPicPr>
             <a:picLocks noChangeAspect="1"/>
           </p:cNvPicPr>
           <p:nvPr/>
         </p:nvPicPr>
         <p:blipFill rotWithShape="1">
-          <a:blip r:embed="rId3"/>
-          <a:stretch/>
+          <a:blip r:embed="rId3">
+            <a:extLst>
+              <a:ext uri="{96DAC541-7B7A-43D3-8B79-37D633B846F1}">
+                <asvg:svgBlip xmlns:asvg="http://schemas.microsoft.com/office/drawing/2016/SVG/main" r:embed="rId4"/>
+              </a:ext>
+            </a:extLst>
+          </a:blip>
         </p:blipFill>
         <p:spPr bwMode="auto">
           <a:xfrm flipH="0" flipV="0">
-            <a:off x="3329001" y="2917436"/>
-            <a:ext cx="766527" cy="572340"/>
+            <a:off x="3488399" y="2972152"/>
+            <a:ext cx="467430" cy="467430"/>
           </a:xfrm>
           <a:prstGeom prst="rect">
             <a:avLst/>
@@ -12697,20 +12770,25 @@
       </p:pic>
       <p:pic>
         <p:nvPicPr>
-          <p:cNvPr id="163391132" name="Picture 125"/>
+          <p:cNvPr id="2095990148" name="Picture 27"/>
           <p:cNvPicPr>
             <a:picLocks noChangeAspect="1"/>
           </p:cNvPicPr>
           <p:nvPr/>
         </p:nvPicPr>
         <p:blipFill rotWithShape="1">
-          <a:blip r:embed="rId3"/>
-          <a:stretch/>
+          <a:blip r:embed="rId3">
+            <a:extLst>
+              <a:ext uri="{96DAC541-7B7A-43D3-8B79-37D633B846F1}">
+                <asvg:svgBlip xmlns:asvg="http://schemas.microsoft.com/office/drawing/2016/SVG/main" r:embed="rId4"/>
+              </a:ext>
+            </a:extLst>
+          </a:blip>
         </p:blipFill>
         <p:spPr bwMode="auto">
           <a:xfrm flipH="0" flipV="0">
-            <a:off x="3331387" y="3789502"/>
-            <a:ext cx="766527" cy="572340"/>
+            <a:off x="3488399" y="3841956"/>
+            <a:ext cx="467430" cy="467430"/>
           </a:xfrm>
           <a:prstGeom prst="rect">
             <a:avLst/>
@@ -12719,20 +12797,25 @@
       </p:pic>
       <p:pic>
         <p:nvPicPr>
-          <p:cNvPr id="1842516214" name="Picture 126"/>
+          <p:cNvPr id="1348116505" name="Picture 28"/>
           <p:cNvPicPr>
             <a:picLocks noChangeAspect="1"/>
           </p:cNvPicPr>
           <p:nvPr/>
         </p:nvPicPr>
         <p:blipFill rotWithShape="1">
-          <a:blip r:embed="rId3"/>
-          <a:stretch/>
+          <a:blip r:embed="rId3">
+            <a:extLst>
+              <a:ext uri="{96DAC541-7B7A-43D3-8B79-37D633B846F1}">
+                <asvg:svgBlip xmlns:asvg="http://schemas.microsoft.com/office/drawing/2016/SVG/main" r:embed="rId4"/>
+              </a:ext>
+            </a:extLst>
+          </a:blip>
         </p:blipFill>
         <p:spPr bwMode="auto">
           <a:xfrm flipH="0" flipV="0">
-            <a:off x="3329001" y="4637122"/>
-            <a:ext cx="766527" cy="572340"/>
+            <a:off x="3477816" y="4692855"/>
+            <a:ext cx="467430" cy="467430"/>
           </a:xfrm>
           <a:prstGeom prst="rect">
             <a:avLst/>
@@ -12778,7 +12861,7 @@
       </p:grpSpPr>
       <p:sp>
         <p:nvSpPr>
-          <p:cNvPr id="1916984170" name="Title 1"/>
+          <p:cNvPr id="1356165231" name="Title 1"/>
           <p:cNvSpPr>
             <a:spLocks noGrp="1"/>
           </p:cNvSpPr>
@@ -12830,7 +12913,7 @@
       </p:sp>
       <p:grpSp>
         <p:nvGrpSpPr>
-          <p:cNvPr id="1593935840" name="Group 22"/>
+          <p:cNvPr id="1590870366" name="Group 22"/>
           <p:cNvGrpSpPr/>
           <p:nvPr/>
         </p:nvGrpSpPr>
@@ -12996,7 +13079,7 @@
       </p:grpSp>
       <p:grpSp>
         <p:nvGrpSpPr>
-          <p:cNvPr id="1828164406" name="Group 24"/>
+          <p:cNvPr id="1294230343" name="Group 24"/>
           <p:cNvGrpSpPr/>
           <p:nvPr/>
         </p:nvGrpSpPr>
@@ -13162,7 +13245,7 @@
       </p:grpSp>
       <p:grpSp>
         <p:nvGrpSpPr>
-          <p:cNvPr id="926095326" name="Group 26"/>
+          <p:cNvPr id="1812961239" name="Group 26"/>
           <p:cNvGrpSpPr/>
           <p:nvPr/>
         </p:nvGrpSpPr>
@@ -13328,7 +13411,7 @@
       </p:grpSp>
       <p:grpSp>
         <p:nvGrpSpPr>
-          <p:cNvPr id="1159892838" name="Group 28"/>
+          <p:cNvPr id="609507312" name="Group 28"/>
           <p:cNvGrpSpPr/>
           <p:nvPr/>
         </p:nvGrpSpPr>
@@ -13494,7 +13577,7 @@
       </p:grpSp>
       <p:sp>
         <p:nvSpPr>
-          <p:cNvPr id="371008325" name="Rectangle 30"/>
+          <p:cNvPr id="253243758" name="Rectangle 30"/>
           <p:cNvSpPr txBox="1"/>
           <p:nvPr/>
         </p:nvSpPr>
@@ -13549,7 +13632,7 @@
       </p:sp>
       <p:sp>
         <p:nvSpPr>
-          <p:cNvPr id="1888965978" name="Rectangle 31"/>
+          <p:cNvPr id="160399269" name="Rectangle 31"/>
           <p:cNvSpPr txBox="1"/>
           <p:nvPr/>
         </p:nvSpPr>
@@ -13594,7 +13677,7 @@
       </p:sp>
       <p:sp>
         <p:nvSpPr>
-          <p:cNvPr id="233223489" name="Rectangle 32"/>
+          <p:cNvPr id="1473452145" name="Rectangle 32"/>
           <p:cNvSpPr txBox="1"/>
           <p:nvPr/>
         </p:nvSpPr>
@@ -13639,7 +13722,7 @@
       </p:sp>
       <p:sp>
         <p:nvSpPr>
-          <p:cNvPr id="726540228" name="Rectangle 33"/>
+          <p:cNvPr id="2139534573" name="Rectangle 33"/>
           <p:cNvSpPr txBox="1"/>
           <p:nvPr/>
         </p:nvSpPr>
@@ -13696,7 +13779,7 @@
       </p:sp>
       <p:grpSp>
         <p:nvGrpSpPr>
-          <p:cNvPr id="987559156" name="Group 34"/>
+          <p:cNvPr id="429886564" name="Group 34"/>
           <p:cNvGrpSpPr/>
           <p:nvPr/>
         </p:nvGrpSpPr>
@@ -13862,13 +13945,13 @@
       </p:grpSp>
       <p:sp>
         <p:nvSpPr>
-          <p:cNvPr id="2121874749" name="Rectangle 36"/>
+          <p:cNvPr id="392683103" name="Rectangle 36"/>
           <p:cNvSpPr txBox="1"/>
           <p:nvPr/>
         </p:nvSpPr>
         <p:spPr bwMode="auto">
           <a:xfrm rot="0" flipH="0" flipV="0">
-            <a:off x="4193069" y="4812314"/>
+            <a:off x="4193069" y="4812313"/>
             <a:ext cx="4560051" cy="366119"/>
           </a:xfrm>
           <a:prstGeom prst="rect">
@@ -13906,19 +13989,25 @@
       </p:sp>
       <p:pic>
         <p:nvPicPr>
-          <p:cNvPr id="949919050" name="Picture 70"/>
+          <p:cNvPr id="1964190037" name="Picture 22"/>
           <p:cNvPicPr>
             <a:picLocks noChangeAspect="1"/>
           </p:cNvPicPr>
           <p:nvPr/>
         </p:nvPicPr>
         <p:blipFill rotWithShape="1">
-          <a:blip r:embed="rId3"/>
+          <a:blip r:embed="rId3">
+            <a:extLst>
+              <a:ext uri="{96DAC541-7B7A-43D3-8B79-37D633B846F1}">
+                <asvg:svgBlip xmlns:asvg="http://schemas.microsoft.com/office/drawing/2016/SVG/main" r:embed="rId4"/>
+              </a:ext>
+            </a:extLst>
+          </a:blip>
         </p:blipFill>
         <p:spPr bwMode="auto">
           <a:xfrm flipH="0" flipV="0">
-            <a:off x="3322729" y="1140701"/>
-            <a:ext cx="764547" cy="570861"/>
+            <a:off x="3477816" y="1199150"/>
+            <a:ext cx="467430" cy="467430"/>
           </a:xfrm>
           <a:prstGeom prst="rect">
             <a:avLst/>
@@ -13927,19 +14016,25 @@
       </p:pic>
       <p:pic>
         <p:nvPicPr>
-          <p:cNvPr id="1122531296" name="Picture 71"/>
+          <p:cNvPr id="398497392" name="Picture 23"/>
           <p:cNvPicPr>
             <a:picLocks noChangeAspect="1"/>
           </p:cNvPicPr>
           <p:nvPr/>
         </p:nvPicPr>
         <p:blipFill rotWithShape="1">
-          <a:blip r:embed="rId3"/>
+          <a:blip r:embed="rId3">
+            <a:extLst>
+              <a:ext uri="{96DAC541-7B7A-43D3-8B79-37D633B846F1}">
+                <asvg:svgBlip xmlns:asvg="http://schemas.microsoft.com/office/drawing/2016/SVG/main" r:embed="rId4"/>
+              </a:ext>
+            </a:extLst>
+          </a:blip>
         </p:blipFill>
         <p:spPr bwMode="auto">
           <a:xfrm flipH="0" flipV="0">
-            <a:off x="3322729" y="2070920"/>
-            <a:ext cx="764547" cy="570861"/>
+            <a:off x="3477816" y="2122634"/>
+            <a:ext cx="467430" cy="467430"/>
           </a:xfrm>
           <a:prstGeom prst="rect">
             <a:avLst/>
@@ -13948,19 +14043,25 @@
       </p:pic>
       <p:pic>
         <p:nvPicPr>
-          <p:cNvPr id="1562379801" name="Picture 72"/>
+          <p:cNvPr id="2114200154" name="Picture 24"/>
           <p:cNvPicPr>
             <a:picLocks noChangeAspect="1"/>
           </p:cNvPicPr>
           <p:nvPr/>
         </p:nvPicPr>
         <p:blipFill rotWithShape="1">
-          <a:blip r:embed="rId3"/>
+          <a:blip r:embed="rId3">
+            <a:extLst>
+              <a:ext uri="{96DAC541-7B7A-43D3-8B79-37D633B846F1}">
+                <asvg:svgBlip xmlns:asvg="http://schemas.microsoft.com/office/drawing/2016/SVG/main" r:embed="rId4"/>
+              </a:ext>
+            </a:extLst>
+          </a:blip>
         </p:blipFill>
         <p:spPr bwMode="auto">
           <a:xfrm flipH="0" flipV="0">
-            <a:off x="3322729" y="2932608"/>
-            <a:ext cx="764547" cy="570861"/>
+            <a:off x="3477816" y="2982062"/>
+            <a:ext cx="467430" cy="467430"/>
           </a:xfrm>
           <a:prstGeom prst="rect">
             <a:avLst/>
@@ -13969,19 +14070,25 @@
       </p:pic>
       <p:pic>
         <p:nvPicPr>
-          <p:cNvPr id="326190177" name="Picture 73"/>
+          <p:cNvPr id="1613330658" name="Picture 25"/>
           <p:cNvPicPr>
             <a:picLocks noChangeAspect="1"/>
           </p:cNvPicPr>
           <p:nvPr/>
         </p:nvPicPr>
         <p:blipFill rotWithShape="1">
-          <a:blip r:embed="rId3"/>
+          <a:blip r:embed="rId3">
+            <a:extLst>
+              <a:ext uri="{96DAC541-7B7A-43D3-8B79-37D633B846F1}">
+                <asvg:svgBlip xmlns:asvg="http://schemas.microsoft.com/office/drawing/2016/SVG/main" r:embed="rId4"/>
+              </a:ext>
+            </a:extLst>
+          </a:blip>
         </p:blipFill>
         <p:spPr bwMode="auto">
           <a:xfrm flipH="0" flipV="0">
-            <a:off x="3322729" y="3827287"/>
-            <a:ext cx="764547" cy="570861"/>
+            <a:off x="3488399" y="3870383"/>
+            <a:ext cx="467430" cy="467430"/>
           </a:xfrm>
           <a:prstGeom prst="rect">
             <a:avLst/>
@@ -13990,19 +14097,25 @@
       </p:pic>
       <p:pic>
         <p:nvPicPr>
-          <p:cNvPr id="408431408" name="Picture 74"/>
+          <p:cNvPr id="427348821" name="Picture 26"/>
           <p:cNvPicPr>
             <a:picLocks noChangeAspect="1"/>
           </p:cNvPicPr>
           <p:nvPr/>
         </p:nvPicPr>
         <p:blipFill rotWithShape="1">
-          <a:blip r:embed="rId3"/>
+          <a:blip r:embed="rId3">
+            <a:extLst>
+              <a:ext uri="{96DAC541-7B7A-43D3-8B79-37D633B846F1}">
+                <asvg:svgBlip xmlns:asvg="http://schemas.microsoft.com/office/drawing/2016/SVG/main" r:embed="rId4"/>
+              </a:ext>
+            </a:extLst>
+          </a:blip>
         </p:blipFill>
         <p:spPr bwMode="auto">
           <a:xfrm flipH="0" flipV="0">
-            <a:off x="3354479" y="4709943"/>
-            <a:ext cx="764547" cy="570861"/>
+            <a:off x="3477816" y="4761657"/>
+            <a:ext cx="467430" cy="467430"/>
           </a:xfrm>
           <a:prstGeom prst="rect">
             <a:avLst/>
@@ -14048,7 +14161,7 @@
       </p:grpSpPr>
       <p:sp>
         <p:nvSpPr>
-          <p:cNvPr id="972704913" name="Title 1"/>
+          <p:cNvPr id="555031221" name="Title 1"/>
           <p:cNvSpPr>
             <a:spLocks noGrp="1"/>
           </p:cNvSpPr>
@@ -14058,7 +14171,7 @@
         </p:nvSpPr>
         <p:spPr bwMode="auto">
           <a:xfrm flipH="0" flipV="0">
-            <a:off x="3739004" y="2514948"/>
+            <a:off x="3749357" y="2514947"/>
             <a:ext cx="4703581" cy="1294743"/>
           </a:xfrm>
         </p:spPr>
@@ -14094,7 +14207,7 @@
       </p:sp>
       <p:sp>
         <p:nvSpPr>
-          <p:cNvPr id="1490949826" name="Subtitle 2"/>
+          <p:cNvPr id="863362206" name="Subtitle 2"/>
           <p:cNvSpPr>
             <a:spLocks noGrp="1"/>
           </p:cNvSpPr>
@@ -14104,7 +14217,7 @@
         </p:nvSpPr>
         <p:spPr bwMode="auto">
           <a:xfrm flipH="0" flipV="0">
-            <a:off x="4082664" y="3896105"/>
+            <a:off x="4061956" y="3896104"/>
             <a:ext cx="4143864" cy="394222"/>
           </a:xfrm>
         </p:spPr>
@@ -14148,9 +14261,35 @@
           </a:p>
         </p:txBody>
       </p:sp>
+      <p:sp>
+        <p:nvSpPr>
+          <p:cNvPr id="1005624193" name="Slide Number Placeholder 5"/>
+          <p:cNvSpPr>
+            <a:spLocks noGrp="1"/>
+          </p:cNvSpPr>
+          <p:nvPr>
+            <p:ph type="sldNum" sz="quarter" idx="12"/>
+          </p:nvPr>
+        </p:nvSpPr>
+        <p:spPr bwMode="auto"/>
+        <p:txBody>
+          <a:bodyPr/>
+          <a:lstStyle/>
+          <a:p>
+            <a:pPr>
+              <a:defRPr/>
+            </a:pPr>
+            <a:fld id="{831E1D6D-2301-946D-6050-67FB814A68C9}" type="slidenum">
+              <a:rPr/>
+              <a:t>1</a:t>
+            </a:fld>
+            <a:endParaRPr/>
+          </a:p>
+        </p:txBody>
+      </p:sp>
       <p:pic>
         <p:nvPicPr>
-          <p:cNvPr id="698572564" name=""/>
+          <p:cNvPr id="152497793" name="Picture 5"/>
           <p:cNvPicPr>
             <a:picLocks noChangeAspect="1"/>
           </p:cNvPicPr>
@@ -14158,72 +14297,17 @@
         </p:nvPicPr>
         <p:blipFill rotWithShape="1">
           <a:blip r:embed="rId4"/>
-          <a:stretch/>
         </p:blipFill>
         <p:spPr bwMode="auto">
           <a:xfrm flipH="0" flipV="0">
-            <a:off x="3941385" y="1029468"/>
-            <a:ext cx="4298815" cy="1485478"/>
+            <a:off x="4583366" y="1289619"/>
+            <a:ext cx="3003154" cy="993722"/>
           </a:xfrm>
           <a:prstGeom prst="rect">
             <a:avLst/>
           </a:prstGeom>
         </p:spPr>
       </p:pic>
-      <p:sp>
-        <p:nvSpPr>
-          <p:cNvPr id="1509156523" name="Slide Number Placeholder 5"/>
-          <p:cNvSpPr>
-            <a:spLocks noGrp="1"/>
-          </p:cNvSpPr>
-          <p:nvPr>
-            <p:ph type="sldNum" sz="quarter" idx="12"/>
-          </p:nvPr>
-        </p:nvSpPr>
-        <p:spPr bwMode="auto"/>
-        <p:txBody>
-          <a:bodyPr/>
-          <a:lstStyle/>
-          <a:p>
-            <a:pPr>
-              <a:defRPr/>
-            </a:pPr>
-            <a:fld id="{831E1D6D-2301-946D-6050-67FB814A68C9}" type="slidenum">
-              <a:rPr/>
-              <a:t>1</a:t>
-            </a:fld>
-            <a:endParaRPr/>
-          </a:p>
-        </p:txBody>
-      </p:sp>
-      <p:sp>
-        <p:nvSpPr>
-          <p:cNvPr id="419069902" name="Rectangle 9"/>
-          <p:cNvSpPr txBox="1"/>
-          <p:nvPr/>
-        </p:nvSpPr>
-        <p:spPr bwMode="auto">
-          <a:xfrm rot="0" flipH="0" flipV="0">
-            <a:off x="5889468" y="3062880"/>
-            <a:ext cx="914400" cy="366118"/>
-          </a:xfrm>
-          <a:prstGeom prst="rect">
-            <a:avLst/>
-          </a:prstGeom>
-          <a:noFill/>
-        </p:spPr>
-        <p:txBody>
-          <a:bodyPr vertOverflow="overflow" horzOverflow="overflow" vert="horz" wrap="none" lIns="91440" tIns="45720" rIns="91440" bIns="45720" numCol="1" spcCol="0" rtlCol="0" fromWordArt="0" anchor="t" anchorCtr="0" forceAA="0" upright="0" compatLnSpc="0">
-            <a:spAutoFit/>
-          </a:bodyPr>
-          <a:p>
-            <a:pPr>
-              <a:defRPr/>
-            </a:pPr>
-            <a:endParaRPr/>
-          </a:p>
-        </p:txBody>
-      </p:sp>
     </p:spTree>
   </p:cSld>
   <p:clrMapOvr>
@@ -14237,89 +14321,7 @@
       <p:transition advClick="1"/>
     </mc:Fallback>
   </mc:AlternateContent>
-  <p:timing>
-    <p:tnLst>
-      <p:par>
-        <p:cTn id="1" dur="indefinite" restart="never" nodeType="tmRoot">
-          <p:childTnLst>
-            <p:seq concurrent="1" nextAc="seek">
-              <p:cTn id="2" dur="indefinite" nodeType="mainSeq">
-                <p:childTnLst>
-                  <p:par>
-                    <p:cTn id="3" fill="hold">
-                      <p:stCondLst>
-                        <p:cond delay="indefinite"/>
-                      </p:stCondLst>
-                      <p:childTnLst>
-                        <p:par>
-                          <p:cTn id="4" fill="hold">
-                            <p:stCondLst>
-                              <p:cond delay="0"/>
-                            </p:stCondLst>
-                            <p:childTnLst>
-                              <p:par>
-                                <p:cTn id="41" presetID="10" presetClass="entr" presetSubtype="0" fill="hold" grpId="0" nodeType="withEffect">
-                                  <p:stCondLst>
-                                    <p:cond delay="0"/>
-                                  </p:stCondLst>
-                                  <p:childTnLst>
-                                    <p:set>
-                                      <p:cBhvr>
-                                        <p:cTn id="43" dur="1" fill="hold">
-                                          <p:stCondLst>
-                                            <p:cond delay="0"/>
-                                          </p:stCondLst>
-                                        </p:cTn>
-                                        <p:tgtEl>
-                                          <p:spTgt spid="419069902"/>
-                                        </p:tgtEl>
-                                        <p:attrNameLst>
-                                          <p:attrName>style.visibility</p:attrName>
-                                        </p:attrNameLst>
-                                      </p:cBhvr>
-                                      <p:to>
-                                        <p:strVal val="visible"/>
-                                      </p:to>
-                                    </p:set>
-                                    <p:animEffect transition="in" filter="fade">
-                                      <p:cBhvr>
-                                        <p:cTn id="42" dur="500"/>
-                                        <p:tgtEl>
-                                          <p:spTgt spid="419069902"/>
-                                        </p:tgtEl>
-                                      </p:cBhvr>
-                                    </p:animEffect>
-                                  </p:childTnLst>
-                                </p:cTn>
-                              </p:par>
-                            </p:childTnLst>
-                          </p:cTn>
-                        </p:par>
-                      </p:childTnLst>
-                    </p:cTn>
-                  </p:par>
-                </p:childTnLst>
-              </p:cTn>
-              <p:prevCondLst>
-                <p:cond evt="onPrev" delay="0">
-                  <p:tgtEl>
-                    <p:sldTgt/>
-                  </p:tgtEl>
-                </p:cond>
-              </p:prevCondLst>
-              <p:nextCondLst>
-                <p:cond evt="onNext" delay="0">
-                  <p:tgtEl>
-                    <p:sldTgt/>
-                  </p:tgtEl>
-                </p:cond>
-              </p:nextCondLst>
-            </p:seq>
-          </p:childTnLst>
-        </p:cTn>
-      </p:par>
-    </p:tnLst>
-  </p:timing>
+  <p:timing/>
 </p:sld>
 </file>
 

</xml_diff>

<commit_message>
Aggiornata presentazione DiarioDiBordo1_ZeroSixStudio aggiungendo logo e link GitHub
</commit_message>
<xml_diff>
--- a/src/diari_di_bordo/DiarioDiBordo1_ZeroSixStudio.pptx
+++ b/src/diari_di_bordo/DiarioDiBordo1_ZeroSixStudio.pptx
@@ -142,7 +142,7 @@
       </p:grpSpPr>
       <p:sp>
         <p:nvSpPr>
-          <p:cNvPr id="1680597095" name="Header Placeholder 1"/>
+          <p:cNvPr id="737300465" name="Header Placeholder 1"/>
           <p:cNvSpPr>
             <a:spLocks noGrp="1"/>
           </p:cNvSpPr>
@@ -176,7 +176,7 @@
       </p:sp>
       <p:sp>
         <p:nvSpPr>
-          <p:cNvPr id="546463927" name="Date Placeholder 2"/>
+          <p:cNvPr id="1755819050" name="Date Placeholder 2"/>
           <p:cNvSpPr>
             <a:spLocks noGrp="1"/>
           </p:cNvSpPr>
@@ -214,7 +214,7 @@
       </p:sp>
       <p:sp>
         <p:nvSpPr>
-          <p:cNvPr id="208254851" name="Footer Placeholder 3"/>
+          <p:cNvPr id="504409246" name="Footer Placeholder 3"/>
           <p:cNvSpPr>
             <a:spLocks noGrp="1"/>
           </p:cNvSpPr>
@@ -248,7 +248,7 @@
       </p:sp>
       <p:sp>
         <p:nvSpPr>
-          <p:cNvPr id="95132235" name="Slide Number Placeholder 4"/>
+          <p:cNvPr id="371101716" name="Slide Number Placeholder 4"/>
           <p:cNvSpPr>
             <a:spLocks noGrp="1"/>
           </p:cNvSpPr>
@@ -314,7 +314,7 @@
       </p:grpSpPr>
       <p:sp>
         <p:nvSpPr>
-          <p:cNvPr id="1917533724" name="Header Placeholder 1"/>
+          <p:cNvPr id="751103682" name="Header Placeholder 1"/>
           <p:cNvSpPr>
             <a:spLocks noGrp="1"/>
           </p:cNvSpPr>
@@ -348,7 +348,7 @@
       </p:sp>
       <p:sp>
         <p:nvSpPr>
-          <p:cNvPr id="1796978333" name="Date Placeholder 2"/>
+          <p:cNvPr id="939746869" name="Date Placeholder 2"/>
           <p:cNvSpPr>
             <a:spLocks noGrp="1"/>
           </p:cNvSpPr>
@@ -386,7 +386,7 @@
       </p:sp>
       <p:sp>
         <p:nvSpPr>
-          <p:cNvPr id="1029573240" name="Slide Image Placeholder 3"/>
+          <p:cNvPr id="405297778" name="Slide Image Placeholder 3"/>
           <p:cNvSpPr>
             <a:spLocks noChangeAspect="1" noGrp="1" noRot="1"/>
           </p:cNvSpPr>
@@ -422,7 +422,7 @@
       </p:sp>
       <p:sp>
         <p:nvSpPr>
-          <p:cNvPr id="1373723539" name="Notes Placeholder 4"/>
+          <p:cNvPr id="475533945" name="Notes Placeholder 4"/>
           <p:cNvSpPr>
             <a:spLocks noGrp="1"/>
           </p:cNvSpPr>
@@ -496,7 +496,7 @@
       </p:sp>
       <p:sp>
         <p:nvSpPr>
-          <p:cNvPr id="351681470" name="Footer Placeholder 5"/>
+          <p:cNvPr id="912813327" name="Footer Placeholder 5"/>
           <p:cNvSpPr>
             <a:spLocks noGrp="1"/>
           </p:cNvSpPr>
@@ -530,7 +530,7 @@
       </p:sp>
       <p:sp>
         <p:nvSpPr>
-          <p:cNvPr id="186920074" name="Slide Number Placeholder 6"/>
+          <p:cNvPr id="1634737928" name="Slide Number Placeholder 6"/>
           <p:cNvSpPr>
             <a:spLocks noGrp="1"/>
           </p:cNvSpPr>
@@ -683,7 +683,7 @@
       </p:grpSpPr>
       <p:sp>
         <p:nvSpPr>
-          <p:cNvPr id="1850604323" name="Slide Image Placeholder 1"/>
+          <p:cNvPr id="327228379" name="Slide Image Placeholder 1"/>
           <p:cNvSpPr>
             <a:spLocks noChangeAspect="1" noGrp="1" noRot="1"/>
           </p:cNvSpPr>
@@ -695,7 +695,7 @@
       </p:sp>
       <p:sp>
         <p:nvSpPr>
-          <p:cNvPr id="1229522136" name="Notes Placeholder 2"/>
+          <p:cNvPr id="1817098843" name="Notes Placeholder 2"/>
           <p:cNvSpPr>
             <a:spLocks noGrp="1"/>
           </p:cNvSpPr>
@@ -717,7 +717,7 @@
       </p:sp>
       <p:sp>
         <p:nvSpPr>
-          <p:cNvPr id="910380205" name="Slide Number Placeholder 3"/>
+          <p:cNvPr id="111928282" name="Slide Number Placeholder 3"/>
           <p:cNvSpPr>
             <a:spLocks noGrp="1"/>
           </p:cNvSpPr>
@@ -768,7 +768,7 @@
       </p:grpSpPr>
       <p:sp>
         <p:nvSpPr>
-          <p:cNvPr id="1827631290" name="Slide Image Placeholder 1"/>
+          <p:cNvPr id="547028696" name="Slide Image Placeholder 1"/>
           <p:cNvSpPr>
             <a:spLocks noChangeAspect="1" noGrp="1" noRot="1"/>
           </p:cNvSpPr>
@@ -780,7 +780,7 @@
       </p:sp>
       <p:sp>
         <p:nvSpPr>
-          <p:cNvPr id="1215464762" name="Notes Placeholder 2"/>
+          <p:cNvPr id="1041344746" name="Notes Placeholder 2"/>
           <p:cNvSpPr>
             <a:spLocks noGrp="1"/>
           </p:cNvSpPr>
@@ -802,7 +802,7 @@
       </p:sp>
       <p:sp>
         <p:nvSpPr>
-          <p:cNvPr id="1035754318" name="Slide Number Placeholder 3"/>
+          <p:cNvPr id="906890640" name="Slide Number Placeholder 3"/>
           <p:cNvSpPr>
             <a:spLocks noGrp="1"/>
           </p:cNvSpPr>
@@ -853,7 +853,7 @@
       </p:grpSpPr>
       <p:sp>
         <p:nvSpPr>
-          <p:cNvPr id="1348133705" name="Slide Image Placeholder 1"/>
+          <p:cNvPr id="1259405079" name="Slide Image Placeholder 1"/>
           <p:cNvSpPr>
             <a:spLocks noChangeAspect="1" noGrp="1" noRot="1"/>
           </p:cNvSpPr>
@@ -865,7 +865,7 @@
       </p:sp>
       <p:sp>
         <p:nvSpPr>
-          <p:cNvPr id="913278784" name="Notes Placeholder 2"/>
+          <p:cNvPr id="1932510600" name="Notes Placeholder 2"/>
           <p:cNvSpPr>
             <a:spLocks noGrp="1"/>
           </p:cNvSpPr>
@@ -887,7 +887,7 @@
       </p:sp>
       <p:sp>
         <p:nvSpPr>
-          <p:cNvPr id="807135932" name="Slide Number Placeholder 3"/>
+          <p:cNvPr id="366923592" name="Slide Number Placeholder 3"/>
           <p:cNvSpPr>
             <a:spLocks noGrp="1"/>
           </p:cNvSpPr>
@@ -938,7 +938,7 @@
       </p:grpSpPr>
       <p:sp>
         <p:nvSpPr>
-          <p:cNvPr id="206991420" name="Slide Image Placeholder 1"/>
+          <p:cNvPr id="52155422" name="Slide Image Placeholder 1"/>
           <p:cNvSpPr>
             <a:spLocks noChangeAspect="1" noGrp="1" noRot="1"/>
           </p:cNvSpPr>
@@ -950,7 +950,7 @@
       </p:sp>
       <p:sp>
         <p:nvSpPr>
-          <p:cNvPr id="610579485" name="Notes Placeholder 2"/>
+          <p:cNvPr id="630996013" name="Notes Placeholder 2"/>
           <p:cNvSpPr>
             <a:spLocks noGrp="1"/>
           </p:cNvSpPr>
@@ -972,7 +972,7 @@
       </p:sp>
       <p:sp>
         <p:nvSpPr>
-          <p:cNvPr id="136897780" name="Slide Number Placeholder 3"/>
+          <p:cNvPr id="927680464" name="Slide Number Placeholder 3"/>
           <p:cNvSpPr>
             <a:spLocks noGrp="1"/>
           </p:cNvSpPr>
@@ -1023,7 +1023,7 @@
       </p:grpSpPr>
       <p:sp>
         <p:nvSpPr>
-          <p:cNvPr id="1573253332" name="Slide Image Placeholder 1"/>
+          <p:cNvPr id="1784870133" name="Slide Image Placeholder 1"/>
           <p:cNvSpPr>
             <a:spLocks noChangeAspect="1" noGrp="1" noRot="1"/>
           </p:cNvSpPr>
@@ -1035,7 +1035,7 @@
       </p:sp>
       <p:sp>
         <p:nvSpPr>
-          <p:cNvPr id="1442387972" name="Notes Placeholder 2"/>
+          <p:cNvPr id="2100334614" name="Notes Placeholder 2"/>
           <p:cNvSpPr>
             <a:spLocks noGrp="1"/>
           </p:cNvSpPr>
@@ -1057,7 +1057,7 @@
       </p:sp>
       <p:sp>
         <p:nvSpPr>
-          <p:cNvPr id="1726120834" name="Slide Number Placeholder 3"/>
+          <p:cNvPr id="919248203" name="Slide Number Placeholder 3"/>
           <p:cNvSpPr>
             <a:spLocks noGrp="1"/>
           </p:cNvSpPr>
@@ -1108,7 +1108,7 @@
       </p:grpSpPr>
       <p:sp>
         <p:nvSpPr>
-          <p:cNvPr id="1644432128" name="Slide Image Placeholder 1"/>
+          <p:cNvPr id="462538289" name="Slide Image Placeholder 1"/>
           <p:cNvSpPr>
             <a:spLocks noChangeAspect="1" noGrp="1" noRot="1"/>
           </p:cNvSpPr>
@@ -1120,7 +1120,7 @@
       </p:sp>
       <p:sp>
         <p:nvSpPr>
-          <p:cNvPr id="1111735693" name="Notes Placeholder 2"/>
+          <p:cNvPr id="2102725244" name="Notes Placeholder 2"/>
           <p:cNvSpPr>
             <a:spLocks noGrp="1"/>
           </p:cNvSpPr>
@@ -1142,7 +1142,7 @@
       </p:sp>
       <p:sp>
         <p:nvSpPr>
-          <p:cNvPr id="162722957" name="Slide Number Placeholder 3"/>
+          <p:cNvPr id="74444681" name="Slide Number Placeholder 3"/>
           <p:cNvSpPr>
             <a:spLocks noGrp="1"/>
           </p:cNvSpPr>
@@ -1193,7 +1193,7 @@
       </p:grpSpPr>
       <p:sp>
         <p:nvSpPr>
-          <p:cNvPr id="1852281222" name="Title 1"/>
+          <p:cNvPr id="2038160131" name="Title 1"/>
           <p:cNvSpPr>
             <a:spLocks noGrp="1"/>
           </p:cNvSpPr>
@@ -1228,7 +1228,7 @@
       </p:sp>
       <p:sp>
         <p:nvSpPr>
-          <p:cNvPr id="389035758" name="Subtitle 2"/>
+          <p:cNvPr id="504546461" name="Subtitle 2"/>
           <p:cNvSpPr>
             <a:spLocks noGrp="1"/>
           </p:cNvSpPr>
@@ -1296,7 +1296,7 @@
       </p:sp>
       <p:sp>
         <p:nvSpPr>
-          <p:cNvPr id="562469946" name="Date Placeholder 3"/>
+          <p:cNvPr id="1602918738" name="Date Placeholder 3"/>
           <p:cNvSpPr>
             <a:spLocks noGrp="1"/>
           </p:cNvSpPr>
@@ -1322,7 +1322,7 @@
       </p:sp>
       <p:sp>
         <p:nvSpPr>
-          <p:cNvPr id="1690731596" name="Footer Placeholder 4"/>
+          <p:cNvPr id="737608942" name="Footer Placeholder 4"/>
           <p:cNvSpPr>
             <a:spLocks noGrp="1"/>
           </p:cNvSpPr>
@@ -1344,7 +1344,7 @@
       </p:sp>
       <p:sp>
         <p:nvSpPr>
-          <p:cNvPr id="1851683908" name="Slide Number Placeholder 5"/>
+          <p:cNvPr id="1951437743" name="Slide Number Placeholder 5"/>
           <p:cNvSpPr>
             <a:spLocks noGrp="1"/>
           </p:cNvSpPr>
@@ -1395,7 +1395,7 @@
       </p:grpSpPr>
       <p:sp>
         <p:nvSpPr>
-          <p:cNvPr id="536409838" name="Title 1"/>
+          <p:cNvPr id="2014578813" name="Title 1"/>
           <p:cNvSpPr>
             <a:spLocks noGrp="1"/>
           </p:cNvSpPr>
@@ -1421,7 +1421,7 @@
       </p:sp>
       <p:sp>
         <p:nvSpPr>
-          <p:cNvPr id="1685135925" name="Vertical Text Placeholder 2"/>
+          <p:cNvPr id="1429180218" name="Vertical Text Placeholder 2"/>
           <p:cNvSpPr>
             <a:spLocks noGrp="1"/>
           </p:cNvSpPr>
@@ -1487,7 +1487,7 @@
       </p:sp>
       <p:sp>
         <p:nvSpPr>
-          <p:cNvPr id="2001096622" name="Date Placeholder 3"/>
+          <p:cNvPr id="1438544312" name="Date Placeholder 3"/>
           <p:cNvSpPr>
             <a:spLocks noGrp="1"/>
           </p:cNvSpPr>
@@ -1513,7 +1513,7 @@
       </p:sp>
       <p:sp>
         <p:nvSpPr>
-          <p:cNvPr id="1064523820" name="Footer Placeholder 4"/>
+          <p:cNvPr id="1551188921" name="Footer Placeholder 4"/>
           <p:cNvSpPr>
             <a:spLocks noGrp="1"/>
           </p:cNvSpPr>
@@ -1535,7 +1535,7 @@
       </p:sp>
       <p:sp>
         <p:nvSpPr>
-          <p:cNvPr id="119684896" name="Slide Number Placeholder 5"/>
+          <p:cNvPr id="1692942508" name="Slide Number Placeholder 5"/>
           <p:cNvSpPr>
             <a:spLocks noGrp="1"/>
           </p:cNvSpPr>
@@ -1586,7 +1586,7 @@
       </p:grpSpPr>
       <p:sp>
         <p:nvSpPr>
-          <p:cNvPr id="1032036824" name="Vertical Title 1"/>
+          <p:cNvPr id="1599714224" name="Vertical Title 1"/>
           <p:cNvSpPr>
             <a:spLocks noGrp="1"/>
           </p:cNvSpPr>
@@ -1617,7 +1617,7 @@
       </p:sp>
       <p:sp>
         <p:nvSpPr>
-          <p:cNvPr id="103796755" name="Vertical Text Placeholder 2"/>
+          <p:cNvPr id="1237047696" name="Vertical Text Placeholder 2"/>
           <p:cNvSpPr>
             <a:spLocks noGrp="1"/>
           </p:cNvSpPr>
@@ -1688,7 +1688,7 @@
       </p:sp>
       <p:sp>
         <p:nvSpPr>
-          <p:cNvPr id="1354680609" name="Date Placeholder 3"/>
+          <p:cNvPr id="402777772" name="Date Placeholder 3"/>
           <p:cNvSpPr>
             <a:spLocks noGrp="1"/>
           </p:cNvSpPr>
@@ -1714,7 +1714,7 @@
       </p:sp>
       <p:sp>
         <p:nvSpPr>
-          <p:cNvPr id="1042115973" name="Footer Placeholder 4"/>
+          <p:cNvPr id="1227526793" name="Footer Placeholder 4"/>
           <p:cNvSpPr>
             <a:spLocks noGrp="1"/>
           </p:cNvSpPr>
@@ -1736,7 +1736,7 @@
       </p:sp>
       <p:sp>
         <p:nvSpPr>
-          <p:cNvPr id="1866058036" name="Slide Number Placeholder 5"/>
+          <p:cNvPr id="1194164751" name="Slide Number Placeholder 5"/>
           <p:cNvSpPr>
             <a:spLocks noGrp="1"/>
           </p:cNvSpPr>
@@ -1787,7 +1787,7 @@
       </p:grpSpPr>
       <p:sp>
         <p:nvSpPr>
-          <p:cNvPr id="1164913182" name="Title 1"/>
+          <p:cNvPr id="933115512" name="Title 1"/>
           <p:cNvSpPr>
             <a:spLocks noGrp="1"/>
           </p:cNvSpPr>
@@ -1813,7 +1813,7 @@
       </p:sp>
       <p:sp>
         <p:nvSpPr>
-          <p:cNvPr id="1974853652" name="Content Placeholder 2"/>
+          <p:cNvPr id="1871455371" name="Content Placeholder 2"/>
           <p:cNvSpPr>
             <a:spLocks noGrp="1"/>
           </p:cNvSpPr>
@@ -1879,7 +1879,7 @@
       </p:sp>
       <p:sp>
         <p:nvSpPr>
-          <p:cNvPr id="1633313569" name="Date Placeholder 3"/>
+          <p:cNvPr id="909717185" name="Date Placeholder 3"/>
           <p:cNvSpPr>
             <a:spLocks noGrp="1"/>
           </p:cNvSpPr>
@@ -1905,7 +1905,7 @@
       </p:sp>
       <p:sp>
         <p:nvSpPr>
-          <p:cNvPr id="1573770584" name="Footer Placeholder 4"/>
+          <p:cNvPr id="495389213" name="Footer Placeholder 4"/>
           <p:cNvSpPr>
             <a:spLocks noGrp="1"/>
           </p:cNvSpPr>
@@ -1927,7 +1927,7 @@
       </p:sp>
       <p:sp>
         <p:nvSpPr>
-          <p:cNvPr id="495524842" name="Slide Number Placeholder 5"/>
+          <p:cNvPr id="1059998946" name="Slide Number Placeholder 5"/>
           <p:cNvSpPr>
             <a:spLocks noGrp="1"/>
           </p:cNvSpPr>
@@ -1978,7 +1978,7 @@
       </p:grpSpPr>
       <p:sp>
         <p:nvSpPr>
-          <p:cNvPr id="1632236978" name="Title 1"/>
+          <p:cNvPr id="206846374" name="Title 1"/>
           <p:cNvSpPr>
             <a:spLocks noGrp="1"/>
           </p:cNvSpPr>
@@ -2013,7 +2013,7 @@
       </p:sp>
       <p:sp>
         <p:nvSpPr>
-          <p:cNvPr id="2124386698" name="Text Placeholder 2"/>
+          <p:cNvPr id="1137668182" name="Text Placeholder 2"/>
           <p:cNvSpPr>
             <a:spLocks noGrp="1"/>
           </p:cNvSpPr>
@@ -2135,7 +2135,7 @@
       </p:sp>
       <p:sp>
         <p:nvSpPr>
-          <p:cNvPr id="1539697585" name="Date Placeholder 3"/>
+          <p:cNvPr id="1955932077" name="Date Placeholder 3"/>
           <p:cNvSpPr>
             <a:spLocks noGrp="1"/>
           </p:cNvSpPr>
@@ -2161,7 +2161,7 @@
       </p:sp>
       <p:sp>
         <p:nvSpPr>
-          <p:cNvPr id="1250799297" name="Footer Placeholder 4"/>
+          <p:cNvPr id="731738306" name="Footer Placeholder 4"/>
           <p:cNvSpPr>
             <a:spLocks noGrp="1"/>
           </p:cNvSpPr>
@@ -2183,7 +2183,7 @@
       </p:sp>
       <p:sp>
         <p:nvSpPr>
-          <p:cNvPr id="1181404413" name="Slide Number Placeholder 5"/>
+          <p:cNvPr id="1577429622" name="Slide Number Placeholder 5"/>
           <p:cNvSpPr>
             <a:spLocks noGrp="1"/>
           </p:cNvSpPr>
@@ -2234,7 +2234,7 @@
       </p:grpSpPr>
       <p:sp>
         <p:nvSpPr>
-          <p:cNvPr id="1826864428" name="Title 1"/>
+          <p:cNvPr id="680069999" name="Title 1"/>
           <p:cNvSpPr>
             <a:spLocks noGrp="1"/>
           </p:cNvSpPr>
@@ -2260,7 +2260,7 @@
       </p:sp>
       <p:sp>
         <p:nvSpPr>
-          <p:cNvPr id="653142336" name="Content Placeholder 2"/>
+          <p:cNvPr id="2124740732" name="Content Placeholder 2"/>
           <p:cNvSpPr>
             <a:spLocks noGrp="1"/>
           </p:cNvSpPr>
@@ -2331,7 +2331,7 @@
       </p:sp>
       <p:sp>
         <p:nvSpPr>
-          <p:cNvPr id="610758163" name="Content Placeholder 3"/>
+          <p:cNvPr id="366473122" name="Content Placeholder 3"/>
           <p:cNvSpPr>
             <a:spLocks noGrp="1"/>
           </p:cNvSpPr>
@@ -2402,7 +2402,7 @@
       </p:sp>
       <p:sp>
         <p:nvSpPr>
-          <p:cNvPr id="896517419" name="Date Placeholder 4"/>
+          <p:cNvPr id="65238214" name="Date Placeholder 4"/>
           <p:cNvSpPr>
             <a:spLocks noGrp="1"/>
           </p:cNvSpPr>
@@ -2428,7 +2428,7 @@
       </p:sp>
       <p:sp>
         <p:nvSpPr>
-          <p:cNvPr id="2068598042" name="Footer Placeholder 5"/>
+          <p:cNvPr id="1153227936" name="Footer Placeholder 5"/>
           <p:cNvSpPr>
             <a:spLocks noGrp="1"/>
           </p:cNvSpPr>
@@ -2450,7 +2450,7 @@
       </p:sp>
       <p:sp>
         <p:nvSpPr>
-          <p:cNvPr id="1073319697" name="Slide Number Placeholder 6"/>
+          <p:cNvPr id="1868693952" name="Slide Number Placeholder 6"/>
           <p:cNvSpPr>
             <a:spLocks noGrp="1"/>
           </p:cNvSpPr>
@@ -2501,7 +2501,7 @@
       </p:grpSpPr>
       <p:sp>
         <p:nvSpPr>
-          <p:cNvPr id="1648602741" name="Title 1"/>
+          <p:cNvPr id="1547657831" name="Title 1"/>
           <p:cNvSpPr>
             <a:spLocks noGrp="1"/>
           </p:cNvSpPr>
@@ -2532,7 +2532,7 @@
       </p:sp>
       <p:sp>
         <p:nvSpPr>
-          <p:cNvPr id="264829113" name="Text Placeholder 2"/>
+          <p:cNvPr id="860795314" name="Text Placeholder 2"/>
           <p:cNvSpPr>
             <a:spLocks noGrp="1"/>
           </p:cNvSpPr>
@@ -2600,7 +2600,7 @@
       </p:sp>
       <p:sp>
         <p:nvSpPr>
-          <p:cNvPr id="1152967549" name="Content Placeholder 3"/>
+          <p:cNvPr id="1842731287" name="Content Placeholder 3"/>
           <p:cNvSpPr>
             <a:spLocks noGrp="1"/>
           </p:cNvSpPr>
@@ -2671,7 +2671,7 @@
       </p:sp>
       <p:sp>
         <p:nvSpPr>
-          <p:cNvPr id="1814411238" name="Text Placeholder 4"/>
+          <p:cNvPr id="1431362582" name="Text Placeholder 4"/>
           <p:cNvSpPr>
             <a:spLocks noGrp="1"/>
           </p:cNvSpPr>
@@ -2739,7 +2739,7 @@
       </p:sp>
       <p:sp>
         <p:nvSpPr>
-          <p:cNvPr id="264063707" name="Content Placeholder 5"/>
+          <p:cNvPr id="1339200891" name="Content Placeholder 5"/>
           <p:cNvSpPr>
             <a:spLocks noGrp="1"/>
           </p:cNvSpPr>
@@ -2810,7 +2810,7 @@
       </p:sp>
       <p:sp>
         <p:nvSpPr>
-          <p:cNvPr id="785049252" name="Date Placeholder 6"/>
+          <p:cNvPr id="1609483870" name="Date Placeholder 6"/>
           <p:cNvSpPr>
             <a:spLocks noGrp="1"/>
           </p:cNvSpPr>
@@ -2836,7 +2836,7 @@
       </p:sp>
       <p:sp>
         <p:nvSpPr>
-          <p:cNvPr id="2046835357" name="Footer Placeholder 7"/>
+          <p:cNvPr id="761653169" name="Footer Placeholder 7"/>
           <p:cNvSpPr>
             <a:spLocks noGrp="1"/>
           </p:cNvSpPr>
@@ -2858,7 +2858,7 @@
       </p:sp>
       <p:sp>
         <p:nvSpPr>
-          <p:cNvPr id="25193946" name="Slide Number Placeholder 8"/>
+          <p:cNvPr id="579208705" name="Slide Number Placeholder 8"/>
           <p:cNvSpPr>
             <a:spLocks noGrp="1"/>
           </p:cNvSpPr>
@@ -2909,7 +2909,7 @@
       </p:grpSpPr>
       <p:sp>
         <p:nvSpPr>
-          <p:cNvPr id="54493441" name="Title 1"/>
+          <p:cNvPr id="214480095" name="Title 1"/>
           <p:cNvSpPr>
             <a:spLocks noGrp="1"/>
           </p:cNvSpPr>
@@ -2935,7 +2935,7 @@
       </p:sp>
       <p:sp>
         <p:nvSpPr>
-          <p:cNvPr id="1019173843" name="Date Placeholder 2"/>
+          <p:cNvPr id="1567444935" name="Date Placeholder 2"/>
           <p:cNvSpPr>
             <a:spLocks noGrp="1"/>
           </p:cNvSpPr>
@@ -2961,7 +2961,7 @@
       </p:sp>
       <p:sp>
         <p:nvSpPr>
-          <p:cNvPr id="1403747123" name="Footer Placeholder 3"/>
+          <p:cNvPr id="533032302" name="Footer Placeholder 3"/>
           <p:cNvSpPr>
             <a:spLocks noGrp="1"/>
           </p:cNvSpPr>
@@ -2983,7 +2983,7 @@
       </p:sp>
       <p:sp>
         <p:nvSpPr>
-          <p:cNvPr id="2052843892" name="Slide Number Placeholder 4"/>
+          <p:cNvPr id="1702040959" name="Slide Number Placeholder 4"/>
           <p:cNvSpPr>
             <a:spLocks noGrp="1"/>
           </p:cNvSpPr>
@@ -3034,7 +3034,7 @@
       </p:grpSpPr>
       <p:sp>
         <p:nvSpPr>
-          <p:cNvPr id="1166136673" name="Date Placeholder 1"/>
+          <p:cNvPr id="1471129564" name="Date Placeholder 1"/>
           <p:cNvSpPr>
             <a:spLocks noGrp="1"/>
           </p:cNvSpPr>
@@ -3060,7 +3060,7 @@
       </p:sp>
       <p:sp>
         <p:nvSpPr>
-          <p:cNvPr id="939473372" name="Footer Placeholder 2"/>
+          <p:cNvPr id="627606833" name="Footer Placeholder 2"/>
           <p:cNvSpPr>
             <a:spLocks noGrp="1"/>
           </p:cNvSpPr>
@@ -3082,7 +3082,7 @@
       </p:sp>
       <p:sp>
         <p:nvSpPr>
-          <p:cNvPr id="1329175972" name="Slide Number Placeholder 3"/>
+          <p:cNvPr id="111488741" name="Slide Number Placeholder 3"/>
           <p:cNvSpPr>
             <a:spLocks noGrp="1"/>
           </p:cNvSpPr>
@@ -3133,7 +3133,7 @@
       </p:grpSpPr>
       <p:sp>
         <p:nvSpPr>
-          <p:cNvPr id="1619283044" name="Title 1"/>
+          <p:cNvPr id="772061835" name="Title 1"/>
           <p:cNvSpPr>
             <a:spLocks noGrp="1"/>
           </p:cNvSpPr>
@@ -3168,7 +3168,7 @@
       </p:sp>
       <p:sp>
         <p:nvSpPr>
-          <p:cNvPr id="1547816838" name="Content Placeholder 2"/>
+          <p:cNvPr id="1543069745" name="Content Placeholder 2"/>
           <p:cNvSpPr>
             <a:spLocks noGrp="1"/>
           </p:cNvSpPr>
@@ -3267,7 +3267,7 @@
       </p:sp>
       <p:sp>
         <p:nvSpPr>
-          <p:cNvPr id="550504456" name="Text Placeholder 3"/>
+          <p:cNvPr id="963773576" name="Text Placeholder 3"/>
           <p:cNvSpPr>
             <a:spLocks noGrp="1"/>
           </p:cNvSpPr>
@@ -3335,7 +3335,7 @@
       </p:sp>
       <p:sp>
         <p:nvSpPr>
-          <p:cNvPr id="522092128" name="Date Placeholder 4"/>
+          <p:cNvPr id="1078189215" name="Date Placeholder 4"/>
           <p:cNvSpPr>
             <a:spLocks noGrp="1"/>
           </p:cNvSpPr>
@@ -3361,7 +3361,7 @@
       </p:sp>
       <p:sp>
         <p:nvSpPr>
-          <p:cNvPr id="1788135484" name="Footer Placeholder 5"/>
+          <p:cNvPr id="2010806855" name="Footer Placeholder 5"/>
           <p:cNvSpPr>
             <a:spLocks noGrp="1"/>
           </p:cNvSpPr>
@@ -3383,7 +3383,7 @@
       </p:sp>
       <p:sp>
         <p:nvSpPr>
-          <p:cNvPr id="896494706" name="Slide Number Placeholder 6"/>
+          <p:cNvPr id="685977144" name="Slide Number Placeholder 6"/>
           <p:cNvSpPr>
             <a:spLocks noGrp="1"/>
           </p:cNvSpPr>
@@ -3434,7 +3434,7 @@
       </p:grpSpPr>
       <p:sp>
         <p:nvSpPr>
-          <p:cNvPr id="639037918" name="Title 1"/>
+          <p:cNvPr id="981644808" name="Title 1"/>
           <p:cNvSpPr>
             <a:spLocks noGrp="1"/>
           </p:cNvSpPr>
@@ -3469,7 +3469,7 @@
       </p:sp>
       <p:sp>
         <p:nvSpPr>
-          <p:cNvPr id="1168291949" name="Picture Placeholder 2"/>
+          <p:cNvPr id="1870610631" name="Picture Placeholder 2"/>
           <p:cNvSpPr>
             <a:spLocks noChangeAspect="1" noGrp="1"/>
           </p:cNvSpPr>
@@ -3537,7 +3537,7 @@
       </p:sp>
       <p:sp>
         <p:nvSpPr>
-          <p:cNvPr id="677715825" name="Text Placeholder 3"/>
+          <p:cNvPr id="1562816194" name="Text Placeholder 3"/>
           <p:cNvSpPr>
             <a:spLocks noGrp="1"/>
           </p:cNvSpPr>
@@ -3605,7 +3605,7 @@
       </p:sp>
       <p:sp>
         <p:nvSpPr>
-          <p:cNvPr id="129206096" name="Date Placeholder 4"/>
+          <p:cNvPr id="903867769" name="Date Placeholder 4"/>
           <p:cNvSpPr>
             <a:spLocks noGrp="1"/>
           </p:cNvSpPr>
@@ -3631,7 +3631,7 @@
       </p:sp>
       <p:sp>
         <p:nvSpPr>
-          <p:cNvPr id="11852518" name="Footer Placeholder 5"/>
+          <p:cNvPr id="1731985672" name="Footer Placeholder 5"/>
           <p:cNvSpPr>
             <a:spLocks noGrp="1"/>
           </p:cNvSpPr>
@@ -3653,7 +3653,7 @@
       </p:sp>
       <p:sp>
         <p:nvSpPr>
-          <p:cNvPr id="262707852" name="Slide Number Placeholder 6"/>
+          <p:cNvPr id="1701356582" name="Slide Number Placeholder 6"/>
           <p:cNvSpPr>
             <a:spLocks noGrp="1"/>
           </p:cNvSpPr>
@@ -3722,7 +3722,7 @@
       </p:grpSpPr>
       <p:sp>
         <p:nvSpPr>
-          <p:cNvPr id="1851724242" name="Title Placeholder 1"/>
+          <p:cNvPr id="272192316" name="Title Placeholder 1"/>
           <p:cNvSpPr>
             <a:spLocks noGrp="1"/>
           </p:cNvSpPr>
@@ -3758,7 +3758,7 @@
       </p:sp>
       <p:sp>
         <p:nvSpPr>
-          <p:cNvPr id="834841791" name="Text Placeholder 2"/>
+          <p:cNvPr id="1521658808" name="Text Placeholder 2"/>
           <p:cNvSpPr>
             <a:spLocks noGrp="1"/>
           </p:cNvSpPr>
@@ -3834,7 +3834,7 @@
       </p:sp>
       <p:sp>
         <p:nvSpPr>
-          <p:cNvPr id="478920496" name="Date Placeholder 3"/>
+          <p:cNvPr id="643699284" name="Date Placeholder 3"/>
           <p:cNvSpPr>
             <a:spLocks noGrp="1"/>
           </p:cNvSpPr>
@@ -3878,7 +3878,7 @@
       </p:sp>
       <p:sp>
         <p:nvSpPr>
-          <p:cNvPr id="1374045924" name="Footer Placeholder 4"/>
+          <p:cNvPr id="253169529" name="Footer Placeholder 4"/>
           <p:cNvSpPr>
             <a:spLocks noGrp="1"/>
           </p:cNvSpPr>
@@ -3918,7 +3918,7 @@
       </p:sp>
       <p:sp>
         <p:nvSpPr>
-          <p:cNvPr id="1687877474" name="Slide Number Placeholder 5"/>
+          <p:cNvPr id="1593000628" name="Slide Number Placeholder 5"/>
           <p:cNvSpPr>
             <a:spLocks noGrp="1"/>
           </p:cNvSpPr>
@@ -4278,7 +4278,7 @@
       </p:grpSpPr>
       <p:sp>
         <p:nvSpPr>
-          <p:cNvPr id="697860040" name="Title 1"/>
+          <p:cNvPr id="1350257453" name="Title 1"/>
           <p:cNvSpPr>
             <a:spLocks noGrp="1"/>
           </p:cNvSpPr>
@@ -4324,7 +4324,7 @@
       </p:sp>
       <p:sp>
         <p:nvSpPr>
-          <p:cNvPr id="2117596412" name="Subtitle 2"/>
+          <p:cNvPr id="230600976" name="Subtitle 2"/>
           <p:cNvSpPr>
             <a:spLocks noGrp="1"/>
           </p:cNvSpPr>
@@ -4390,7 +4390,7 @@
       </p:sp>
       <p:pic>
         <p:nvPicPr>
-          <p:cNvPr id="466567142" name=""/>
+          <p:cNvPr id="381501490" name=""/>
           <p:cNvPicPr>
             <a:picLocks noChangeAspect="1"/>
           </p:cNvPicPr>
@@ -4411,7 +4411,7 @@
       </p:pic>
       <p:sp>
         <p:nvSpPr>
-          <p:cNvPr id="1808587498" name="Slide Number Placeholder 5"/>
+          <p:cNvPr id="2052486827" name="Slide Number Placeholder 5"/>
           <p:cNvSpPr>
             <a:spLocks noGrp="1"/>
           </p:cNvSpPr>
@@ -4437,7 +4437,7 @@
       </p:sp>
       <p:sp>
         <p:nvSpPr>
-          <p:cNvPr id="1702767056" name=""/>
+          <p:cNvPr id="793044142" name=""/>
           <p:cNvSpPr/>
           <p:nvPr/>
         </p:nvSpPr>
@@ -4479,7 +4479,7 @@
       </p:sp>
       <p:sp>
         <p:nvSpPr>
-          <p:cNvPr id="268328484" name=""/>
+          <p:cNvPr id="175057464" name=""/>
           <p:cNvSpPr/>
           <p:nvPr/>
         </p:nvSpPr>
@@ -4521,7 +4521,7 @@
       </p:sp>
       <p:sp>
         <p:nvSpPr>
-          <p:cNvPr id="2057605249" name=""/>
+          <p:cNvPr id="110487083" name=""/>
           <p:cNvSpPr/>
           <p:nvPr/>
         </p:nvSpPr>
@@ -4563,7 +4563,7 @@
       </p:sp>
       <p:sp>
         <p:nvSpPr>
-          <p:cNvPr id="2003360418" name=""/>
+          <p:cNvPr id="1099273620" name=""/>
           <p:cNvSpPr/>
           <p:nvPr/>
         </p:nvSpPr>
@@ -4605,7 +4605,7 @@
       </p:sp>
       <p:sp>
         <p:nvSpPr>
-          <p:cNvPr id="1284932859" name="Rectangle 9"/>
+          <p:cNvPr id="2048009938" name="Rectangle 9"/>
           <p:cNvSpPr txBox="1"/>
           <p:nvPr/>
         </p:nvSpPr>
@@ -4633,7 +4633,7 @@
       </p:sp>
       <p:sp>
         <p:nvSpPr>
-          <p:cNvPr id="802154972" name="Rectangle 10"/>
+          <p:cNvPr id="1445288708" name="Rectangle 10"/>
           <p:cNvSpPr txBox="1"/>
           <p:nvPr/>
         </p:nvSpPr>
@@ -4679,7 +4679,7 @@
       </p:sp>
       <p:sp>
         <p:nvSpPr>
-          <p:cNvPr id="797661599" name="Rectangle 11"/>
+          <p:cNvPr id="267150870" name="Rectangle 11"/>
           <p:cNvSpPr txBox="1"/>
           <p:nvPr/>
         </p:nvSpPr>
@@ -4725,7 +4725,7 @@
       </p:sp>
       <p:sp>
         <p:nvSpPr>
-          <p:cNvPr id="401349314" name="Rectangle 12"/>
+          <p:cNvPr id="43044299" name="Rectangle 12"/>
           <p:cNvSpPr txBox="1"/>
           <p:nvPr/>
         </p:nvSpPr>
@@ -4774,7 +4774,7 @@
       </p:sp>
       <p:sp>
         <p:nvSpPr>
-          <p:cNvPr id="1939953279" name="Rectangle 13"/>
+          <p:cNvPr id="156969880" name="Rectangle 13"/>
           <p:cNvSpPr txBox="1"/>
           <p:nvPr/>
         </p:nvSpPr>
@@ -4823,7 +4823,7 @@
       </p:sp>
       <p:sp>
         <p:nvSpPr>
-          <p:cNvPr id="1568389149" name="Flowchart: Alternate process 14"/>
+          <p:cNvPr id="777839610" name="Flowchart: Alternate process 14"/>
           <p:cNvSpPr/>
           <p:nvPr/>
         </p:nvSpPr>
@@ -4932,7 +4932,7 @@
       </p:sp>
       <p:sp>
         <p:nvSpPr>
-          <p:cNvPr id="645227797" name="Flowchart: Alternate process 14"/>
+          <p:cNvPr id="1509471531" name="Flowchart: Alternate process 14"/>
           <p:cNvSpPr/>
           <p:nvPr/>
         </p:nvSpPr>
@@ -5036,7 +5036,7 @@
       </p:sp>
       <p:sp>
         <p:nvSpPr>
-          <p:cNvPr id="1364336091" name="Flowchart: Alternate process 14"/>
+          <p:cNvPr id="453948995" name="Flowchart: Alternate process 14"/>
           <p:cNvSpPr/>
           <p:nvPr/>
         </p:nvSpPr>
@@ -5140,7 +5140,7 @@
       </p:sp>
       <p:sp>
         <p:nvSpPr>
-          <p:cNvPr id="817063639" name="Flowchart: Alternate process 14"/>
+          <p:cNvPr id="247239005" name="Flowchart: Alternate process 14"/>
           <p:cNvSpPr/>
           <p:nvPr/>
         </p:nvSpPr>
@@ -5247,7 +5247,7 @@
       </p:sp>
       <p:sp>
         <p:nvSpPr>
-          <p:cNvPr id="1093468178" name="Rectangle 18"/>
+          <p:cNvPr id="1524493848" name="Rectangle 18"/>
           <p:cNvSpPr txBox="1"/>
           <p:nvPr/>
         </p:nvSpPr>
@@ -5292,7 +5292,7 @@
       </p:sp>
       <p:sp>
         <p:nvSpPr>
-          <p:cNvPr id="504553678" name="Rectangle 19"/>
+          <p:cNvPr id="712844017" name="Rectangle 19"/>
           <p:cNvSpPr txBox="1"/>
           <p:nvPr/>
         </p:nvSpPr>
@@ -5337,7 +5337,7 @@
       </p:sp>
       <p:sp>
         <p:nvSpPr>
-          <p:cNvPr id="680541558" name="Rectangle 20"/>
+          <p:cNvPr id="377040753" name="Rectangle 20"/>
           <p:cNvSpPr txBox="1"/>
           <p:nvPr/>
         </p:nvSpPr>
@@ -5385,7 +5385,7 @@
       </p:sp>
       <p:sp>
         <p:nvSpPr>
-          <p:cNvPr id="1763621809" name="Rectangle 21"/>
+          <p:cNvPr id="150966268" name="Rectangle 21"/>
           <p:cNvSpPr txBox="1"/>
           <p:nvPr/>
         </p:nvSpPr>
@@ -5480,7 +5480,7 @@
                                           </p:stCondLst>
                                         </p:cTn>
                                         <p:tgtEl>
-                                          <p:spTgt spid="1702767056"/>
+                                          <p:spTgt spid="793044142"/>
                                         </p:tgtEl>
                                         <p:attrNameLst>
                                           <p:attrName>style.visibility</p:attrName>
@@ -5494,7 +5494,7 @@
                                       <p:cBhvr>
                                         <p:cTn id="54" dur="500"/>
                                         <p:tgtEl>
-                                          <p:spTgt spid="1702767056"/>
+                                          <p:spTgt spid="793044142"/>
                                         </p:tgtEl>
                                       </p:cBhvr>
                                     </p:animEffect>
@@ -5515,7 +5515,7 @@
                                           </p:stCondLst>
                                         </p:cTn>
                                         <p:tgtEl>
-                                          <p:spTgt spid="268328484"/>
+                                          <p:spTgt spid="175057464"/>
                                         </p:tgtEl>
                                         <p:attrNameLst>
                                           <p:attrName>style.visibility</p:attrName>
@@ -5529,7 +5529,7 @@
                                       <p:cBhvr>
                                         <p:cTn id="51" dur="500"/>
                                         <p:tgtEl>
-                                          <p:spTgt spid="268328484"/>
+                                          <p:spTgt spid="175057464"/>
                                         </p:tgtEl>
                                       </p:cBhvr>
                                     </p:animEffect>
@@ -5550,7 +5550,7 @@
                                           </p:stCondLst>
                                         </p:cTn>
                                         <p:tgtEl>
-                                          <p:spTgt spid="2057605249"/>
+                                          <p:spTgt spid="110487083"/>
                                         </p:tgtEl>
                                         <p:attrNameLst>
                                           <p:attrName>style.visibility</p:attrName>
@@ -5564,7 +5564,7 @@
                                       <p:cBhvr>
                                         <p:cTn id="48" dur="500"/>
                                         <p:tgtEl>
-                                          <p:spTgt spid="2057605249"/>
+                                          <p:spTgt spid="110487083"/>
                                         </p:tgtEl>
                                       </p:cBhvr>
                                     </p:animEffect>
@@ -5585,7 +5585,7 @@
                                           </p:stCondLst>
                                         </p:cTn>
                                         <p:tgtEl>
-                                          <p:spTgt spid="2003360418"/>
+                                          <p:spTgt spid="1099273620"/>
                                         </p:tgtEl>
                                         <p:attrNameLst>
                                           <p:attrName>style.visibility</p:attrName>
@@ -5599,7 +5599,7 @@
                                       <p:cBhvr>
                                         <p:cTn id="45" dur="500"/>
                                         <p:tgtEl>
-                                          <p:spTgt spid="2003360418"/>
+                                          <p:spTgt spid="1099273620"/>
                                         </p:tgtEl>
                                       </p:cBhvr>
                                     </p:animEffect>
@@ -5620,7 +5620,7 @@
                                           </p:stCondLst>
                                         </p:cTn>
                                         <p:tgtEl>
-                                          <p:spTgt spid="1284932859"/>
+                                          <p:spTgt spid="2048009938"/>
                                         </p:tgtEl>
                                         <p:attrNameLst>
                                           <p:attrName>style.visibility</p:attrName>
@@ -5634,7 +5634,7 @@
                                       <p:cBhvr>
                                         <p:cTn id="42" dur="500"/>
                                         <p:tgtEl>
-                                          <p:spTgt spid="1284932859"/>
+                                          <p:spTgt spid="2048009938"/>
                                         </p:tgtEl>
                                       </p:cBhvr>
                                     </p:animEffect>
@@ -5655,7 +5655,7 @@
                                           </p:stCondLst>
                                         </p:cTn>
                                         <p:tgtEl>
-                                          <p:spTgt spid="802154972"/>
+                                          <p:spTgt spid="1445288708"/>
                                         </p:tgtEl>
                                         <p:attrNameLst>
                                           <p:attrName>style.visibility</p:attrName>
@@ -5669,7 +5669,7 @@
                                       <p:cBhvr>
                                         <p:cTn id="39" dur="500"/>
                                         <p:tgtEl>
-                                          <p:spTgt spid="802154972"/>
+                                          <p:spTgt spid="1445288708"/>
                                         </p:tgtEl>
                                       </p:cBhvr>
                                     </p:animEffect>
@@ -5690,7 +5690,7 @@
                                           </p:stCondLst>
                                         </p:cTn>
                                         <p:tgtEl>
-                                          <p:spTgt spid="797661599"/>
+                                          <p:spTgt spid="267150870"/>
                                         </p:tgtEl>
                                         <p:attrNameLst>
                                           <p:attrName>style.visibility</p:attrName>
@@ -5704,7 +5704,7 @@
                                       <p:cBhvr>
                                         <p:cTn id="36" dur="500"/>
                                         <p:tgtEl>
-                                          <p:spTgt spid="797661599"/>
+                                          <p:spTgt spid="267150870"/>
                                         </p:tgtEl>
                                       </p:cBhvr>
                                     </p:animEffect>
@@ -5725,7 +5725,7 @@
                                           </p:stCondLst>
                                         </p:cTn>
                                         <p:tgtEl>
-                                          <p:spTgt spid="401349314"/>
+                                          <p:spTgt spid="43044299"/>
                                         </p:tgtEl>
                                         <p:attrNameLst>
                                           <p:attrName>style.visibility</p:attrName>
@@ -5739,7 +5739,7 @@
                                       <p:cBhvr>
                                         <p:cTn id="33" dur="500"/>
                                         <p:tgtEl>
-                                          <p:spTgt spid="401349314"/>
+                                          <p:spTgt spid="43044299"/>
                                         </p:tgtEl>
                                       </p:cBhvr>
                                     </p:animEffect>
@@ -5760,7 +5760,7 @@
                                           </p:stCondLst>
                                         </p:cTn>
                                         <p:tgtEl>
-                                          <p:spTgt spid="1939953279"/>
+                                          <p:spTgt spid="156969880"/>
                                         </p:tgtEl>
                                         <p:attrNameLst>
                                           <p:attrName>style.visibility</p:attrName>
@@ -5774,7 +5774,7 @@
                                       <p:cBhvr>
                                         <p:cTn id="30" dur="500"/>
                                         <p:tgtEl>
-                                          <p:spTgt spid="1939953279"/>
+                                          <p:spTgt spid="156969880"/>
                                         </p:tgtEl>
                                       </p:cBhvr>
                                     </p:animEffect>
@@ -5795,7 +5795,7 @@
                                           </p:stCondLst>
                                         </p:cTn>
                                         <p:tgtEl>
-                                          <p:spTgt spid="1568389149"/>
+                                          <p:spTgt spid="777839610"/>
                                         </p:tgtEl>
                                         <p:attrNameLst>
                                           <p:attrName>style.visibility</p:attrName>
@@ -5809,7 +5809,7 @@
                                       <p:cBhvr>
                                         <p:cTn id="27" dur="500"/>
                                         <p:tgtEl>
-                                          <p:spTgt spid="1568389149"/>
+                                          <p:spTgt spid="777839610"/>
                                         </p:tgtEl>
                                       </p:cBhvr>
                                     </p:animEffect>
@@ -5830,7 +5830,7 @@
                                           </p:stCondLst>
                                         </p:cTn>
                                         <p:tgtEl>
-                                          <p:spTgt spid="645227797"/>
+                                          <p:spTgt spid="1509471531"/>
                                         </p:tgtEl>
                                         <p:attrNameLst>
                                           <p:attrName>style.visibility</p:attrName>
@@ -5844,7 +5844,7 @@
                                       <p:cBhvr>
                                         <p:cTn id="24" dur="500"/>
                                         <p:tgtEl>
-                                          <p:spTgt spid="645227797"/>
+                                          <p:spTgt spid="1509471531"/>
                                         </p:tgtEl>
                                       </p:cBhvr>
                                     </p:animEffect>
@@ -5865,7 +5865,7 @@
                                           </p:stCondLst>
                                         </p:cTn>
                                         <p:tgtEl>
-                                          <p:spTgt spid="1364336091"/>
+                                          <p:spTgt spid="453948995"/>
                                         </p:tgtEl>
                                         <p:attrNameLst>
                                           <p:attrName>style.visibility</p:attrName>
@@ -5879,7 +5879,7 @@
                                       <p:cBhvr>
                                         <p:cTn id="21" dur="500"/>
                                         <p:tgtEl>
-                                          <p:spTgt spid="1364336091"/>
+                                          <p:spTgt spid="453948995"/>
                                         </p:tgtEl>
                                       </p:cBhvr>
                                     </p:animEffect>
@@ -5900,7 +5900,7 @@
                                           </p:stCondLst>
                                         </p:cTn>
                                         <p:tgtEl>
-                                          <p:spTgt spid="817063639"/>
+                                          <p:spTgt spid="247239005"/>
                                         </p:tgtEl>
                                         <p:attrNameLst>
                                           <p:attrName>style.visibility</p:attrName>
@@ -5914,7 +5914,7 @@
                                       <p:cBhvr>
                                         <p:cTn id="18" dur="500"/>
                                         <p:tgtEl>
-                                          <p:spTgt spid="817063639"/>
+                                          <p:spTgt spid="247239005"/>
                                         </p:tgtEl>
                                       </p:cBhvr>
                                     </p:animEffect>
@@ -5935,7 +5935,7 @@
                                           </p:stCondLst>
                                         </p:cTn>
                                         <p:tgtEl>
-                                          <p:spTgt spid="1093468178"/>
+                                          <p:spTgt spid="1524493848"/>
                                         </p:tgtEl>
                                         <p:attrNameLst>
                                           <p:attrName>style.visibility</p:attrName>
@@ -5949,7 +5949,7 @@
                                       <p:cBhvr>
                                         <p:cTn id="15" dur="500"/>
                                         <p:tgtEl>
-                                          <p:spTgt spid="1093468178"/>
+                                          <p:spTgt spid="1524493848"/>
                                         </p:tgtEl>
                                       </p:cBhvr>
                                     </p:animEffect>
@@ -5970,7 +5970,7 @@
                                           </p:stCondLst>
                                         </p:cTn>
                                         <p:tgtEl>
-                                          <p:spTgt spid="504553678"/>
+                                          <p:spTgt spid="712844017"/>
                                         </p:tgtEl>
                                         <p:attrNameLst>
                                           <p:attrName>style.visibility</p:attrName>
@@ -5984,7 +5984,7 @@
                                       <p:cBhvr>
                                         <p:cTn id="12" dur="500"/>
                                         <p:tgtEl>
-                                          <p:spTgt spid="504553678"/>
+                                          <p:spTgt spid="712844017"/>
                                         </p:tgtEl>
                                       </p:cBhvr>
                                     </p:animEffect>
@@ -6005,7 +6005,7 @@
                                           </p:stCondLst>
                                         </p:cTn>
                                         <p:tgtEl>
-                                          <p:spTgt spid="680541558"/>
+                                          <p:spTgt spid="377040753"/>
                                         </p:tgtEl>
                                         <p:attrNameLst>
                                           <p:attrName>style.visibility</p:attrName>
@@ -6019,7 +6019,7 @@
                                       <p:cBhvr>
                                         <p:cTn id="9" dur="500"/>
                                         <p:tgtEl>
-                                          <p:spTgt spid="680541558"/>
+                                          <p:spTgt spid="377040753"/>
                                         </p:tgtEl>
                                       </p:cBhvr>
                                     </p:animEffect>
@@ -6040,7 +6040,7 @@
                                           </p:stCondLst>
                                         </p:cTn>
                                         <p:tgtEl>
-                                          <p:spTgt spid="1763621809"/>
+                                          <p:spTgt spid="150966268"/>
                                         </p:tgtEl>
                                         <p:attrNameLst>
                                           <p:attrName>style.visibility</p:attrName>
@@ -6054,7 +6054,7 @@
                                       <p:cBhvr>
                                         <p:cTn id="6" dur="500"/>
                                         <p:tgtEl>
-                                          <p:spTgt spid="1763621809"/>
+                                          <p:spTgt spid="150966268"/>
                                         </p:tgtEl>
                                       </p:cBhvr>
                                     </p:animEffect>
@@ -6111,7 +6111,7 @@
       </p:grpSpPr>
       <p:sp>
         <p:nvSpPr>
-          <p:cNvPr id="1922137123" name="Title 1"/>
+          <p:cNvPr id="974065918" name="Title 1"/>
           <p:cNvSpPr>
             <a:spLocks noGrp="1"/>
           </p:cNvSpPr>
@@ -6163,7 +6163,7 @@
       </p:sp>
       <p:grpSp>
         <p:nvGrpSpPr>
-          <p:cNvPr id="464793542" name="Group 62"/>
+          <p:cNvPr id="1488159787" name="Group 62"/>
           <p:cNvGrpSpPr/>
           <p:nvPr/>
         </p:nvGrpSpPr>
@@ -6329,7 +6329,7 @@
       </p:grpSp>
       <p:grpSp>
         <p:nvGrpSpPr>
-          <p:cNvPr id="149029921" name="Group 64"/>
+          <p:cNvPr id="472208932" name="Group 64"/>
           <p:cNvGrpSpPr/>
           <p:nvPr/>
         </p:nvGrpSpPr>
@@ -6495,7 +6495,7 @@
       </p:grpSp>
       <p:grpSp>
         <p:nvGrpSpPr>
-          <p:cNvPr id="1728294586" name="Group 66"/>
+          <p:cNvPr id="1927465817" name="Group 66"/>
           <p:cNvGrpSpPr/>
           <p:nvPr/>
         </p:nvGrpSpPr>
@@ -6661,7 +6661,7 @@
       </p:grpSp>
       <p:grpSp>
         <p:nvGrpSpPr>
-          <p:cNvPr id="372098076" name="Group 68"/>
+          <p:cNvPr id="1295062725" name="Group 68"/>
           <p:cNvGrpSpPr/>
           <p:nvPr/>
         </p:nvGrpSpPr>
@@ -6827,7 +6827,7 @@
       </p:grpSp>
       <p:sp>
         <p:nvSpPr>
-          <p:cNvPr id="1866511623" name="Rectangle 70"/>
+          <p:cNvPr id="1818939144" name="Rectangle 70"/>
           <p:cNvSpPr txBox="1"/>
           <p:nvPr/>
         </p:nvSpPr>
@@ -6872,7 +6872,7 @@
       </p:sp>
       <p:sp>
         <p:nvSpPr>
-          <p:cNvPr id="1682666309" name="Rectangle 71"/>
+          <p:cNvPr id="1671015826" name="Rectangle 71"/>
           <p:cNvSpPr txBox="1"/>
           <p:nvPr/>
         </p:nvSpPr>
@@ -6917,7 +6917,7 @@
       </p:sp>
       <p:sp>
         <p:nvSpPr>
-          <p:cNvPr id="734979463" name="Rectangle 72"/>
+          <p:cNvPr id="1400076005" name="Rectangle 72"/>
           <p:cNvSpPr txBox="1"/>
           <p:nvPr/>
         </p:nvSpPr>
@@ -6962,7 +6962,7 @@
       </p:sp>
       <p:sp>
         <p:nvSpPr>
-          <p:cNvPr id="976672064" name="Rectangle 73"/>
+          <p:cNvPr id="1596806646" name="Rectangle 73"/>
           <p:cNvSpPr txBox="1"/>
           <p:nvPr/>
         </p:nvSpPr>
@@ -7007,7 +7007,7 @@
       </p:sp>
       <p:grpSp>
         <p:nvGrpSpPr>
-          <p:cNvPr id="1914970234" name="Group 74"/>
+          <p:cNvPr id="944544788" name="Group 74"/>
           <p:cNvGrpSpPr/>
           <p:nvPr/>
         </p:nvGrpSpPr>
@@ -7173,7 +7173,7 @@
       </p:grpSp>
       <p:sp>
         <p:nvSpPr>
-          <p:cNvPr id="588813444" name="Rectangle 76"/>
+          <p:cNvPr id="1685059566" name="Rectangle 76"/>
           <p:cNvSpPr txBox="1"/>
           <p:nvPr/>
         </p:nvSpPr>
@@ -7217,7 +7217,7 @@
       </p:sp>
       <p:grpSp>
         <p:nvGrpSpPr>
-          <p:cNvPr id="277008413" name="Group 77"/>
+          <p:cNvPr id="998526541" name="Group 77"/>
           <p:cNvGrpSpPr/>
           <p:nvPr/>
         </p:nvGrpSpPr>
@@ -7383,7 +7383,7 @@
       </p:grpSp>
       <p:sp>
         <p:nvSpPr>
-          <p:cNvPr id="1926041079" name="Rectangle 79"/>
+          <p:cNvPr id="6488683" name="Rectangle 79"/>
           <p:cNvSpPr txBox="1"/>
           <p:nvPr/>
         </p:nvSpPr>
@@ -7427,7 +7427,7 @@
       </p:sp>
       <p:grpSp>
         <p:nvGrpSpPr>
-          <p:cNvPr id="958821218" name="Group 80"/>
+          <p:cNvPr id="1430283589" name="Group 80"/>
           <p:cNvGrpSpPr/>
           <p:nvPr/>
         </p:nvGrpSpPr>
@@ -7593,7 +7593,7 @@
       </p:grpSp>
       <p:sp>
         <p:nvSpPr>
-          <p:cNvPr id="779891917" name="Rectangle 82"/>
+          <p:cNvPr id="178598820" name="Rectangle 82"/>
           <p:cNvSpPr txBox="1"/>
           <p:nvPr/>
         </p:nvSpPr>
@@ -7670,7 +7670,7 @@
       </p:sp>
       <p:grpSp>
         <p:nvGrpSpPr>
-          <p:cNvPr id="711436570" name="Group 83"/>
+          <p:cNvPr id="1191916724" name="Group 83"/>
           <p:cNvGrpSpPr/>
           <p:nvPr/>
         </p:nvGrpSpPr>
@@ -7836,7 +7836,7 @@
       </p:grpSp>
       <p:sp>
         <p:nvSpPr>
-          <p:cNvPr id="892797708" name="Rectangle 85"/>
+          <p:cNvPr id="1469533486" name="Rectangle 85"/>
           <p:cNvSpPr txBox="1"/>
           <p:nvPr/>
         </p:nvSpPr>
@@ -7880,7 +7880,7 @@
       </p:sp>
       <p:grpSp>
         <p:nvGrpSpPr>
-          <p:cNvPr id="1915745889" name="Group 86"/>
+          <p:cNvPr id="739879962" name="Group 86"/>
           <p:cNvGrpSpPr/>
           <p:nvPr/>
         </p:nvGrpSpPr>
@@ -8046,7 +8046,7 @@
       </p:grpSp>
       <p:sp>
         <p:nvSpPr>
-          <p:cNvPr id="1913525597" name="Rectangle 88"/>
+          <p:cNvPr id="51449504" name="Rectangle 88"/>
           <p:cNvSpPr txBox="1"/>
           <p:nvPr/>
         </p:nvSpPr>
@@ -8091,7 +8091,7 @@
       </p:sp>
       <p:grpSp>
         <p:nvGrpSpPr>
-          <p:cNvPr id="2088253295" name="Group 89"/>
+          <p:cNvPr id="1481358855" name="Group 89"/>
           <p:cNvGrpSpPr/>
           <p:nvPr/>
         </p:nvGrpSpPr>
@@ -8257,7 +8257,7 @@
       </p:grpSp>
       <p:sp>
         <p:nvSpPr>
-          <p:cNvPr id="1988027534" name="Rectangle 91"/>
+          <p:cNvPr id="789454152" name="Rectangle 91"/>
           <p:cNvSpPr txBox="1"/>
           <p:nvPr/>
         </p:nvSpPr>
@@ -8301,7 +8301,7 @@
       </p:sp>
       <p:grpSp>
         <p:nvGrpSpPr>
-          <p:cNvPr id="1315269387" name="Group 92"/>
+          <p:cNvPr id="1840932472" name="Group 92"/>
           <p:cNvGrpSpPr/>
           <p:nvPr/>
         </p:nvGrpSpPr>
@@ -8467,7 +8467,7 @@
       </p:grpSp>
       <p:sp>
         <p:nvSpPr>
-          <p:cNvPr id="1761750" name="Rectangle 94"/>
+          <p:cNvPr id="2012946033" name="Rectangle 94"/>
           <p:cNvSpPr txBox="1"/>
           <p:nvPr/>
         </p:nvSpPr>
@@ -8511,7 +8511,7 @@
       </p:sp>
       <p:grpSp>
         <p:nvGrpSpPr>
-          <p:cNvPr id="1109971024" name="Group 106"/>
+          <p:cNvPr id="1364174869" name="Group 106"/>
           <p:cNvGrpSpPr/>
           <p:nvPr/>
         </p:nvGrpSpPr>
@@ -8677,7 +8677,7 @@
       </p:grpSp>
       <p:sp>
         <p:nvSpPr>
-          <p:cNvPr id="1231005969" name="Rectangle 108"/>
+          <p:cNvPr id="1752213649" name="Rectangle 108"/>
           <p:cNvSpPr txBox="1"/>
           <p:nvPr/>
         </p:nvSpPr>
@@ -8722,7 +8722,7 @@
       </p:sp>
       <p:pic>
         <p:nvPicPr>
-          <p:cNvPr id="657619679" name="Picture 52"/>
+          <p:cNvPr id="459355405" name="Picture 52"/>
           <p:cNvPicPr>
             <a:picLocks noChangeAspect="1"/>
           </p:cNvPicPr>
@@ -8750,7 +8750,7 @@
       </p:pic>
       <p:pic>
         <p:nvPicPr>
-          <p:cNvPr id="1444375481" name="Picture 53"/>
+          <p:cNvPr id="427500807" name="Picture 53"/>
           <p:cNvPicPr>
             <a:picLocks noChangeAspect="1"/>
           </p:cNvPicPr>
@@ -8774,11 +8774,12 @@
           <a:prstGeom prst="rect">
             <a:avLst/>
           </a:prstGeom>
+          <a:noFill/>
         </p:spPr>
       </p:pic>
       <p:pic>
         <p:nvPicPr>
-          <p:cNvPr id="217444960" name="Picture 54"/>
+          <p:cNvPr id="745128772" name="Picture 54"/>
           <p:cNvPicPr>
             <a:picLocks noChangeAspect="1"/>
           </p:cNvPicPr>
@@ -8806,7 +8807,7 @@
       </p:pic>
       <p:pic>
         <p:nvPicPr>
-          <p:cNvPr id="321598638" name="Picture 55"/>
+          <p:cNvPr id="180991575" name="Picture 55"/>
           <p:cNvPicPr>
             <a:picLocks noChangeAspect="1"/>
           </p:cNvPicPr>
@@ -8834,7 +8835,7 @@
       </p:pic>
       <p:pic>
         <p:nvPicPr>
-          <p:cNvPr id="1186971665" name="Picture 56"/>
+          <p:cNvPr id="293418017" name="Picture 56"/>
           <p:cNvPicPr>
             <a:picLocks noChangeAspect="1"/>
           </p:cNvPicPr>
@@ -8862,7 +8863,7 @@
       </p:pic>
       <p:pic>
         <p:nvPicPr>
-          <p:cNvPr id="914360017" name="Picture 57"/>
+          <p:cNvPr id="682106234" name="Picture 57"/>
           <p:cNvPicPr>
             <a:picLocks noChangeAspect="1"/>
           </p:cNvPicPr>
@@ -8880,7 +8881,7 @@
         </p:blipFill>
         <p:spPr bwMode="auto">
           <a:xfrm flipH="0" flipV="0">
-            <a:off x="446750" y="5966199"/>
+            <a:off x="446750" y="5966198"/>
             <a:ext cx="467430" cy="467430"/>
           </a:xfrm>
           <a:prstGeom prst="rect">
@@ -8890,7 +8891,7 @@
       </p:pic>
       <p:pic>
         <p:nvPicPr>
-          <p:cNvPr id="1072965399" name="Picture 58"/>
+          <p:cNvPr id="751797394" name="Picture 58"/>
           <p:cNvPicPr>
             <a:picLocks noChangeAspect="1"/>
           </p:cNvPicPr>
@@ -8918,7 +8919,7 @@
       </p:pic>
       <p:pic>
         <p:nvPicPr>
-          <p:cNvPr id="360206553" name="Picture 59"/>
+          <p:cNvPr id="1923797684" name="Picture 59"/>
           <p:cNvPicPr>
             <a:picLocks noChangeAspect="1"/>
           </p:cNvPicPr>
@@ -8946,7 +8947,7 @@
       </p:pic>
       <p:pic>
         <p:nvPicPr>
-          <p:cNvPr id="1588396186" name="Picture 60"/>
+          <p:cNvPr id="1314901434" name="Picture 60"/>
           <p:cNvPicPr>
             <a:picLocks noChangeAspect="1"/>
           </p:cNvPicPr>
@@ -8974,7 +8975,7 @@
       </p:pic>
       <p:pic>
         <p:nvPicPr>
-          <p:cNvPr id="201742190" name="Picture 61"/>
+          <p:cNvPr id="1560285736" name="Picture 61"/>
           <p:cNvPicPr>
             <a:picLocks noChangeAspect="1"/>
           </p:cNvPicPr>
@@ -9002,7 +9003,7 @@
       </p:pic>
       <p:pic>
         <p:nvPicPr>
-          <p:cNvPr id="15922105" name="Picture 62"/>
+          <p:cNvPr id="149730836" name="Picture 62"/>
           <p:cNvPicPr>
             <a:picLocks noChangeAspect="1"/>
           </p:cNvPicPr>
@@ -9030,7 +9031,7 @@
       </p:pic>
       <p:pic>
         <p:nvPicPr>
-          <p:cNvPr id="990716342" name="Picture 65"/>
+          <p:cNvPr id="1716461639" name="Picture 65"/>
           <p:cNvPicPr>
             <a:picLocks noChangeAspect="1"/>
           </p:cNvPicPr>
@@ -9095,7 +9096,7 @@
       </p:grpSpPr>
       <p:sp>
         <p:nvSpPr>
-          <p:cNvPr id="712414078" name="Title 1"/>
+          <p:cNvPr id="1806529226" name="Title 1"/>
           <p:cNvSpPr>
             <a:spLocks noGrp="1"/>
           </p:cNvSpPr>
@@ -9147,7 +9148,7 @@
       </p:sp>
       <p:grpSp>
         <p:nvGrpSpPr>
-          <p:cNvPr id="829425874" name="Group 2"/>
+          <p:cNvPr id="2092392161" name="Group 2"/>
           <p:cNvGrpSpPr/>
           <p:nvPr/>
         </p:nvGrpSpPr>
@@ -9313,7 +9314,7 @@
       </p:grpSp>
       <p:grpSp>
         <p:nvGrpSpPr>
-          <p:cNvPr id="2124462235" name="Group 5"/>
+          <p:cNvPr id="1389490761" name="Group 5"/>
           <p:cNvGrpSpPr/>
           <p:nvPr/>
         </p:nvGrpSpPr>
@@ -9479,7 +9480,7 @@
       </p:grpSp>
       <p:grpSp>
         <p:nvGrpSpPr>
-          <p:cNvPr id="290627112" name="Group 8"/>
+          <p:cNvPr id="207948949" name="Group 8"/>
           <p:cNvGrpSpPr/>
           <p:nvPr/>
         </p:nvGrpSpPr>
@@ -9645,7 +9646,7 @@
       </p:grpSp>
       <p:sp>
         <p:nvSpPr>
-          <p:cNvPr id="714007354" name="Rectangle 14"/>
+          <p:cNvPr id="955177371" name="Rectangle 14"/>
           <p:cNvSpPr txBox="1"/>
           <p:nvPr/>
         </p:nvSpPr>
@@ -9689,7 +9690,7 @@
       </p:sp>
       <p:sp>
         <p:nvSpPr>
-          <p:cNvPr id="846293226" name="Rectangle 15"/>
+          <p:cNvPr id="1867144911" name="Rectangle 15"/>
           <p:cNvSpPr txBox="1"/>
           <p:nvPr/>
         </p:nvSpPr>
@@ -9733,7 +9734,7 @@
       </p:sp>
       <p:sp>
         <p:nvSpPr>
-          <p:cNvPr id="1313664251" name="Rectangle 16"/>
+          <p:cNvPr id="66288052" name="Rectangle 16"/>
           <p:cNvSpPr txBox="1"/>
           <p:nvPr/>
         </p:nvSpPr>
@@ -9783,7 +9784,7 @@
       </p:sp>
       <p:grpSp>
         <p:nvGrpSpPr>
-          <p:cNvPr id="771430268" name="Group 56"/>
+          <p:cNvPr id="117134496" name="Group 56"/>
           <p:cNvGrpSpPr/>
           <p:nvPr/>
         </p:nvGrpSpPr>
@@ -9949,7 +9950,7 @@
       </p:grpSp>
       <p:sp>
         <p:nvSpPr>
-          <p:cNvPr id="1418999668" name="Rectangle 58"/>
+          <p:cNvPr id="2088708978" name="Rectangle 58"/>
           <p:cNvSpPr txBox="1"/>
           <p:nvPr/>
         </p:nvSpPr>
@@ -9994,7 +9995,7 @@
       </p:sp>
       <p:sp>
         <p:nvSpPr>
-          <p:cNvPr id="760168387" name="Flowchart: Alternate process 64"/>
+          <p:cNvPr id="570454122" name="Flowchart: Alternate process 64"/>
           <p:cNvSpPr/>
           <p:nvPr/>
         </p:nvSpPr>
@@ -10088,13 +10089,13 @@
       </p:sp>
       <p:sp>
         <p:nvSpPr>
-          <p:cNvPr id="1121993144" name="Rectangle 65"/>
+          <p:cNvPr id="836314845" name="Rectangle 65"/>
           <p:cNvSpPr txBox="1"/>
           <p:nvPr/>
         </p:nvSpPr>
         <p:spPr bwMode="auto">
           <a:xfrm rot="0" flipH="0" flipV="0">
-            <a:off x="299016" y="1480789"/>
+            <a:off x="299015" y="1480789"/>
             <a:ext cx="825590" cy="701399"/>
           </a:xfrm>
           <a:prstGeom prst="rect">
@@ -10142,7 +10143,7 @@
       </p:sp>
       <p:sp>
         <p:nvSpPr>
-          <p:cNvPr id="435909104" name="Rectangle 66"/>
+          <p:cNvPr id="2011513972" name="Rectangle 66"/>
           <p:cNvSpPr txBox="1"/>
           <p:nvPr/>
         </p:nvSpPr>
@@ -10196,7 +10197,7 @@
       </p:sp>
       <p:sp>
         <p:nvSpPr>
-          <p:cNvPr id="1557053405" name="Rectangle 67"/>
+          <p:cNvPr id="111336389" name="Rectangle 67"/>
           <p:cNvSpPr txBox="1"/>
           <p:nvPr/>
         </p:nvSpPr>
@@ -10250,7 +10251,7 @@
       </p:sp>
       <p:sp>
         <p:nvSpPr>
-          <p:cNvPr id="231262687" name="Rectangle 68"/>
+          <p:cNvPr id="348968607" name="Rectangle 68"/>
           <p:cNvSpPr txBox="1"/>
           <p:nvPr/>
         </p:nvSpPr>
@@ -10304,7 +10305,7 @@
       </p:sp>
       <p:grpSp>
         <p:nvGrpSpPr>
-          <p:cNvPr id="2051232548" name="Group 69"/>
+          <p:cNvPr id="1640176449" name="Group 69"/>
           <p:cNvGrpSpPr/>
           <p:nvPr/>
         </p:nvGrpSpPr>
@@ -10470,7 +10471,7 @@
       </p:grpSp>
       <p:grpSp>
         <p:nvGrpSpPr>
-          <p:cNvPr id="1553870218" name="Group 71"/>
+          <p:cNvPr id="364873856" name="Group 71"/>
           <p:cNvGrpSpPr/>
           <p:nvPr/>
         </p:nvGrpSpPr>
@@ -10636,7 +10637,7 @@
       </p:grpSp>
       <p:sp>
         <p:nvSpPr>
-          <p:cNvPr id="172462490" name="Rectangle 75"/>
+          <p:cNvPr id="1744562795" name="Rectangle 75"/>
           <p:cNvSpPr txBox="1"/>
           <p:nvPr/>
         </p:nvSpPr>
@@ -10675,7 +10676,7 @@
       </p:sp>
       <p:sp>
         <p:nvSpPr>
-          <p:cNvPr id="193520749" name="Rectangle 76"/>
+          <p:cNvPr id="110269571" name="Rectangle 76"/>
           <p:cNvSpPr txBox="1"/>
           <p:nvPr/>
         </p:nvSpPr>
@@ -10719,7 +10720,7 @@
       </p:sp>
       <p:sp>
         <p:nvSpPr>
-          <p:cNvPr id="1127195306" name="Rectangle 82"/>
+          <p:cNvPr id="706944115" name="Rectangle 82"/>
           <p:cNvSpPr txBox="1"/>
           <p:nvPr/>
         </p:nvSpPr>
@@ -10773,7 +10774,7 @@
       </p:sp>
       <p:sp>
         <p:nvSpPr>
-          <p:cNvPr id="1323745656" name="Flowchart: Alternate process 103"/>
+          <p:cNvPr id="1407959408" name="Flowchart: Alternate process 103"/>
           <p:cNvSpPr/>
           <p:nvPr/>
         </p:nvSpPr>
@@ -10863,7 +10864,7 @@
       </p:sp>
       <p:grpSp>
         <p:nvGrpSpPr>
-          <p:cNvPr id="706121253" name="Group 110"/>
+          <p:cNvPr id="1976380679" name="Group 110"/>
           <p:cNvGrpSpPr/>
           <p:nvPr/>
         </p:nvGrpSpPr>
@@ -11029,7 +11030,7 @@
       </p:grpSp>
       <p:grpSp>
         <p:nvGrpSpPr>
-          <p:cNvPr id="1133376437" name="Group 112"/>
+          <p:cNvPr id="1475549340" name="Group 112"/>
           <p:cNvGrpSpPr/>
           <p:nvPr/>
         </p:nvGrpSpPr>
@@ -11195,7 +11196,7 @@
       </p:grpSp>
       <p:sp>
         <p:nvSpPr>
-          <p:cNvPr id="1696093517" name="Rectangle 114"/>
+          <p:cNvPr id="1832354937" name="Rectangle 114"/>
           <p:cNvSpPr txBox="1"/>
           <p:nvPr/>
         </p:nvSpPr>
@@ -11246,7 +11247,7 @@
       </p:sp>
       <p:sp>
         <p:nvSpPr>
-          <p:cNvPr id="793804314" name="Rectangle 115"/>
+          <p:cNvPr id="1227451409" name="Rectangle 115"/>
           <p:cNvSpPr txBox="1"/>
           <p:nvPr/>
         </p:nvSpPr>
@@ -11297,7 +11298,7 @@
       </p:sp>
       <p:sp>
         <p:nvSpPr>
-          <p:cNvPr id="1572611968" name="Rectangle 116"/>
+          <p:cNvPr id="156510923" name="Rectangle 116"/>
           <p:cNvSpPr txBox="1"/>
           <p:nvPr/>
         </p:nvSpPr>
@@ -11351,7 +11352,7 @@
       </p:sp>
       <p:sp>
         <p:nvSpPr>
-          <p:cNvPr id="1620091321" name="Rectangle 117"/>
+          <p:cNvPr id="1456918560" name="Rectangle 117"/>
           <p:cNvSpPr txBox="1"/>
           <p:nvPr/>
         </p:nvSpPr>
@@ -11405,7 +11406,7 @@
       </p:sp>
       <p:sp>
         <p:nvSpPr>
-          <p:cNvPr id="755871580" name="Flowchart: Alternate process 118"/>
+          <p:cNvPr id="422265623" name="Flowchart: Alternate process 118"/>
           <p:cNvSpPr/>
           <p:nvPr/>
         </p:nvSpPr>
@@ -11495,7 +11496,7 @@
       </p:sp>
       <p:sp>
         <p:nvSpPr>
-          <p:cNvPr id="653857009" name="Rectangle 119"/>
+          <p:cNvPr id="319321418" name="Rectangle 119"/>
           <p:cNvSpPr txBox="1"/>
           <p:nvPr/>
         </p:nvSpPr>
@@ -11586,7 +11587,7 @@
       </p:grpSpPr>
       <p:sp>
         <p:nvSpPr>
-          <p:cNvPr id="329921568" name="Title 1"/>
+          <p:cNvPr id="2099588267" name="Title 1"/>
           <p:cNvSpPr>
             <a:spLocks noGrp="1"/>
           </p:cNvSpPr>
@@ -11638,7 +11639,7 @@
       </p:sp>
       <p:grpSp>
         <p:nvGrpSpPr>
-          <p:cNvPr id="453853073" name="Group 2"/>
+          <p:cNvPr id="1642813831" name="Group 2"/>
           <p:cNvGrpSpPr/>
           <p:nvPr/>
         </p:nvGrpSpPr>
@@ -11804,7 +11805,7 @@
       </p:grpSp>
       <p:grpSp>
         <p:nvGrpSpPr>
-          <p:cNvPr id="958528873" name="Group 5"/>
+          <p:cNvPr id="615621734" name="Group 5"/>
           <p:cNvGrpSpPr/>
           <p:nvPr/>
         </p:nvGrpSpPr>
@@ -11970,7 +11971,7 @@
       </p:grpSp>
       <p:grpSp>
         <p:nvGrpSpPr>
-          <p:cNvPr id="751916719" name="Group 8"/>
+          <p:cNvPr id="101935286" name="Group 8"/>
           <p:cNvGrpSpPr/>
           <p:nvPr/>
         </p:nvGrpSpPr>
@@ -12136,7 +12137,7 @@
       </p:grpSp>
       <p:sp>
         <p:nvSpPr>
-          <p:cNvPr id="75505583" name="Rectangle 14"/>
+          <p:cNvPr id="1893463342" name="Rectangle 14"/>
           <p:cNvSpPr txBox="1"/>
           <p:nvPr/>
         </p:nvSpPr>
@@ -12180,7 +12181,7 @@
       </p:sp>
       <p:sp>
         <p:nvSpPr>
-          <p:cNvPr id="344010587" name="Rectangle 15"/>
+          <p:cNvPr id="515025448" name="Rectangle 15"/>
           <p:cNvSpPr txBox="1"/>
           <p:nvPr/>
         </p:nvSpPr>
@@ -12225,7 +12226,7 @@
       </p:sp>
       <p:sp>
         <p:nvSpPr>
-          <p:cNvPr id="120823684" name="Rectangle 16"/>
+          <p:cNvPr id="1257531497" name="Rectangle 16"/>
           <p:cNvSpPr txBox="1"/>
           <p:nvPr/>
         </p:nvSpPr>
@@ -12269,7 +12270,7 @@
       </p:sp>
       <p:grpSp>
         <p:nvGrpSpPr>
-          <p:cNvPr id="187545028" name="Group 66"/>
+          <p:cNvPr id="1418125491" name="Group 66"/>
           <p:cNvGrpSpPr/>
           <p:nvPr/>
         </p:nvGrpSpPr>
@@ -12435,7 +12436,7 @@
       </p:grpSp>
       <p:sp>
         <p:nvSpPr>
-          <p:cNvPr id="1527699410" name="Rectangle 68"/>
+          <p:cNvPr id="391309709" name="Rectangle 68"/>
           <p:cNvSpPr txBox="1"/>
           <p:nvPr/>
         </p:nvSpPr>
@@ -12479,7 +12480,7 @@
       </p:sp>
       <p:grpSp>
         <p:nvGrpSpPr>
-          <p:cNvPr id="2058855112" name="Group 118"/>
+          <p:cNvPr id="1274811468" name="Group 118"/>
           <p:cNvGrpSpPr/>
           <p:nvPr/>
         </p:nvGrpSpPr>
@@ -12645,7 +12646,7 @@
       </p:grpSp>
       <p:sp>
         <p:nvSpPr>
-          <p:cNvPr id="2003696336" name="Rectangle 120"/>
+          <p:cNvPr id="1923620486" name="Rectangle 120"/>
           <p:cNvSpPr txBox="1"/>
           <p:nvPr/>
         </p:nvSpPr>
@@ -12689,7 +12690,7 @@
       </p:sp>
       <p:pic>
         <p:nvPicPr>
-          <p:cNvPr id="232027022" name="Picture 22"/>
+          <p:cNvPr id="1650781369" name="Picture 22"/>
           <p:cNvPicPr>
             <a:picLocks noChangeAspect="1"/>
           </p:cNvPicPr>
@@ -12716,7 +12717,7 @@
       </p:pic>
       <p:pic>
         <p:nvPicPr>
-          <p:cNvPr id="2016503548" name="Picture 25"/>
+          <p:cNvPr id="708677029" name="Picture 25"/>
           <p:cNvPicPr>
             <a:picLocks noChangeAspect="1"/>
           </p:cNvPicPr>
@@ -12743,7 +12744,7 @@
       </p:pic>
       <p:pic>
         <p:nvPicPr>
-          <p:cNvPr id="1568876101" name="Picture 26"/>
+          <p:cNvPr id="1755164147" name="Picture 26"/>
           <p:cNvPicPr>
             <a:picLocks noChangeAspect="1"/>
           </p:cNvPicPr>
@@ -12770,7 +12771,7 @@
       </p:pic>
       <p:pic>
         <p:nvPicPr>
-          <p:cNvPr id="2095990148" name="Picture 27"/>
+          <p:cNvPr id="1770250824" name="Picture 27"/>
           <p:cNvPicPr>
             <a:picLocks noChangeAspect="1"/>
           </p:cNvPicPr>
@@ -12797,7 +12798,7 @@
       </p:pic>
       <p:pic>
         <p:nvPicPr>
-          <p:cNvPr id="1348116505" name="Picture 28"/>
+          <p:cNvPr id="1866091378" name="Picture 28"/>
           <p:cNvPicPr>
             <a:picLocks noChangeAspect="1"/>
           </p:cNvPicPr>
@@ -12861,7 +12862,7 @@
       </p:grpSpPr>
       <p:sp>
         <p:nvSpPr>
-          <p:cNvPr id="1356165231" name="Title 1"/>
+          <p:cNvPr id="1895258920" name="Title 1"/>
           <p:cNvSpPr>
             <a:spLocks noGrp="1"/>
           </p:cNvSpPr>
@@ -12913,7 +12914,7 @@
       </p:sp>
       <p:grpSp>
         <p:nvGrpSpPr>
-          <p:cNvPr id="1590870366" name="Group 22"/>
+          <p:cNvPr id="1271397403" name="Group 22"/>
           <p:cNvGrpSpPr/>
           <p:nvPr/>
         </p:nvGrpSpPr>
@@ -13079,7 +13080,7 @@
       </p:grpSp>
       <p:grpSp>
         <p:nvGrpSpPr>
-          <p:cNvPr id="1294230343" name="Group 24"/>
+          <p:cNvPr id="1895012621" name="Group 24"/>
           <p:cNvGrpSpPr/>
           <p:nvPr/>
         </p:nvGrpSpPr>
@@ -13245,7 +13246,7 @@
       </p:grpSp>
       <p:grpSp>
         <p:nvGrpSpPr>
-          <p:cNvPr id="1812961239" name="Group 26"/>
+          <p:cNvPr id="1332884706" name="Group 26"/>
           <p:cNvGrpSpPr/>
           <p:nvPr/>
         </p:nvGrpSpPr>
@@ -13411,7 +13412,7 @@
       </p:grpSp>
       <p:grpSp>
         <p:nvGrpSpPr>
-          <p:cNvPr id="609507312" name="Group 28"/>
+          <p:cNvPr id="814642713" name="Group 28"/>
           <p:cNvGrpSpPr/>
           <p:nvPr/>
         </p:nvGrpSpPr>
@@ -13577,7 +13578,7 @@
       </p:grpSp>
       <p:sp>
         <p:nvSpPr>
-          <p:cNvPr id="253243758" name="Rectangle 30"/>
+          <p:cNvPr id="1398838450" name="Rectangle 30"/>
           <p:cNvSpPr txBox="1"/>
           <p:nvPr/>
         </p:nvSpPr>
@@ -13632,7 +13633,7 @@
       </p:sp>
       <p:sp>
         <p:nvSpPr>
-          <p:cNvPr id="160399269" name="Rectangle 31"/>
+          <p:cNvPr id="918774975" name="Rectangle 31"/>
           <p:cNvSpPr txBox="1"/>
           <p:nvPr/>
         </p:nvSpPr>
@@ -13677,7 +13678,7 @@
       </p:sp>
       <p:sp>
         <p:nvSpPr>
-          <p:cNvPr id="1473452145" name="Rectangle 32"/>
+          <p:cNvPr id="1241125804" name="Rectangle 32"/>
           <p:cNvSpPr txBox="1"/>
           <p:nvPr/>
         </p:nvSpPr>
@@ -13722,7 +13723,7 @@
       </p:sp>
       <p:sp>
         <p:nvSpPr>
-          <p:cNvPr id="2139534573" name="Rectangle 33"/>
+          <p:cNvPr id="240544430" name="Rectangle 33"/>
           <p:cNvSpPr txBox="1"/>
           <p:nvPr/>
         </p:nvSpPr>
@@ -13779,7 +13780,7 @@
       </p:sp>
       <p:grpSp>
         <p:nvGrpSpPr>
-          <p:cNvPr id="429886564" name="Group 34"/>
+          <p:cNvPr id="210765346" name="Group 34"/>
           <p:cNvGrpSpPr/>
           <p:nvPr/>
         </p:nvGrpSpPr>
@@ -13945,7 +13946,7 @@
       </p:grpSp>
       <p:sp>
         <p:nvSpPr>
-          <p:cNvPr id="392683103" name="Rectangle 36"/>
+          <p:cNvPr id="837646164" name="Rectangle 36"/>
           <p:cNvSpPr txBox="1"/>
           <p:nvPr/>
         </p:nvSpPr>
@@ -13989,7 +13990,7 @@
       </p:sp>
       <p:pic>
         <p:nvPicPr>
-          <p:cNvPr id="1964190037" name="Picture 22"/>
+          <p:cNvPr id="891538462" name="Picture 22"/>
           <p:cNvPicPr>
             <a:picLocks noChangeAspect="1"/>
           </p:cNvPicPr>
@@ -14016,7 +14017,7 @@
       </p:pic>
       <p:pic>
         <p:nvPicPr>
-          <p:cNvPr id="398497392" name="Picture 23"/>
+          <p:cNvPr id="934220758" name="Picture 23"/>
           <p:cNvPicPr>
             <a:picLocks noChangeAspect="1"/>
           </p:cNvPicPr>
@@ -14043,7 +14044,7 @@
       </p:pic>
       <p:pic>
         <p:nvPicPr>
-          <p:cNvPr id="2114200154" name="Picture 24"/>
+          <p:cNvPr id="2087555763" name="Picture 24"/>
           <p:cNvPicPr>
             <a:picLocks noChangeAspect="1"/>
           </p:cNvPicPr>
@@ -14070,7 +14071,7 @@
       </p:pic>
       <p:pic>
         <p:nvPicPr>
-          <p:cNvPr id="1613330658" name="Picture 25"/>
+          <p:cNvPr id="1046039785" name="Picture 25"/>
           <p:cNvPicPr>
             <a:picLocks noChangeAspect="1"/>
           </p:cNvPicPr>
@@ -14097,7 +14098,7 @@
       </p:pic>
       <p:pic>
         <p:nvPicPr>
-          <p:cNvPr id="427348821" name="Picture 26"/>
+          <p:cNvPr id="1744546781" name="Picture 26"/>
           <p:cNvPicPr>
             <a:picLocks noChangeAspect="1"/>
           </p:cNvPicPr>
@@ -14161,7 +14162,7 @@
       </p:grpSpPr>
       <p:sp>
         <p:nvSpPr>
-          <p:cNvPr id="555031221" name="Title 1"/>
+          <p:cNvPr id="1924796314" name="Title 1"/>
           <p:cNvSpPr>
             <a:spLocks noGrp="1"/>
           </p:cNvSpPr>
@@ -14171,7 +14172,7 @@
         </p:nvSpPr>
         <p:spPr bwMode="auto">
           <a:xfrm flipH="0" flipV="0">
-            <a:off x="3749357" y="2514947"/>
+            <a:off x="3886940" y="2514946"/>
             <a:ext cx="4703581" cy="1294743"/>
           </a:xfrm>
         </p:spPr>
@@ -14193,7 +14194,7 @@
                 <a:ea typeface="Michroma"/>
                 <a:cs typeface="Michroma"/>
               </a:rPr>
-              <a:t>Grazie per l’attenzione !</a:t>
+              <a:t>Grazie per l’attenzione!</a:t>
             </a:r>
             <a:endParaRPr sz="3200">
               <a:solidFill>
@@ -14207,7 +14208,7 @@
       </p:sp>
       <p:sp>
         <p:nvSpPr>
-          <p:cNvPr id="863362206" name="Subtitle 2"/>
+          <p:cNvPr id="1783184892" name="Subtitle 2"/>
           <p:cNvSpPr>
             <a:spLocks noGrp="1"/>
           </p:cNvSpPr>
@@ -14217,7 +14218,7 @@
         </p:nvSpPr>
         <p:spPr bwMode="auto">
           <a:xfrm flipH="0" flipV="0">
-            <a:off x="4061956" y="3896104"/>
+            <a:off x="4056664" y="3896103"/>
             <a:ext cx="4143864" cy="394222"/>
           </a:xfrm>
         </p:spPr>
@@ -14263,7 +14264,7 @@
       </p:sp>
       <p:sp>
         <p:nvSpPr>
-          <p:cNvPr id="1005624193" name="Slide Number Placeholder 5"/>
+          <p:cNvPr id="2084687338" name="Slide Number Placeholder 5"/>
           <p:cNvSpPr>
             <a:spLocks noGrp="1"/>
           </p:cNvSpPr>
@@ -14289,7 +14290,7 @@
       </p:sp>
       <p:pic>
         <p:nvPicPr>
-          <p:cNvPr id="152497793" name="Picture 5"/>
+          <p:cNvPr id="1625931233" name="Picture 5"/>
           <p:cNvPicPr>
             <a:picLocks noChangeAspect="1"/>
           </p:cNvPicPr>
@@ -14300,8 +14301,37 @@
         </p:blipFill>
         <p:spPr bwMode="auto">
           <a:xfrm flipH="0" flipV="0">
-            <a:off x="4583366" y="1289619"/>
+            <a:off x="4710366" y="1480118"/>
             <a:ext cx="3003154" cy="993722"/>
+          </a:xfrm>
+          <a:prstGeom prst="rect">
+            <a:avLst/>
+          </a:prstGeom>
+        </p:spPr>
+      </p:pic>
+      <p:pic>
+        <p:nvPicPr>
+          <p:cNvPr id="911191967" name="Picture 7"/>
+          <p:cNvPicPr>
+            <a:picLocks noChangeAspect="1"/>
+          </p:cNvPicPr>
+          <p:nvPr/>
+        </p:nvPicPr>
+        <p:blipFill rotWithShape="1">
+          <a:blip r:embed="rId5">
+            <a:alphaModFix amt="99999"/>
+            <a:extLst>
+              <a:ext uri="{96DAC541-7B7A-43D3-8B79-37D633B846F1}">
+                <asvg:svgBlip xmlns:asvg="http://schemas.microsoft.com/office/drawing/2016/SVG/main" r:embed="rId6"/>
+              </a:ext>
+            </a:extLst>
+          </a:blip>
+          <a:stretch/>
+        </p:blipFill>
+        <p:spPr bwMode="auto">
+          <a:xfrm flipH="0" flipV="0">
+            <a:off x="7691558" y="3940449"/>
+            <a:ext cx="166403" cy="162081"/>
           </a:xfrm>
           <a:prstGeom prst="rect">
             <a:avLst/>

</xml_diff>

<commit_message>
Aggiornato diario delle modifiche
</commit_message>
<xml_diff>
--- a/src/diari_di_bordo/DiarioDiBordo1_ZeroSixStudio.pptx
+++ b/src/diari_di_bordo/DiarioDiBordo1_ZeroSixStudio.pptx
@@ -142,7 +142,7 @@
       </p:grpSpPr>
       <p:sp>
         <p:nvSpPr>
-          <p:cNvPr id="985785155" name="Header Placeholder 1"/>
+          <p:cNvPr id="737300465" name="Header Placeholder 1"/>
           <p:cNvSpPr>
             <a:spLocks noGrp="1"/>
           </p:cNvSpPr>
@@ -176,7 +176,7 @@
       </p:sp>
       <p:sp>
         <p:nvSpPr>
-          <p:cNvPr id="461192569" name="Date Placeholder 2"/>
+          <p:cNvPr id="1755819050" name="Date Placeholder 2"/>
           <p:cNvSpPr>
             <a:spLocks noGrp="1"/>
           </p:cNvSpPr>
@@ -214,7 +214,7 @@
       </p:sp>
       <p:sp>
         <p:nvSpPr>
-          <p:cNvPr id="1163860604" name="Footer Placeholder 3"/>
+          <p:cNvPr id="504409246" name="Footer Placeholder 3"/>
           <p:cNvSpPr>
             <a:spLocks noGrp="1"/>
           </p:cNvSpPr>
@@ -248,7 +248,7 @@
       </p:sp>
       <p:sp>
         <p:nvSpPr>
-          <p:cNvPr id="259107707" name="Slide Number Placeholder 4"/>
+          <p:cNvPr id="371101716" name="Slide Number Placeholder 4"/>
           <p:cNvSpPr>
             <a:spLocks noGrp="1"/>
           </p:cNvSpPr>
@@ -314,7 +314,7 @@
       </p:grpSpPr>
       <p:sp>
         <p:nvSpPr>
-          <p:cNvPr id="1302927058" name="Header Placeholder 1"/>
+          <p:cNvPr id="751103682" name="Header Placeholder 1"/>
           <p:cNvSpPr>
             <a:spLocks noGrp="1"/>
           </p:cNvSpPr>
@@ -348,7 +348,7 @@
       </p:sp>
       <p:sp>
         <p:nvSpPr>
-          <p:cNvPr id="1887351866" name="Date Placeholder 2"/>
+          <p:cNvPr id="939746869" name="Date Placeholder 2"/>
           <p:cNvSpPr>
             <a:spLocks noGrp="1"/>
           </p:cNvSpPr>
@@ -386,7 +386,7 @@
       </p:sp>
       <p:sp>
         <p:nvSpPr>
-          <p:cNvPr id="118826351" name="Slide Image Placeholder 3"/>
+          <p:cNvPr id="405297778" name="Slide Image Placeholder 3"/>
           <p:cNvSpPr>
             <a:spLocks noChangeAspect="1" noGrp="1" noRot="1"/>
           </p:cNvSpPr>
@@ -422,7 +422,7 @@
       </p:sp>
       <p:sp>
         <p:nvSpPr>
-          <p:cNvPr id="1214321579" name="Notes Placeholder 4"/>
+          <p:cNvPr id="475533945" name="Notes Placeholder 4"/>
           <p:cNvSpPr>
             <a:spLocks noGrp="1"/>
           </p:cNvSpPr>
@@ -496,7 +496,7 @@
       </p:sp>
       <p:sp>
         <p:nvSpPr>
-          <p:cNvPr id="1999236309" name="Footer Placeholder 5"/>
+          <p:cNvPr id="912813327" name="Footer Placeholder 5"/>
           <p:cNvSpPr>
             <a:spLocks noGrp="1"/>
           </p:cNvSpPr>
@@ -530,7 +530,7 @@
       </p:sp>
       <p:sp>
         <p:nvSpPr>
-          <p:cNvPr id="1432182554" name="Slide Number Placeholder 6"/>
+          <p:cNvPr id="1634737928" name="Slide Number Placeholder 6"/>
           <p:cNvSpPr>
             <a:spLocks noGrp="1"/>
           </p:cNvSpPr>
@@ -683,7 +683,7 @@
       </p:grpSpPr>
       <p:sp>
         <p:nvSpPr>
-          <p:cNvPr id="646651869" name="Slide Image Placeholder 1"/>
+          <p:cNvPr id="327228379" name="Slide Image Placeholder 1"/>
           <p:cNvSpPr>
             <a:spLocks noChangeAspect="1" noGrp="1" noRot="1"/>
           </p:cNvSpPr>
@@ -695,7 +695,7 @@
       </p:sp>
       <p:sp>
         <p:nvSpPr>
-          <p:cNvPr id="741554771" name="Notes Placeholder 2"/>
+          <p:cNvPr id="1817098843" name="Notes Placeholder 2"/>
           <p:cNvSpPr>
             <a:spLocks noGrp="1"/>
           </p:cNvSpPr>
@@ -717,7 +717,7 @@
       </p:sp>
       <p:sp>
         <p:nvSpPr>
-          <p:cNvPr id="410297312" name="Slide Number Placeholder 3"/>
+          <p:cNvPr id="111928282" name="Slide Number Placeholder 3"/>
           <p:cNvSpPr>
             <a:spLocks noGrp="1"/>
           </p:cNvSpPr>
@@ -768,7 +768,7 @@
       </p:grpSpPr>
       <p:sp>
         <p:nvSpPr>
-          <p:cNvPr id="32787955" name="Slide Image Placeholder 1"/>
+          <p:cNvPr id="547028696" name="Slide Image Placeholder 1"/>
           <p:cNvSpPr>
             <a:spLocks noChangeAspect="1" noGrp="1" noRot="1"/>
           </p:cNvSpPr>
@@ -780,7 +780,7 @@
       </p:sp>
       <p:sp>
         <p:nvSpPr>
-          <p:cNvPr id="1969646922" name="Notes Placeholder 2"/>
+          <p:cNvPr id="1041344746" name="Notes Placeholder 2"/>
           <p:cNvSpPr>
             <a:spLocks noGrp="1"/>
           </p:cNvSpPr>
@@ -802,7 +802,7 @@
       </p:sp>
       <p:sp>
         <p:nvSpPr>
-          <p:cNvPr id="1523514590" name="Slide Number Placeholder 3"/>
+          <p:cNvPr id="906890640" name="Slide Number Placeholder 3"/>
           <p:cNvSpPr>
             <a:spLocks noGrp="1"/>
           </p:cNvSpPr>
@@ -853,7 +853,7 @@
       </p:grpSpPr>
       <p:sp>
         <p:nvSpPr>
-          <p:cNvPr id="2078714633" name="Slide Image Placeholder 1"/>
+          <p:cNvPr id="1259405079" name="Slide Image Placeholder 1"/>
           <p:cNvSpPr>
             <a:spLocks noChangeAspect="1" noGrp="1" noRot="1"/>
           </p:cNvSpPr>
@@ -865,7 +865,7 @@
       </p:sp>
       <p:sp>
         <p:nvSpPr>
-          <p:cNvPr id="1199246978" name="Notes Placeholder 2"/>
+          <p:cNvPr id="1932510600" name="Notes Placeholder 2"/>
           <p:cNvSpPr>
             <a:spLocks noGrp="1"/>
           </p:cNvSpPr>
@@ -887,7 +887,7 @@
       </p:sp>
       <p:sp>
         <p:nvSpPr>
-          <p:cNvPr id="1617196487" name="Slide Number Placeholder 3"/>
+          <p:cNvPr id="366923592" name="Slide Number Placeholder 3"/>
           <p:cNvSpPr>
             <a:spLocks noGrp="1"/>
           </p:cNvSpPr>
@@ -938,7 +938,7 @@
       </p:grpSpPr>
       <p:sp>
         <p:nvSpPr>
-          <p:cNvPr id="301960699" name="Slide Image Placeholder 1"/>
+          <p:cNvPr id="52155422" name="Slide Image Placeholder 1"/>
           <p:cNvSpPr>
             <a:spLocks noChangeAspect="1" noGrp="1" noRot="1"/>
           </p:cNvSpPr>
@@ -950,7 +950,7 @@
       </p:sp>
       <p:sp>
         <p:nvSpPr>
-          <p:cNvPr id="1980457412" name="Notes Placeholder 2"/>
+          <p:cNvPr id="630996013" name="Notes Placeholder 2"/>
           <p:cNvSpPr>
             <a:spLocks noGrp="1"/>
           </p:cNvSpPr>
@@ -972,7 +972,7 @@
       </p:sp>
       <p:sp>
         <p:nvSpPr>
-          <p:cNvPr id="1028717569" name="Slide Number Placeholder 3"/>
+          <p:cNvPr id="927680464" name="Slide Number Placeholder 3"/>
           <p:cNvSpPr>
             <a:spLocks noGrp="1"/>
           </p:cNvSpPr>
@@ -1023,7 +1023,7 @@
       </p:grpSpPr>
       <p:sp>
         <p:nvSpPr>
-          <p:cNvPr id="1486117185" name="Slide Image Placeholder 1"/>
+          <p:cNvPr id="1784870133" name="Slide Image Placeholder 1"/>
           <p:cNvSpPr>
             <a:spLocks noChangeAspect="1" noGrp="1" noRot="1"/>
           </p:cNvSpPr>
@@ -1035,7 +1035,7 @@
       </p:sp>
       <p:sp>
         <p:nvSpPr>
-          <p:cNvPr id="1620081502" name="Notes Placeholder 2"/>
+          <p:cNvPr id="2100334614" name="Notes Placeholder 2"/>
           <p:cNvSpPr>
             <a:spLocks noGrp="1"/>
           </p:cNvSpPr>
@@ -1057,7 +1057,7 @@
       </p:sp>
       <p:sp>
         <p:nvSpPr>
-          <p:cNvPr id="1173342963" name="Slide Number Placeholder 3"/>
+          <p:cNvPr id="919248203" name="Slide Number Placeholder 3"/>
           <p:cNvSpPr>
             <a:spLocks noGrp="1"/>
           </p:cNvSpPr>
@@ -1108,7 +1108,7 @@
       </p:grpSpPr>
       <p:sp>
         <p:nvSpPr>
-          <p:cNvPr id="2023717913" name="Slide Image Placeholder 1"/>
+          <p:cNvPr id="462538289" name="Slide Image Placeholder 1"/>
           <p:cNvSpPr>
             <a:spLocks noChangeAspect="1" noGrp="1" noRot="1"/>
           </p:cNvSpPr>
@@ -1120,7 +1120,7 @@
       </p:sp>
       <p:sp>
         <p:nvSpPr>
-          <p:cNvPr id="380425884" name="Notes Placeholder 2"/>
+          <p:cNvPr id="2102725244" name="Notes Placeholder 2"/>
           <p:cNvSpPr>
             <a:spLocks noGrp="1"/>
           </p:cNvSpPr>
@@ -1142,7 +1142,7 @@
       </p:sp>
       <p:sp>
         <p:nvSpPr>
-          <p:cNvPr id="1028984886" name="Slide Number Placeholder 3"/>
+          <p:cNvPr id="74444681" name="Slide Number Placeholder 3"/>
           <p:cNvSpPr>
             <a:spLocks noGrp="1"/>
           </p:cNvSpPr>
@@ -1193,7 +1193,7 @@
       </p:grpSpPr>
       <p:sp>
         <p:nvSpPr>
-          <p:cNvPr id="1928202713" name="Title 1"/>
+          <p:cNvPr id="2038160131" name="Title 1"/>
           <p:cNvSpPr>
             <a:spLocks noGrp="1"/>
           </p:cNvSpPr>
@@ -1228,7 +1228,7 @@
       </p:sp>
       <p:sp>
         <p:nvSpPr>
-          <p:cNvPr id="66052847" name="Subtitle 2"/>
+          <p:cNvPr id="504546461" name="Subtitle 2"/>
           <p:cNvSpPr>
             <a:spLocks noGrp="1"/>
           </p:cNvSpPr>
@@ -1296,7 +1296,7 @@
       </p:sp>
       <p:sp>
         <p:nvSpPr>
-          <p:cNvPr id="824955164" name="Date Placeholder 3"/>
+          <p:cNvPr id="1602918738" name="Date Placeholder 3"/>
           <p:cNvSpPr>
             <a:spLocks noGrp="1"/>
           </p:cNvSpPr>
@@ -1322,7 +1322,7 @@
       </p:sp>
       <p:sp>
         <p:nvSpPr>
-          <p:cNvPr id="376335108" name="Footer Placeholder 4"/>
+          <p:cNvPr id="737608942" name="Footer Placeholder 4"/>
           <p:cNvSpPr>
             <a:spLocks noGrp="1"/>
           </p:cNvSpPr>
@@ -1344,7 +1344,7 @@
       </p:sp>
       <p:sp>
         <p:nvSpPr>
-          <p:cNvPr id="453107427" name="Slide Number Placeholder 5"/>
+          <p:cNvPr id="1951437743" name="Slide Number Placeholder 5"/>
           <p:cNvSpPr>
             <a:spLocks noGrp="1"/>
           </p:cNvSpPr>
@@ -1395,7 +1395,7 @@
       </p:grpSpPr>
       <p:sp>
         <p:nvSpPr>
-          <p:cNvPr id="1940173766" name="Title 1"/>
+          <p:cNvPr id="2014578813" name="Title 1"/>
           <p:cNvSpPr>
             <a:spLocks noGrp="1"/>
           </p:cNvSpPr>
@@ -1421,7 +1421,7 @@
       </p:sp>
       <p:sp>
         <p:nvSpPr>
-          <p:cNvPr id="1086475326" name="Vertical Text Placeholder 2"/>
+          <p:cNvPr id="1429180218" name="Vertical Text Placeholder 2"/>
           <p:cNvSpPr>
             <a:spLocks noGrp="1"/>
           </p:cNvSpPr>
@@ -1487,7 +1487,7 @@
       </p:sp>
       <p:sp>
         <p:nvSpPr>
-          <p:cNvPr id="1032765822" name="Date Placeholder 3"/>
+          <p:cNvPr id="1438544312" name="Date Placeholder 3"/>
           <p:cNvSpPr>
             <a:spLocks noGrp="1"/>
           </p:cNvSpPr>
@@ -1513,7 +1513,7 @@
       </p:sp>
       <p:sp>
         <p:nvSpPr>
-          <p:cNvPr id="1692540157" name="Footer Placeholder 4"/>
+          <p:cNvPr id="1551188921" name="Footer Placeholder 4"/>
           <p:cNvSpPr>
             <a:spLocks noGrp="1"/>
           </p:cNvSpPr>
@@ -1535,7 +1535,7 @@
       </p:sp>
       <p:sp>
         <p:nvSpPr>
-          <p:cNvPr id="874872213" name="Slide Number Placeholder 5"/>
+          <p:cNvPr id="1692942508" name="Slide Number Placeholder 5"/>
           <p:cNvSpPr>
             <a:spLocks noGrp="1"/>
           </p:cNvSpPr>
@@ -1586,7 +1586,7 @@
       </p:grpSpPr>
       <p:sp>
         <p:nvSpPr>
-          <p:cNvPr id="2006187785" name="Vertical Title 1"/>
+          <p:cNvPr id="1599714224" name="Vertical Title 1"/>
           <p:cNvSpPr>
             <a:spLocks noGrp="1"/>
           </p:cNvSpPr>
@@ -1617,7 +1617,7 @@
       </p:sp>
       <p:sp>
         <p:nvSpPr>
-          <p:cNvPr id="1207700952" name="Vertical Text Placeholder 2"/>
+          <p:cNvPr id="1237047696" name="Vertical Text Placeholder 2"/>
           <p:cNvSpPr>
             <a:spLocks noGrp="1"/>
           </p:cNvSpPr>
@@ -1688,7 +1688,7 @@
       </p:sp>
       <p:sp>
         <p:nvSpPr>
-          <p:cNvPr id="1414640922" name="Date Placeholder 3"/>
+          <p:cNvPr id="402777772" name="Date Placeholder 3"/>
           <p:cNvSpPr>
             <a:spLocks noGrp="1"/>
           </p:cNvSpPr>
@@ -1714,7 +1714,7 @@
       </p:sp>
       <p:sp>
         <p:nvSpPr>
-          <p:cNvPr id="1055516673" name="Footer Placeholder 4"/>
+          <p:cNvPr id="1227526793" name="Footer Placeholder 4"/>
           <p:cNvSpPr>
             <a:spLocks noGrp="1"/>
           </p:cNvSpPr>
@@ -1736,7 +1736,7 @@
       </p:sp>
       <p:sp>
         <p:nvSpPr>
-          <p:cNvPr id="1170068829" name="Slide Number Placeholder 5"/>
+          <p:cNvPr id="1194164751" name="Slide Number Placeholder 5"/>
           <p:cNvSpPr>
             <a:spLocks noGrp="1"/>
           </p:cNvSpPr>
@@ -1787,7 +1787,7 @@
       </p:grpSpPr>
       <p:sp>
         <p:nvSpPr>
-          <p:cNvPr id="938882720" name="Title 1"/>
+          <p:cNvPr id="933115512" name="Title 1"/>
           <p:cNvSpPr>
             <a:spLocks noGrp="1"/>
           </p:cNvSpPr>
@@ -1813,7 +1813,7 @@
       </p:sp>
       <p:sp>
         <p:nvSpPr>
-          <p:cNvPr id="248867136" name="Content Placeholder 2"/>
+          <p:cNvPr id="1871455371" name="Content Placeholder 2"/>
           <p:cNvSpPr>
             <a:spLocks noGrp="1"/>
           </p:cNvSpPr>
@@ -1879,7 +1879,7 @@
       </p:sp>
       <p:sp>
         <p:nvSpPr>
-          <p:cNvPr id="1922674716" name="Date Placeholder 3"/>
+          <p:cNvPr id="909717185" name="Date Placeholder 3"/>
           <p:cNvSpPr>
             <a:spLocks noGrp="1"/>
           </p:cNvSpPr>
@@ -1905,7 +1905,7 @@
       </p:sp>
       <p:sp>
         <p:nvSpPr>
-          <p:cNvPr id="6168686" name="Footer Placeholder 4"/>
+          <p:cNvPr id="495389213" name="Footer Placeholder 4"/>
           <p:cNvSpPr>
             <a:spLocks noGrp="1"/>
           </p:cNvSpPr>
@@ -1927,7 +1927,7 @@
       </p:sp>
       <p:sp>
         <p:nvSpPr>
-          <p:cNvPr id="573796764" name="Slide Number Placeholder 5"/>
+          <p:cNvPr id="1059998946" name="Slide Number Placeholder 5"/>
           <p:cNvSpPr>
             <a:spLocks noGrp="1"/>
           </p:cNvSpPr>
@@ -1978,7 +1978,7 @@
       </p:grpSpPr>
       <p:sp>
         <p:nvSpPr>
-          <p:cNvPr id="1466024901" name="Title 1"/>
+          <p:cNvPr id="206846374" name="Title 1"/>
           <p:cNvSpPr>
             <a:spLocks noGrp="1"/>
           </p:cNvSpPr>
@@ -2013,7 +2013,7 @@
       </p:sp>
       <p:sp>
         <p:nvSpPr>
-          <p:cNvPr id="260548410" name="Text Placeholder 2"/>
+          <p:cNvPr id="1137668182" name="Text Placeholder 2"/>
           <p:cNvSpPr>
             <a:spLocks noGrp="1"/>
           </p:cNvSpPr>
@@ -2135,7 +2135,7 @@
       </p:sp>
       <p:sp>
         <p:nvSpPr>
-          <p:cNvPr id="1770244518" name="Date Placeholder 3"/>
+          <p:cNvPr id="1955932077" name="Date Placeholder 3"/>
           <p:cNvSpPr>
             <a:spLocks noGrp="1"/>
           </p:cNvSpPr>
@@ -2161,7 +2161,7 @@
       </p:sp>
       <p:sp>
         <p:nvSpPr>
-          <p:cNvPr id="1574307512" name="Footer Placeholder 4"/>
+          <p:cNvPr id="731738306" name="Footer Placeholder 4"/>
           <p:cNvSpPr>
             <a:spLocks noGrp="1"/>
           </p:cNvSpPr>
@@ -2183,7 +2183,7 @@
       </p:sp>
       <p:sp>
         <p:nvSpPr>
-          <p:cNvPr id="2060878015" name="Slide Number Placeholder 5"/>
+          <p:cNvPr id="1577429622" name="Slide Number Placeholder 5"/>
           <p:cNvSpPr>
             <a:spLocks noGrp="1"/>
           </p:cNvSpPr>
@@ -2234,7 +2234,7 @@
       </p:grpSpPr>
       <p:sp>
         <p:nvSpPr>
-          <p:cNvPr id="2093691306" name="Title 1"/>
+          <p:cNvPr id="680069999" name="Title 1"/>
           <p:cNvSpPr>
             <a:spLocks noGrp="1"/>
           </p:cNvSpPr>
@@ -2260,7 +2260,7 @@
       </p:sp>
       <p:sp>
         <p:nvSpPr>
-          <p:cNvPr id="1483270219" name="Content Placeholder 2"/>
+          <p:cNvPr id="2124740732" name="Content Placeholder 2"/>
           <p:cNvSpPr>
             <a:spLocks noGrp="1"/>
           </p:cNvSpPr>
@@ -2331,7 +2331,7 @@
       </p:sp>
       <p:sp>
         <p:nvSpPr>
-          <p:cNvPr id="120732551" name="Content Placeholder 3"/>
+          <p:cNvPr id="366473122" name="Content Placeholder 3"/>
           <p:cNvSpPr>
             <a:spLocks noGrp="1"/>
           </p:cNvSpPr>
@@ -2402,7 +2402,7 @@
       </p:sp>
       <p:sp>
         <p:nvSpPr>
-          <p:cNvPr id="2024801627" name="Date Placeholder 4"/>
+          <p:cNvPr id="65238214" name="Date Placeholder 4"/>
           <p:cNvSpPr>
             <a:spLocks noGrp="1"/>
           </p:cNvSpPr>
@@ -2428,7 +2428,7 @@
       </p:sp>
       <p:sp>
         <p:nvSpPr>
-          <p:cNvPr id="1233432923" name="Footer Placeholder 5"/>
+          <p:cNvPr id="1153227936" name="Footer Placeholder 5"/>
           <p:cNvSpPr>
             <a:spLocks noGrp="1"/>
           </p:cNvSpPr>
@@ -2450,7 +2450,7 @@
       </p:sp>
       <p:sp>
         <p:nvSpPr>
-          <p:cNvPr id="1963392609" name="Slide Number Placeholder 6"/>
+          <p:cNvPr id="1868693952" name="Slide Number Placeholder 6"/>
           <p:cNvSpPr>
             <a:spLocks noGrp="1"/>
           </p:cNvSpPr>
@@ -2501,7 +2501,7 @@
       </p:grpSpPr>
       <p:sp>
         <p:nvSpPr>
-          <p:cNvPr id="1778443374" name="Title 1"/>
+          <p:cNvPr id="1547657831" name="Title 1"/>
           <p:cNvSpPr>
             <a:spLocks noGrp="1"/>
           </p:cNvSpPr>
@@ -2532,7 +2532,7 @@
       </p:sp>
       <p:sp>
         <p:nvSpPr>
-          <p:cNvPr id="1856366945" name="Text Placeholder 2"/>
+          <p:cNvPr id="860795314" name="Text Placeholder 2"/>
           <p:cNvSpPr>
             <a:spLocks noGrp="1"/>
           </p:cNvSpPr>
@@ -2600,7 +2600,7 @@
       </p:sp>
       <p:sp>
         <p:nvSpPr>
-          <p:cNvPr id="462190713" name="Content Placeholder 3"/>
+          <p:cNvPr id="1842731287" name="Content Placeholder 3"/>
           <p:cNvSpPr>
             <a:spLocks noGrp="1"/>
           </p:cNvSpPr>
@@ -2671,7 +2671,7 @@
       </p:sp>
       <p:sp>
         <p:nvSpPr>
-          <p:cNvPr id="1085133048" name="Text Placeholder 4"/>
+          <p:cNvPr id="1431362582" name="Text Placeholder 4"/>
           <p:cNvSpPr>
             <a:spLocks noGrp="1"/>
           </p:cNvSpPr>
@@ -2739,7 +2739,7 @@
       </p:sp>
       <p:sp>
         <p:nvSpPr>
-          <p:cNvPr id="504607825" name="Content Placeholder 5"/>
+          <p:cNvPr id="1339200891" name="Content Placeholder 5"/>
           <p:cNvSpPr>
             <a:spLocks noGrp="1"/>
           </p:cNvSpPr>
@@ -2810,7 +2810,7 @@
       </p:sp>
       <p:sp>
         <p:nvSpPr>
-          <p:cNvPr id="370196755" name="Date Placeholder 6"/>
+          <p:cNvPr id="1609483870" name="Date Placeholder 6"/>
           <p:cNvSpPr>
             <a:spLocks noGrp="1"/>
           </p:cNvSpPr>
@@ -2836,7 +2836,7 @@
       </p:sp>
       <p:sp>
         <p:nvSpPr>
-          <p:cNvPr id="1772327500" name="Footer Placeholder 7"/>
+          <p:cNvPr id="761653169" name="Footer Placeholder 7"/>
           <p:cNvSpPr>
             <a:spLocks noGrp="1"/>
           </p:cNvSpPr>
@@ -2858,7 +2858,7 @@
       </p:sp>
       <p:sp>
         <p:nvSpPr>
-          <p:cNvPr id="569050730" name="Slide Number Placeholder 8"/>
+          <p:cNvPr id="579208705" name="Slide Number Placeholder 8"/>
           <p:cNvSpPr>
             <a:spLocks noGrp="1"/>
           </p:cNvSpPr>
@@ -2909,7 +2909,7 @@
       </p:grpSpPr>
       <p:sp>
         <p:nvSpPr>
-          <p:cNvPr id="1650594478" name="Title 1"/>
+          <p:cNvPr id="214480095" name="Title 1"/>
           <p:cNvSpPr>
             <a:spLocks noGrp="1"/>
           </p:cNvSpPr>
@@ -2935,7 +2935,7 @@
       </p:sp>
       <p:sp>
         <p:nvSpPr>
-          <p:cNvPr id="1485666697" name="Date Placeholder 2"/>
+          <p:cNvPr id="1567444935" name="Date Placeholder 2"/>
           <p:cNvSpPr>
             <a:spLocks noGrp="1"/>
           </p:cNvSpPr>
@@ -2961,7 +2961,7 @@
       </p:sp>
       <p:sp>
         <p:nvSpPr>
-          <p:cNvPr id="625886140" name="Footer Placeholder 3"/>
+          <p:cNvPr id="533032302" name="Footer Placeholder 3"/>
           <p:cNvSpPr>
             <a:spLocks noGrp="1"/>
           </p:cNvSpPr>
@@ -2983,7 +2983,7 @@
       </p:sp>
       <p:sp>
         <p:nvSpPr>
-          <p:cNvPr id="1260366938" name="Slide Number Placeholder 4"/>
+          <p:cNvPr id="1702040959" name="Slide Number Placeholder 4"/>
           <p:cNvSpPr>
             <a:spLocks noGrp="1"/>
           </p:cNvSpPr>
@@ -3034,7 +3034,7 @@
       </p:grpSpPr>
       <p:sp>
         <p:nvSpPr>
-          <p:cNvPr id="690676353" name="Date Placeholder 1"/>
+          <p:cNvPr id="1471129564" name="Date Placeholder 1"/>
           <p:cNvSpPr>
             <a:spLocks noGrp="1"/>
           </p:cNvSpPr>
@@ -3060,7 +3060,7 @@
       </p:sp>
       <p:sp>
         <p:nvSpPr>
-          <p:cNvPr id="2041702" name="Footer Placeholder 2"/>
+          <p:cNvPr id="627606833" name="Footer Placeholder 2"/>
           <p:cNvSpPr>
             <a:spLocks noGrp="1"/>
           </p:cNvSpPr>
@@ -3082,7 +3082,7 @@
       </p:sp>
       <p:sp>
         <p:nvSpPr>
-          <p:cNvPr id="1593459548" name="Slide Number Placeholder 3"/>
+          <p:cNvPr id="111488741" name="Slide Number Placeholder 3"/>
           <p:cNvSpPr>
             <a:spLocks noGrp="1"/>
           </p:cNvSpPr>
@@ -3133,7 +3133,7 @@
       </p:grpSpPr>
       <p:sp>
         <p:nvSpPr>
-          <p:cNvPr id="1692859874" name="Title 1"/>
+          <p:cNvPr id="772061835" name="Title 1"/>
           <p:cNvSpPr>
             <a:spLocks noGrp="1"/>
           </p:cNvSpPr>
@@ -3168,7 +3168,7 @@
       </p:sp>
       <p:sp>
         <p:nvSpPr>
-          <p:cNvPr id="2006447122" name="Content Placeholder 2"/>
+          <p:cNvPr id="1543069745" name="Content Placeholder 2"/>
           <p:cNvSpPr>
             <a:spLocks noGrp="1"/>
           </p:cNvSpPr>
@@ -3267,7 +3267,7 @@
       </p:sp>
       <p:sp>
         <p:nvSpPr>
-          <p:cNvPr id="61712521" name="Text Placeholder 3"/>
+          <p:cNvPr id="963773576" name="Text Placeholder 3"/>
           <p:cNvSpPr>
             <a:spLocks noGrp="1"/>
           </p:cNvSpPr>
@@ -3335,7 +3335,7 @@
       </p:sp>
       <p:sp>
         <p:nvSpPr>
-          <p:cNvPr id="1844524074" name="Date Placeholder 4"/>
+          <p:cNvPr id="1078189215" name="Date Placeholder 4"/>
           <p:cNvSpPr>
             <a:spLocks noGrp="1"/>
           </p:cNvSpPr>
@@ -3361,7 +3361,7 @@
       </p:sp>
       <p:sp>
         <p:nvSpPr>
-          <p:cNvPr id="737329743" name="Footer Placeholder 5"/>
+          <p:cNvPr id="2010806855" name="Footer Placeholder 5"/>
           <p:cNvSpPr>
             <a:spLocks noGrp="1"/>
           </p:cNvSpPr>
@@ -3383,7 +3383,7 @@
       </p:sp>
       <p:sp>
         <p:nvSpPr>
-          <p:cNvPr id="542162120" name="Slide Number Placeholder 6"/>
+          <p:cNvPr id="685977144" name="Slide Number Placeholder 6"/>
           <p:cNvSpPr>
             <a:spLocks noGrp="1"/>
           </p:cNvSpPr>
@@ -3434,7 +3434,7 @@
       </p:grpSpPr>
       <p:sp>
         <p:nvSpPr>
-          <p:cNvPr id="679457396" name="Title 1"/>
+          <p:cNvPr id="981644808" name="Title 1"/>
           <p:cNvSpPr>
             <a:spLocks noGrp="1"/>
           </p:cNvSpPr>
@@ -3469,7 +3469,7 @@
       </p:sp>
       <p:sp>
         <p:nvSpPr>
-          <p:cNvPr id="348135175" name="Picture Placeholder 2"/>
+          <p:cNvPr id="1870610631" name="Picture Placeholder 2"/>
           <p:cNvSpPr>
             <a:spLocks noChangeAspect="1" noGrp="1"/>
           </p:cNvSpPr>
@@ -3537,7 +3537,7 @@
       </p:sp>
       <p:sp>
         <p:nvSpPr>
-          <p:cNvPr id="1582843658" name="Text Placeholder 3"/>
+          <p:cNvPr id="1562816194" name="Text Placeholder 3"/>
           <p:cNvSpPr>
             <a:spLocks noGrp="1"/>
           </p:cNvSpPr>
@@ -3605,7 +3605,7 @@
       </p:sp>
       <p:sp>
         <p:nvSpPr>
-          <p:cNvPr id="1895691344" name="Date Placeholder 4"/>
+          <p:cNvPr id="903867769" name="Date Placeholder 4"/>
           <p:cNvSpPr>
             <a:spLocks noGrp="1"/>
           </p:cNvSpPr>
@@ -3631,7 +3631,7 @@
       </p:sp>
       <p:sp>
         <p:nvSpPr>
-          <p:cNvPr id="1675065704" name="Footer Placeholder 5"/>
+          <p:cNvPr id="1731985672" name="Footer Placeholder 5"/>
           <p:cNvSpPr>
             <a:spLocks noGrp="1"/>
           </p:cNvSpPr>
@@ -3653,7 +3653,7 @@
       </p:sp>
       <p:sp>
         <p:nvSpPr>
-          <p:cNvPr id="1280744560" name="Slide Number Placeholder 6"/>
+          <p:cNvPr id="1701356582" name="Slide Number Placeholder 6"/>
           <p:cNvSpPr>
             <a:spLocks noGrp="1"/>
           </p:cNvSpPr>
@@ -3722,7 +3722,7 @@
       </p:grpSpPr>
       <p:sp>
         <p:nvSpPr>
-          <p:cNvPr id="902254012" name="Title Placeholder 1"/>
+          <p:cNvPr id="272192316" name="Title Placeholder 1"/>
           <p:cNvSpPr>
             <a:spLocks noGrp="1"/>
           </p:cNvSpPr>
@@ -3758,7 +3758,7 @@
       </p:sp>
       <p:sp>
         <p:nvSpPr>
-          <p:cNvPr id="306298921" name="Text Placeholder 2"/>
+          <p:cNvPr id="1521658808" name="Text Placeholder 2"/>
           <p:cNvSpPr>
             <a:spLocks noGrp="1"/>
           </p:cNvSpPr>
@@ -3834,7 +3834,7 @@
       </p:sp>
       <p:sp>
         <p:nvSpPr>
-          <p:cNvPr id="1780762400" name="Date Placeholder 3"/>
+          <p:cNvPr id="643699284" name="Date Placeholder 3"/>
           <p:cNvSpPr>
             <a:spLocks noGrp="1"/>
           </p:cNvSpPr>
@@ -3878,7 +3878,7 @@
       </p:sp>
       <p:sp>
         <p:nvSpPr>
-          <p:cNvPr id="51327816" name="Footer Placeholder 4"/>
+          <p:cNvPr id="253169529" name="Footer Placeholder 4"/>
           <p:cNvSpPr>
             <a:spLocks noGrp="1"/>
           </p:cNvSpPr>
@@ -3918,7 +3918,7 @@
       </p:sp>
       <p:sp>
         <p:nvSpPr>
-          <p:cNvPr id="98902238" name="Slide Number Placeholder 5"/>
+          <p:cNvPr id="1593000628" name="Slide Number Placeholder 5"/>
           <p:cNvSpPr>
             <a:spLocks noGrp="1"/>
           </p:cNvSpPr>
@@ -4278,7 +4278,7 @@
       </p:grpSpPr>
       <p:sp>
         <p:nvSpPr>
-          <p:cNvPr id="1576256533" name="Title 1"/>
+          <p:cNvPr id="1350257453" name="Title 1"/>
           <p:cNvSpPr>
             <a:spLocks noGrp="1"/>
           </p:cNvSpPr>
@@ -4324,7 +4324,7 @@
       </p:sp>
       <p:sp>
         <p:nvSpPr>
-          <p:cNvPr id="87581731" name="Subtitle 2"/>
+          <p:cNvPr id="230600976" name="Subtitle 2"/>
           <p:cNvSpPr>
             <a:spLocks noGrp="1"/>
           </p:cNvSpPr>
@@ -4390,7 +4390,7 @@
       </p:sp>
       <p:pic>
         <p:nvPicPr>
-          <p:cNvPr id="1352519171" name=""/>
+          <p:cNvPr id="381501490" name=""/>
           <p:cNvPicPr>
             <a:picLocks noChangeAspect="1"/>
           </p:cNvPicPr>
@@ -4398,12 +4398,11 @@
         </p:nvPicPr>
         <p:blipFill rotWithShape="1">
           <a:blip r:embed="rId3"/>
-          <a:stretch/>
         </p:blipFill>
         <p:spPr bwMode="auto">
           <a:xfrm flipH="0" flipV="0">
-            <a:off x="193591" y="1943520"/>
-            <a:ext cx="4298816" cy="1485479"/>
+            <a:off x="939105" y="2418125"/>
+            <a:ext cx="2807790" cy="929078"/>
           </a:xfrm>
           <a:prstGeom prst="rect">
             <a:avLst/>
@@ -4412,7 +4411,7 @@
       </p:pic>
       <p:sp>
         <p:nvSpPr>
-          <p:cNvPr id="97090709" name="Slide Number Placeholder 5"/>
+          <p:cNvPr id="2052486827" name="Slide Number Placeholder 5"/>
           <p:cNvSpPr>
             <a:spLocks noGrp="1"/>
           </p:cNvSpPr>
@@ -4438,7 +4437,7 @@
       </p:sp>
       <p:sp>
         <p:nvSpPr>
-          <p:cNvPr id="1800736473" name=""/>
+          <p:cNvPr id="793044142" name=""/>
           <p:cNvSpPr/>
           <p:nvPr/>
         </p:nvSpPr>
@@ -4480,7 +4479,7 @@
       </p:sp>
       <p:sp>
         <p:nvSpPr>
-          <p:cNvPr id="1947743035" name=""/>
+          <p:cNvPr id="175057464" name=""/>
           <p:cNvSpPr/>
           <p:nvPr/>
         </p:nvSpPr>
@@ -4522,7 +4521,7 @@
       </p:sp>
       <p:sp>
         <p:nvSpPr>
-          <p:cNvPr id="1744844491" name=""/>
+          <p:cNvPr id="110487083" name=""/>
           <p:cNvSpPr/>
           <p:nvPr/>
         </p:nvSpPr>
@@ -4564,7 +4563,7 @@
       </p:sp>
       <p:sp>
         <p:nvSpPr>
-          <p:cNvPr id="1374364718" name=""/>
+          <p:cNvPr id="1099273620" name=""/>
           <p:cNvSpPr/>
           <p:nvPr/>
         </p:nvSpPr>
@@ -4606,7 +4605,7 @@
       </p:sp>
       <p:sp>
         <p:nvSpPr>
-          <p:cNvPr id="262861921" name="Rectangle 9"/>
+          <p:cNvPr id="2048009938" name="Rectangle 9"/>
           <p:cNvSpPr txBox="1"/>
           <p:nvPr/>
         </p:nvSpPr>
@@ -4634,7 +4633,7 @@
       </p:sp>
       <p:sp>
         <p:nvSpPr>
-          <p:cNvPr id="1375867328" name="Rectangle 10"/>
+          <p:cNvPr id="1445288708" name="Rectangle 10"/>
           <p:cNvSpPr txBox="1"/>
           <p:nvPr/>
         </p:nvSpPr>
@@ -4680,7 +4679,7 @@
       </p:sp>
       <p:sp>
         <p:nvSpPr>
-          <p:cNvPr id="898444448" name="Rectangle 11"/>
+          <p:cNvPr id="267150870" name="Rectangle 11"/>
           <p:cNvSpPr txBox="1"/>
           <p:nvPr/>
         </p:nvSpPr>
@@ -4726,7 +4725,7 @@
       </p:sp>
       <p:sp>
         <p:nvSpPr>
-          <p:cNvPr id="1817655228" name="Rectangle 12"/>
+          <p:cNvPr id="43044299" name="Rectangle 12"/>
           <p:cNvSpPr txBox="1"/>
           <p:nvPr/>
         </p:nvSpPr>
@@ -4775,7 +4774,7 @@
       </p:sp>
       <p:sp>
         <p:nvSpPr>
-          <p:cNvPr id="302627632" name="Rectangle 13"/>
+          <p:cNvPr id="156969880" name="Rectangle 13"/>
           <p:cNvSpPr txBox="1"/>
           <p:nvPr/>
         </p:nvSpPr>
@@ -4824,7 +4823,7 @@
       </p:sp>
       <p:sp>
         <p:nvSpPr>
-          <p:cNvPr id="1125981474" name="Flowchart: Alternate process 14"/>
+          <p:cNvPr id="777839610" name="Flowchart: Alternate process 14"/>
           <p:cNvSpPr/>
           <p:nvPr/>
         </p:nvSpPr>
@@ -4933,13 +4932,117 @@
       </p:sp>
       <p:sp>
         <p:nvSpPr>
-          <p:cNvPr id="225819872" name="Flowchart: Alternate process 14"/>
+          <p:cNvPr id="1509471531" name="Flowchart: Alternate process 14"/>
           <p:cNvSpPr/>
           <p:nvPr/>
         </p:nvSpPr>
         <p:spPr bwMode="auto">
           <a:xfrm rot="16199998" flipH="0" flipV="0">
-            <a:off x="4834764" y="2452538"/>
+            <a:off x="4836777" y="2454551"/>
+            <a:ext cx="1124988" cy="656759"/>
+          </a:xfrm>
+          <a:custGeom>
+            <a:avLst>
+              <a:gd name="adj1" fmla="val 16667"/>
+              <a:gd name="adj2" fmla="val 0"/>
+            </a:avLst>
+            <a:gdLst/>
+            <a:ahLst/>
+            <a:cxnLst/>
+            <a:rect l="0" t="0" r="r" b="b"/>
+            <a:pathLst>
+              <a:path w="43200" h="43200" fill="norm" stroke="1" extrusionOk="0">
+                <a:moveTo>
+                  <a:pt x="8020" y="125"/>
+                </a:moveTo>
+                <a:cubicBezTo>
+                  <a:pt x="17916" y="149"/>
+                  <a:pt x="23926" y="441"/>
+                  <a:pt x="36137" y="125"/>
+                </a:cubicBezTo>
+                <a:cubicBezTo>
+                  <a:pt x="40012" y="54"/>
+                  <a:pt x="42994" y="6516"/>
+                  <a:pt x="43167" y="11773"/>
+                </a:cubicBezTo>
+                <a:cubicBezTo>
+                  <a:pt x="43246" y="22503"/>
+                  <a:pt x="43164" y="33018"/>
+                  <a:pt x="43077" y="43200"/>
+                </a:cubicBezTo>
+                <a:lnTo>
+                  <a:pt x="0" y="43200"/>
+                </a:lnTo>
+                <a:lnTo>
+                  <a:pt x="132" y="9898"/>
+                </a:lnTo>
+                <a:cubicBezTo>
+                  <a:pt x="410" y="5021"/>
+                  <a:pt x="4194" y="-378"/>
+                  <a:pt x="8020" y="125"/>
+                </a:cubicBezTo>
+                <a:close/>
+              </a:path>
+            </a:pathLst>
+          </a:custGeom>
+          <a:gradFill>
+            <a:gsLst>
+              <a:gs pos="0">
+                <a:srgbClr val="9551F3">
+                  <a:alpha val="99999"/>
+                </a:srgbClr>
+              </a:gs>
+              <a:gs pos="100000">
+                <a:srgbClr val="002060">
+                  <a:alpha val="99999"/>
+                </a:srgbClr>
+              </a:gs>
+            </a:gsLst>
+            <a:lin ang="2700000" scaled="1"/>
+          </a:gradFill>
+          <a:ln w="6350" cap="flat" cmpd="sng" algn="ctr">
+            <a:solidFill>
+              <a:srgbClr val="0F0F1B"/>
+            </a:solidFill>
+            <a:prstDash val="solid"/>
+            <a:miter lim="800000"/>
+          </a:ln>
+        </p:spPr>
+        <p:style>
+          <a:lnRef idx="2">
+            <a:schemeClr val="accent1">
+              <a:shade val="50000"/>
+            </a:schemeClr>
+          </a:lnRef>
+          <a:fillRef idx="1">
+            <a:schemeClr val="accent1"/>
+          </a:fillRef>
+          <a:effectRef idx="0">
+            <a:schemeClr val="accent1"/>
+          </a:effectRef>
+          <a:fontRef idx="minor">
+            <a:schemeClr val="lt1"/>
+          </a:fontRef>
+        </p:style>
+        <p:txBody>
+          <a:bodyPr anchor="ctr"/>
+          <a:p>
+            <a:pPr algn="ctr">
+              <a:defRPr/>
+            </a:pPr>
+            <a:endParaRPr/>
+          </a:p>
+        </p:txBody>
+      </p:sp>
+      <p:sp>
+        <p:nvSpPr>
+          <p:cNvPr id="453948995" name="Flowchart: Alternate process 14"/>
+          <p:cNvSpPr/>
+          <p:nvPr/>
+        </p:nvSpPr>
+        <p:spPr bwMode="auto">
+          <a:xfrm rot="16199998" flipH="0" flipV="0">
+            <a:off x="4831345" y="3966364"/>
             <a:ext cx="1129015" cy="656760"/>
           </a:xfrm>
           <a:custGeom>
@@ -5037,111 +5140,7 @@
       </p:sp>
       <p:sp>
         <p:nvSpPr>
-          <p:cNvPr id="1228369645" name="Flowchart: Alternate process 14"/>
-          <p:cNvSpPr/>
-          <p:nvPr/>
-        </p:nvSpPr>
-        <p:spPr bwMode="auto">
-          <a:xfrm rot="16199998" flipH="0" flipV="0">
-            <a:off x="4831345" y="3966364"/>
-            <a:ext cx="1129015" cy="656760"/>
-          </a:xfrm>
-          <a:custGeom>
-            <a:avLst>
-              <a:gd name="adj1" fmla="val 16667"/>
-              <a:gd name="adj2" fmla="val 0"/>
-            </a:avLst>
-            <a:gdLst/>
-            <a:ahLst/>
-            <a:cxnLst/>
-            <a:rect l="0" t="0" r="r" b="b"/>
-            <a:pathLst>
-              <a:path w="43200" h="43200" fill="norm" stroke="1" extrusionOk="0">
-                <a:moveTo>
-                  <a:pt x="7992" y="126"/>
-                </a:moveTo>
-                <a:cubicBezTo>
-                  <a:pt x="17853" y="149"/>
-                  <a:pt x="23841" y="441"/>
-                  <a:pt x="36009" y="126"/>
-                </a:cubicBezTo>
-                <a:cubicBezTo>
-                  <a:pt x="39870" y="54"/>
-                  <a:pt x="43012" y="7398"/>
-                  <a:pt x="43184" y="12655"/>
-                </a:cubicBezTo>
-                <a:cubicBezTo>
-                  <a:pt x="43263" y="23385"/>
-                  <a:pt x="43011" y="33018"/>
-                  <a:pt x="42924" y="43200"/>
-                </a:cubicBezTo>
-                <a:lnTo>
-                  <a:pt x="0" y="43200"/>
-                </a:lnTo>
-                <a:lnTo>
-                  <a:pt x="132" y="9899"/>
-                </a:lnTo>
-                <a:cubicBezTo>
-                  <a:pt x="409" y="5022"/>
-                  <a:pt x="4180" y="-378"/>
-                  <a:pt x="7992" y="126"/>
-                </a:cubicBezTo>
-                <a:close/>
-              </a:path>
-            </a:pathLst>
-          </a:custGeom>
-          <a:gradFill>
-            <a:gsLst>
-              <a:gs pos="0">
-                <a:srgbClr val="9551F3">
-                  <a:alpha val="99999"/>
-                </a:srgbClr>
-              </a:gs>
-              <a:gs pos="100000">
-                <a:srgbClr val="002060">
-                  <a:alpha val="99999"/>
-                </a:srgbClr>
-              </a:gs>
-            </a:gsLst>
-            <a:lin ang="2700000" scaled="1"/>
-          </a:gradFill>
-          <a:ln w="6350" cap="flat" cmpd="sng" algn="ctr">
-            <a:solidFill>
-              <a:srgbClr val="0F0F1B"/>
-            </a:solidFill>
-            <a:prstDash val="solid"/>
-            <a:miter lim="800000"/>
-          </a:ln>
-        </p:spPr>
-        <p:style>
-          <a:lnRef idx="2">
-            <a:schemeClr val="accent1">
-              <a:shade val="50000"/>
-            </a:schemeClr>
-          </a:lnRef>
-          <a:fillRef idx="1">
-            <a:schemeClr val="accent1"/>
-          </a:fillRef>
-          <a:effectRef idx="0">
-            <a:schemeClr val="accent1"/>
-          </a:effectRef>
-          <a:fontRef idx="minor">
-            <a:schemeClr val="lt1"/>
-          </a:fontRef>
-        </p:style>
-        <p:txBody>
-          <a:bodyPr anchor="ctr"/>
-          <a:p>
-            <a:pPr algn="ctr">
-              <a:defRPr/>
-            </a:pPr>
-            <a:endParaRPr/>
-          </a:p>
-        </p:txBody>
-      </p:sp>
-      <p:sp>
-        <p:nvSpPr>
-          <p:cNvPr id="1057576104" name="Flowchart: Alternate process 14"/>
+          <p:cNvPr id="247239005" name="Flowchart: Alternate process 14"/>
           <p:cNvSpPr/>
           <p:nvPr/>
         </p:nvSpPr>
@@ -5248,7 +5247,7 @@
       </p:sp>
       <p:sp>
         <p:nvSpPr>
-          <p:cNvPr id="1034481654" name="Rectangle 18"/>
+          <p:cNvPr id="1524493848" name="Rectangle 18"/>
           <p:cNvSpPr txBox="1"/>
           <p:nvPr/>
         </p:nvSpPr>
@@ -5293,7 +5292,7 @@
       </p:sp>
       <p:sp>
         <p:nvSpPr>
-          <p:cNvPr id="114382343" name="Rectangle 19"/>
+          <p:cNvPr id="712844017" name="Rectangle 19"/>
           <p:cNvSpPr txBox="1"/>
           <p:nvPr/>
         </p:nvSpPr>
@@ -5338,7 +5337,7 @@
       </p:sp>
       <p:sp>
         <p:nvSpPr>
-          <p:cNvPr id="411818749" name="Rectangle 20"/>
+          <p:cNvPr id="377040753" name="Rectangle 20"/>
           <p:cNvSpPr txBox="1"/>
           <p:nvPr/>
         </p:nvSpPr>
@@ -5386,7 +5385,7 @@
       </p:sp>
       <p:sp>
         <p:nvSpPr>
-          <p:cNvPr id="735781963" name="Rectangle 21"/>
+          <p:cNvPr id="150966268" name="Rectangle 21"/>
           <p:cNvSpPr txBox="1"/>
           <p:nvPr/>
         </p:nvSpPr>
@@ -5481,7 +5480,7 @@
                                           </p:stCondLst>
                                         </p:cTn>
                                         <p:tgtEl>
-                                          <p:spTgt spid="1800736473"/>
+                                          <p:spTgt spid="793044142"/>
                                         </p:tgtEl>
                                         <p:attrNameLst>
                                           <p:attrName>style.visibility</p:attrName>
@@ -5495,7 +5494,7 @@
                                       <p:cBhvr>
                                         <p:cTn id="54" dur="500"/>
                                         <p:tgtEl>
-                                          <p:spTgt spid="1800736473"/>
+                                          <p:spTgt spid="793044142"/>
                                         </p:tgtEl>
                                       </p:cBhvr>
                                     </p:animEffect>
@@ -5516,7 +5515,7 @@
                                           </p:stCondLst>
                                         </p:cTn>
                                         <p:tgtEl>
-                                          <p:spTgt spid="1947743035"/>
+                                          <p:spTgt spid="175057464"/>
                                         </p:tgtEl>
                                         <p:attrNameLst>
                                           <p:attrName>style.visibility</p:attrName>
@@ -5530,7 +5529,7 @@
                                       <p:cBhvr>
                                         <p:cTn id="51" dur="500"/>
                                         <p:tgtEl>
-                                          <p:spTgt spid="1947743035"/>
+                                          <p:spTgt spid="175057464"/>
                                         </p:tgtEl>
                                       </p:cBhvr>
                                     </p:animEffect>
@@ -5551,7 +5550,7 @@
                                           </p:stCondLst>
                                         </p:cTn>
                                         <p:tgtEl>
-                                          <p:spTgt spid="1744844491"/>
+                                          <p:spTgt spid="110487083"/>
                                         </p:tgtEl>
                                         <p:attrNameLst>
                                           <p:attrName>style.visibility</p:attrName>
@@ -5565,7 +5564,7 @@
                                       <p:cBhvr>
                                         <p:cTn id="48" dur="500"/>
                                         <p:tgtEl>
-                                          <p:spTgt spid="1744844491"/>
+                                          <p:spTgt spid="110487083"/>
                                         </p:tgtEl>
                                       </p:cBhvr>
                                     </p:animEffect>
@@ -5586,7 +5585,7 @@
                                           </p:stCondLst>
                                         </p:cTn>
                                         <p:tgtEl>
-                                          <p:spTgt spid="1374364718"/>
+                                          <p:spTgt spid="1099273620"/>
                                         </p:tgtEl>
                                         <p:attrNameLst>
                                           <p:attrName>style.visibility</p:attrName>
@@ -5600,7 +5599,7 @@
                                       <p:cBhvr>
                                         <p:cTn id="45" dur="500"/>
                                         <p:tgtEl>
-                                          <p:spTgt spid="1374364718"/>
+                                          <p:spTgt spid="1099273620"/>
                                         </p:tgtEl>
                                       </p:cBhvr>
                                     </p:animEffect>
@@ -5621,7 +5620,7 @@
                                           </p:stCondLst>
                                         </p:cTn>
                                         <p:tgtEl>
-                                          <p:spTgt spid="262861921"/>
+                                          <p:spTgt spid="2048009938"/>
                                         </p:tgtEl>
                                         <p:attrNameLst>
                                           <p:attrName>style.visibility</p:attrName>
@@ -5635,7 +5634,7 @@
                                       <p:cBhvr>
                                         <p:cTn id="42" dur="500"/>
                                         <p:tgtEl>
-                                          <p:spTgt spid="262861921"/>
+                                          <p:spTgt spid="2048009938"/>
                                         </p:tgtEl>
                                       </p:cBhvr>
                                     </p:animEffect>
@@ -5656,7 +5655,7 @@
                                           </p:stCondLst>
                                         </p:cTn>
                                         <p:tgtEl>
-                                          <p:spTgt spid="1375867328"/>
+                                          <p:spTgt spid="1445288708"/>
                                         </p:tgtEl>
                                         <p:attrNameLst>
                                           <p:attrName>style.visibility</p:attrName>
@@ -5670,7 +5669,7 @@
                                       <p:cBhvr>
                                         <p:cTn id="39" dur="500"/>
                                         <p:tgtEl>
-                                          <p:spTgt spid="1375867328"/>
+                                          <p:spTgt spid="1445288708"/>
                                         </p:tgtEl>
                                       </p:cBhvr>
                                     </p:animEffect>
@@ -5691,7 +5690,7 @@
                                           </p:stCondLst>
                                         </p:cTn>
                                         <p:tgtEl>
-                                          <p:spTgt spid="898444448"/>
+                                          <p:spTgt spid="267150870"/>
                                         </p:tgtEl>
                                         <p:attrNameLst>
                                           <p:attrName>style.visibility</p:attrName>
@@ -5705,7 +5704,7 @@
                                       <p:cBhvr>
                                         <p:cTn id="36" dur="500"/>
                                         <p:tgtEl>
-                                          <p:spTgt spid="898444448"/>
+                                          <p:spTgt spid="267150870"/>
                                         </p:tgtEl>
                                       </p:cBhvr>
                                     </p:animEffect>
@@ -5726,7 +5725,7 @@
                                           </p:stCondLst>
                                         </p:cTn>
                                         <p:tgtEl>
-                                          <p:spTgt spid="1817655228"/>
+                                          <p:spTgt spid="43044299"/>
                                         </p:tgtEl>
                                         <p:attrNameLst>
                                           <p:attrName>style.visibility</p:attrName>
@@ -5740,7 +5739,7 @@
                                       <p:cBhvr>
                                         <p:cTn id="33" dur="500"/>
                                         <p:tgtEl>
-                                          <p:spTgt spid="1817655228"/>
+                                          <p:spTgt spid="43044299"/>
                                         </p:tgtEl>
                                       </p:cBhvr>
                                     </p:animEffect>
@@ -5761,7 +5760,7 @@
                                           </p:stCondLst>
                                         </p:cTn>
                                         <p:tgtEl>
-                                          <p:spTgt spid="302627632"/>
+                                          <p:spTgt spid="156969880"/>
                                         </p:tgtEl>
                                         <p:attrNameLst>
                                           <p:attrName>style.visibility</p:attrName>
@@ -5775,7 +5774,7 @@
                                       <p:cBhvr>
                                         <p:cTn id="30" dur="500"/>
                                         <p:tgtEl>
-                                          <p:spTgt spid="302627632"/>
+                                          <p:spTgt spid="156969880"/>
                                         </p:tgtEl>
                                       </p:cBhvr>
                                     </p:animEffect>
@@ -5796,7 +5795,7 @@
                                           </p:stCondLst>
                                         </p:cTn>
                                         <p:tgtEl>
-                                          <p:spTgt spid="1125981474"/>
+                                          <p:spTgt spid="777839610"/>
                                         </p:tgtEl>
                                         <p:attrNameLst>
                                           <p:attrName>style.visibility</p:attrName>
@@ -5810,7 +5809,7 @@
                                       <p:cBhvr>
                                         <p:cTn id="27" dur="500"/>
                                         <p:tgtEl>
-                                          <p:spTgt spid="1125981474"/>
+                                          <p:spTgt spid="777839610"/>
                                         </p:tgtEl>
                                       </p:cBhvr>
                                     </p:animEffect>
@@ -5831,7 +5830,7 @@
                                           </p:stCondLst>
                                         </p:cTn>
                                         <p:tgtEl>
-                                          <p:spTgt spid="225819872"/>
+                                          <p:spTgt spid="1509471531"/>
                                         </p:tgtEl>
                                         <p:attrNameLst>
                                           <p:attrName>style.visibility</p:attrName>
@@ -5845,7 +5844,7 @@
                                       <p:cBhvr>
                                         <p:cTn id="24" dur="500"/>
                                         <p:tgtEl>
-                                          <p:spTgt spid="225819872"/>
+                                          <p:spTgt spid="1509471531"/>
                                         </p:tgtEl>
                                       </p:cBhvr>
                                     </p:animEffect>
@@ -5866,7 +5865,7 @@
                                           </p:stCondLst>
                                         </p:cTn>
                                         <p:tgtEl>
-                                          <p:spTgt spid="1228369645"/>
+                                          <p:spTgt spid="453948995"/>
                                         </p:tgtEl>
                                         <p:attrNameLst>
                                           <p:attrName>style.visibility</p:attrName>
@@ -5880,7 +5879,7 @@
                                       <p:cBhvr>
                                         <p:cTn id="21" dur="500"/>
                                         <p:tgtEl>
-                                          <p:spTgt spid="1228369645"/>
+                                          <p:spTgt spid="453948995"/>
                                         </p:tgtEl>
                                       </p:cBhvr>
                                     </p:animEffect>
@@ -5901,7 +5900,7 @@
                                           </p:stCondLst>
                                         </p:cTn>
                                         <p:tgtEl>
-                                          <p:spTgt spid="1057576104"/>
+                                          <p:spTgt spid="247239005"/>
                                         </p:tgtEl>
                                         <p:attrNameLst>
                                           <p:attrName>style.visibility</p:attrName>
@@ -5915,7 +5914,7 @@
                                       <p:cBhvr>
                                         <p:cTn id="18" dur="500"/>
                                         <p:tgtEl>
-                                          <p:spTgt spid="1057576104"/>
+                                          <p:spTgt spid="247239005"/>
                                         </p:tgtEl>
                                       </p:cBhvr>
                                     </p:animEffect>
@@ -5936,7 +5935,7 @@
                                           </p:stCondLst>
                                         </p:cTn>
                                         <p:tgtEl>
-                                          <p:spTgt spid="1034481654"/>
+                                          <p:spTgt spid="1524493848"/>
                                         </p:tgtEl>
                                         <p:attrNameLst>
                                           <p:attrName>style.visibility</p:attrName>
@@ -5950,7 +5949,7 @@
                                       <p:cBhvr>
                                         <p:cTn id="15" dur="500"/>
                                         <p:tgtEl>
-                                          <p:spTgt spid="1034481654"/>
+                                          <p:spTgt spid="1524493848"/>
                                         </p:tgtEl>
                                       </p:cBhvr>
                                     </p:animEffect>
@@ -5971,7 +5970,7 @@
                                           </p:stCondLst>
                                         </p:cTn>
                                         <p:tgtEl>
-                                          <p:spTgt spid="114382343"/>
+                                          <p:spTgt spid="712844017"/>
                                         </p:tgtEl>
                                         <p:attrNameLst>
                                           <p:attrName>style.visibility</p:attrName>
@@ -5985,7 +5984,7 @@
                                       <p:cBhvr>
                                         <p:cTn id="12" dur="500"/>
                                         <p:tgtEl>
-                                          <p:spTgt spid="114382343"/>
+                                          <p:spTgt spid="712844017"/>
                                         </p:tgtEl>
                                       </p:cBhvr>
                                     </p:animEffect>
@@ -6006,7 +6005,7 @@
                                           </p:stCondLst>
                                         </p:cTn>
                                         <p:tgtEl>
-                                          <p:spTgt spid="411818749"/>
+                                          <p:spTgt spid="377040753"/>
                                         </p:tgtEl>
                                         <p:attrNameLst>
                                           <p:attrName>style.visibility</p:attrName>
@@ -6020,7 +6019,7 @@
                                       <p:cBhvr>
                                         <p:cTn id="9" dur="500"/>
                                         <p:tgtEl>
-                                          <p:spTgt spid="411818749"/>
+                                          <p:spTgt spid="377040753"/>
                                         </p:tgtEl>
                                       </p:cBhvr>
                                     </p:animEffect>
@@ -6041,7 +6040,7 @@
                                           </p:stCondLst>
                                         </p:cTn>
                                         <p:tgtEl>
-                                          <p:spTgt spid="735781963"/>
+                                          <p:spTgt spid="150966268"/>
                                         </p:tgtEl>
                                         <p:attrNameLst>
                                           <p:attrName>style.visibility</p:attrName>
@@ -6055,7 +6054,7 @@
                                       <p:cBhvr>
                                         <p:cTn id="6" dur="500"/>
                                         <p:tgtEl>
-                                          <p:spTgt spid="735781963"/>
+                                          <p:spTgt spid="150966268"/>
                                         </p:tgtEl>
                                       </p:cBhvr>
                                     </p:animEffect>
@@ -6112,7 +6111,7 @@
       </p:grpSpPr>
       <p:sp>
         <p:nvSpPr>
-          <p:cNvPr id="864315419" name="Title 1"/>
+          <p:cNvPr id="974065918" name="Title 1"/>
           <p:cNvSpPr>
             <a:spLocks noGrp="1"/>
           </p:cNvSpPr>
@@ -6164,7 +6163,7 @@
       </p:sp>
       <p:grpSp>
         <p:nvGrpSpPr>
-          <p:cNvPr id="2089966841" name="Group 62"/>
+          <p:cNvPr id="1488159787" name="Group 62"/>
           <p:cNvGrpSpPr/>
           <p:nvPr/>
         </p:nvGrpSpPr>
@@ -6330,7 +6329,7 @@
       </p:grpSp>
       <p:grpSp>
         <p:nvGrpSpPr>
-          <p:cNvPr id="1427821688" name="Group 64"/>
+          <p:cNvPr id="472208932" name="Group 64"/>
           <p:cNvGrpSpPr/>
           <p:nvPr/>
         </p:nvGrpSpPr>
@@ -6496,7 +6495,7 @@
       </p:grpSp>
       <p:grpSp>
         <p:nvGrpSpPr>
-          <p:cNvPr id="1999753003" name="Group 66"/>
+          <p:cNvPr id="1927465817" name="Group 66"/>
           <p:cNvGrpSpPr/>
           <p:nvPr/>
         </p:nvGrpSpPr>
@@ -6662,7 +6661,7 @@
       </p:grpSp>
       <p:grpSp>
         <p:nvGrpSpPr>
-          <p:cNvPr id="835250080" name="Group 68"/>
+          <p:cNvPr id="1295062725" name="Group 68"/>
           <p:cNvGrpSpPr/>
           <p:nvPr/>
         </p:nvGrpSpPr>
@@ -6828,7 +6827,7 @@
       </p:grpSp>
       <p:sp>
         <p:nvSpPr>
-          <p:cNvPr id="190128656" name="Rectangle 70"/>
+          <p:cNvPr id="1818939144" name="Rectangle 70"/>
           <p:cNvSpPr txBox="1"/>
           <p:nvPr/>
         </p:nvSpPr>
@@ -6873,7 +6872,7 @@
       </p:sp>
       <p:sp>
         <p:nvSpPr>
-          <p:cNvPr id="640881803" name="Rectangle 71"/>
+          <p:cNvPr id="1671015826" name="Rectangle 71"/>
           <p:cNvSpPr txBox="1"/>
           <p:nvPr/>
         </p:nvSpPr>
@@ -6918,7 +6917,7 @@
       </p:sp>
       <p:sp>
         <p:nvSpPr>
-          <p:cNvPr id="146327239" name="Rectangle 72"/>
+          <p:cNvPr id="1400076005" name="Rectangle 72"/>
           <p:cNvSpPr txBox="1"/>
           <p:nvPr/>
         </p:nvSpPr>
@@ -6963,14 +6962,14 @@
       </p:sp>
       <p:sp>
         <p:nvSpPr>
-          <p:cNvPr id="958218608" name="Rectangle 73"/>
+          <p:cNvPr id="1596806646" name="Rectangle 73"/>
           <p:cNvSpPr txBox="1"/>
           <p:nvPr/>
         </p:nvSpPr>
         <p:spPr bwMode="auto">
           <a:xfrm rot="0" flipH="0" flipV="0">
             <a:off x="1174131" y="4031649"/>
-            <a:ext cx="4523330" cy="366119"/>
+            <a:ext cx="4523689" cy="366119"/>
           </a:xfrm>
           <a:prstGeom prst="rect">
             <a:avLst/>
@@ -7008,7 +7007,7 @@
       </p:sp>
       <p:grpSp>
         <p:nvGrpSpPr>
-          <p:cNvPr id="1192772700" name="Group 74"/>
+          <p:cNvPr id="944544788" name="Group 74"/>
           <p:cNvGrpSpPr/>
           <p:nvPr/>
         </p:nvGrpSpPr>
@@ -7174,7 +7173,7 @@
       </p:grpSp>
       <p:sp>
         <p:nvSpPr>
-          <p:cNvPr id="947813721" name="Rectangle 76"/>
+          <p:cNvPr id="1685059566" name="Rectangle 76"/>
           <p:cNvSpPr txBox="1"/>
           <p:nvPr/>
         </p:nvSpPr>
@@ -7218,7 +7217,7 @@
       </p:sp>
       <p:grpSp>
         <p:nvGrpSpPr>
-          <p:cNvPr id="1207687651" name="Group 77"/>
+          <p:cNvPr id="998526541" name="Group 77"/>
           <p:cNvGrpSpPr/>
           <p:nvPr/>
         </p:nvGrpSpPr>
@@ -7384,7 +7383,7 @@
       </p:grpSp>
       <p:sp>
         <p:nvSpPr>
-          <p:cNvPr id="407145229" name="Rectangle 79"/>
+          <p:cNvPr id="6488683" name="Rectangle 79"/>
           <p:cNvSpPr txBox="1"/>
           <p:nvPr/>
         </p:nvSpPr>
@@ -7428,7 +7427,7 @@
       </p:sp>
       <p:grpSp>
         <p:nvGrpSpPr>
-          <p:cNvPr id="1430474631" name="Group 80"/>
+          <p:cNvPr id="1430283589" name="Group 80"/>
           <p:cNvGrpSpPr/>
           <p:nvPr/>
         </p:nvGrpSpPr>
@@ -7594,7 +7593,7 @@
       </p:grpSp>
       <p:sp>
         <p:nvSpPr>
-          <p:cNvPr id="872687484" name="Rectangle 82"/>
+          <p:cNvPr id="178598820" name="Rectangle 82"/>
           <p:cNvSpPr txBox="1"/>
           <p:nvPr/>
         </p:nvSpPr>
@@ -7671,7 +7670,7 @@
       </p:sp>
       <p:grpSp>
         <p:nvGrpSpPr>
-          <p:cNvPr id="1137206618" name="Group 83"/>
+          <p:cNvPr id="1191916724" name="Group 83"/>
           <p:cNvGrpSpPr/>
           <p:nvPr/>
         </p:nvGrpSpPr>
@@ -7837,7 +7836,7 @@
       </p:grpSp>
       <p:sp>
         <p:nvSpPr>
-          <p:cNvPr id="1546584836" name="Rectangle 85"/>
+          <p:cNvPr id="1469533486" name="Rectangle 85"/>
           <p:cNvSpPr txBox="1"/>
           <p:nvPr/>
         </p:nvSpPr>
@@ -7881,7 +7880,7 @@
       </p:sp>
       <p:grpSp>
         <p:nvGrpSpPr>
-          <p:cNvPr id="1957962375" name="Group 86"/>
+          <p:cNvPr id="739879962" name="Group 86"/>
           <p:cNvGrpSpPr/>
           <p:nvPr/>
         </p:nvGrpSpPr>
@@ -8047,7 +8046,7 @@
       </p:grpSp>
       <p:sp>
         <p:nvSpPr>
-          <p:cNvPr id="1821900029" name="Rectangle 88"/>
+          <p:cNvPr id="51449504" name="Rectangle 88"/>
           <p:cNvSpPr txBox="1"/>
           <p:nvPr/>
         </p:nvSpPr>
@@ -8092,7 +8091,7 @@
       </p:sp>
       <p:grpSp>
         <p:nvGrpSpPr>
-          <p:cNvPr id="1650391751" name="Group 89"/>
+          <p:cNvPr id="1481358855" name="Group 89"/>
           <p:cNvGrpSpPr/>
           <p:nvPr/>
         </p:nvGrpSpPr>
@@ -8258,7 +8257,7 @@
       </p:grpSp>
       <p:sp>
         <p:nvSpPr>
-          <p:cNvPr id="551164759" name="Rectangle 91"/>
+          <p:cNvPr id="789454152" name="Rectangle 91"/>
           <p:cNvSpPr txBox="1"/>
           <p:nvPr/>
         </p:nvSpPr>
@@ -8302,13 +8301,13 @@
       </p:sp>
       <p:grpSp>
         <p:nvGrpSpPr>
-          <p:cNvPr id="1736756833" name="Group 92"/>
+          <p:cNvPr id="1840932472" name="Group 92"/>
           <p:cNvGrpSpPr/>
           <p:nvPr/>
         </p:nvGrpSpPr>
         <p:grpSpPr bwMode="auto">
           <a:xfrm flipH="0" flipV="0">
-            <a:off x="6440418" y="5847709"/>
+            <a:off x="6440418" y="5847708"/>
             <a:ext cx="5429269" cy="629307"/>
             <a:chOff x="0" y="0"/>
             <a:chExt cx="5429269" cy="629307"/>
@@ -8468,7 +8467,7 @@
       </p:grpSp>
       <p:sp>
         <p:nvSpPr>
-          <p:cNvPr id="1604520241" name="Rectangle 94"/>
+          <p:cNvPr id="2012946033" name="Rectangle 94"/>
           <p:cNvSpPr txBox="1"/>
           <p:nvPr/>
         </p:nvSpPr>
@@ -8510,262 +8509,9 @@
           </a:p>
         </p:txBody>
       </p:sp>
-      <p:pic>
-        <p:nvPicPr>
-          <p:cNvPr id="1517512863" name="Picture 95"/>
-          <p:cNvPicPr>
-            <a:picLocks noChangeAspect="1"/>
-          </p:cNvPicPr>
-          <p:nvPr/>
-        </p:nvPicPr>
-        <p:blipFill rotWithShape="1">
-          <a:blip r:embed="rId6"/>
-          <a:srcRect l="0" t="0" r="43292" b="0"/>
-          <a:stretch/>
-        </p:blipFill>
-        <p:spPr bwMode="auto">
-          <a:xfrm flipH="0" flipV="0">
-            <a:off x="380133" y="1078430"/>
-            <a:ext cx="617432" cy="730034"/>
-          </a:xfrm>
-          <a:prstGeom prst="rect">
-            <a:avLst/>
-          </a:prstGeom>
-        </p:spPr>
-      </p:pic>
-      <p:pic>
-        <p:nvPicPr>
-          <p:cNvPr id="692899693" name="Picture 96"/>
-          <p:cNvPicPr>
-            <a:picLocks noChangeAspect="1"/>
-          </p:cNvPicPr>
-          <p:nvPr/>
-        </p:nvPicPr>
-        <p:blipFill rotWithShape="1">
-          <a:blip r:embed="rId6"/>
-          <a:srcRect l="0" t="0" r="43292" b="0"/>
-          <a:stretch/>
-        </p:blipFill>
-        <p:spPr bwMode="auto">
-          <a:xfrm flipH="0" flipV="0">
-            <a:off x="380133" y="2019232"/>
-            <a:ext cx="617432" cy="730033"/>
-          </a:xfrm>
-          <a:prstGeom prst="rect">
-            <a:avLst/>
-          </a:prstGeom>
-        </p:spPr>
-      </p:pic>
-      <p:pic>
-        <p:nvPicPr>
-          <p:cNvPr id="527621043" name="Picture 97"/>
-          <p:cNvPicPr>
-            <a:picLocks noChangeAspect="1"/>
-          </p:cNvPicPr>
-          <p:nvPr/>
-        </p:nvPicPr>
-        <p:blipFill rotWithShape="1">
-          <a:blip r:embed="rId6"/>
-          <a:srcRect l="0" t="0" r="43292" b="0"/>
-          <a:stretch/>
-        </p:blipFill>
-        <p:spPr bwMode="auto">
-          <a:xfrm flipH="0" flipV="0">
-            <a:off x="380133" y="2880920"/>
-            <a:ext cx="617432" cy="730033"/>
-          </a:xfrm>
-          <a:prstGeom prst="rect">
-            <a:avLst/>
-          </a:prstGeom>
-        </p:spPr>
-      </p:pic>
-      <p:pic>
-        <p:nvPicPr>
-          <p:cNvPr id="1786126831" name="Picture 98"/>
-          <p:cNvPicPr>
-            <a:picLocks noChangeAspect="1"/>
-          </p:cNvPicPr>
-          <p:nvPr/>
-        </p:nvPicPr>
-        <p:blipFill rotWithShape="1">
-          <a:blip r:embed="rId6"/>
-          <a:srcRect l="0" t="0" r="43292" b="0"/>
-          <a:stretch/>
-        </p:blipFill>
-        <p:spPr bwMode="auto">
-          <a:xfrm flipH="0" flipV="0">
-            <a:off x="403944" y="3849689"/>
-            <a:ext cx="617432" cy="730033"/>
-          </a:xfrm>
-          <a:prstGeom prst="rect">
-            <a:avLst/>
-          </a:prstGeom>
-        </p:spPr>
-      </p:pic>
-      <p:pic>
-        <p:nvPicPr>
-          <p:cNvPr id="1268779798" name="Picture 99"/>
-          <p:cNvPicPr>
-            <a:picLocks noChangeAspect="1"/>
-          </p:cNvPicPr>
-          <p:nvPr/>
-        </p:nvPicPr>
-        <p:blipFill rotWithShape="1">
-          <a:blip r:embed="rId6"/>
-          <a:srcRect l="0" t="0" r="43292" b="0"/>
-          <a:stretch/>
-        </p:blipFill>
-        <p:spPr bwMode="auto">
-          <a:xfrm flipH="0" flipV="0">
-            <a:off x="380133" y="4848755"/>
-            <a:ext cx="617432" cy="730033"/>
-          </a:xfrm>
-          <a:prstGeom prst="rect">
-            <a:avLst/>
-          </a:prstGeom>
-        </p:spPr>
-      </p:pic>
-      <p:pic>
-        <p:nvPicPr>
-          <p:cNvPr id="775705204" name="Picture 100"/>
-          <p:cNvPicPr>
-            <a:picLocks noChangeAspect="1"/>
-          </p:cNvPicPr>
-          <p:nvPr/>
-        </p:nvPicPr>
-        <p:blipFill rotWithShape="1">
-          <a:blip r:embed="rId6"/>
-          <a:srcRect l="0" t="0" r="43292" b="0"/>
-          <a:stretch/>
-        </p:blipFill>
-        <p:spPr bwMode="auto">
-          <a:xfrm flipH="0" flipV="0">
-            <a:off x="380133" y="5826654"/>
-            <a:ext cx="617432" cy="730033"/>
-          </a:xfrm>
-          <a:prstGeom prst="rect">
-            <a:avLst/>
-          </a:prstGeom>
-        </p:spPr>
-      </p:pic>
-      <p:pic>
-        <p:nvPicPr>
-          <p:cNvPr id="514485027" name="Picture 101"/>
-          <p:cNvPicPr>
-            <a:picLocks noChangeAspect="1"/>
-          </p:cNvPicPr>
-          <p:nvPr/>
-        </p:nvPicPr>
-        <p:blipFill rotWithShape="1">
-          <a:blip r:embed="rId6"/>
-          <a:srcRect l="0" t="0" r="43292" b="0"/>
-          <a:stretch/>
-        </p:blipFill>
-        <p:spPr bwMode="auto">
-          <a:xfrm flipH="0" flipV="0">
-            <a:off x="6481328" y="1078430"/>
-            <a:ext cx="617432" cy="730033"/>
-          </a:xfrm>
-          <a:prstGeom prst="rect">
-            <a:avLst/>
-          </a:prstGeom>
-        </p:spPr>
-      </p:pic>
-      <p:pic>
-        <p:nvPicPr>
-          <p:cNvPr id="1921808527" name="Picture 102"/>
-          <p:cNvPicPr>
-            <a:picLocks noChangeAspect="1"/>
-          </p:cNvPicPr>
-          <p:nvPr/>
-        </p:nvPicPr>
-        <p:blipFill rotWithShape="1">
-          <a:blip r:embed="rId6"/>
-          <a:srcRect l="0" t="0" r="43292" b="0"/>
-          <a:stretch/>
-        </p:blipFill>
-        <p:spPr bwMode="auto">
-          <a:xfrm flipH="0" flipV="0">
-            <a:off x="6481328" y="2019232"/>
-            <a:ext cx="617432" cy="730033"/>
-          </a:xfrm>
-          <a:prstGeom prst="rect">
-            <a:avLst/>
-          </a:prstGeom>
-        </p:spPr>
-      </p:pic>
-      <p:pic>
-        <p:nvPicPr>
-          <p:cNvPr id="1758978188" name="Picture 103"/>
-          <p:cNvPicPr>
-            <a:picLocks noChangeAspect="1"/>
-          </p:cNvPicPr>
-          <p:nvPr/>
-        </p:nvPicPr>
-        <p:blipFill rotWithShape="1">
-          <a:blip r:embed="rId6"/>
-          <a:srcRect l="0" t="0" r="43292" b="0"/>
-          <a:stretch/>
-        </p:blipFill>
-        <p:spPr bwMode="auto">
-          <a:xfrm flipH="0" flipV="0">
-            <a:off x="6481328" y="2880920"/>
-            <a:ext cx="617432" cy="730033"/>
-          </a:xfrm>
-          <a:prstGeom prst="rect">
-            <a:avLst/>
-          </a:prstGeom>
-        </p:spPr>
-      </p:pic>
-      <p:pic>
-        <p:nvPicPr>
-          <p:cNvPr id="433877431" name="Picture 104"/>
-          <p:cNvPicPr>
-            <a:picLocks noChangeAspect="1"/>
-          </p:cNvPicPr>
-          <p:nvPr/>
-        </p:nvPicPr>
-        <p:blipFill rotWithShape="1">
-          <a:blip r:embed="rId6"/>
-          <a:srcRect l="0" t="0" r="43292" b="0"/>
-          <a:stretch/>
-        </p:blipFill>
-        <p:spPr bwMode="auto">
-          <a:xfrm flipH="0" flipV="0">
-            <a:off x="6481328" y="3849689"/>
-            <a:ext cx="617432" cy="730033"/>
-          </a:xfrm>
-          <a:prstGeom prst="rect">
-            <a:avLst/>
-          </a:prstGeom>
-        </p:spPr>
-      </p:pic>
-      <p:pic>
-        <p:nvPicPr>
-          <p:cNvPr id="1099547216" name="Picture 105"/>
-          <p:cNvPicPr>
-            <a:picLocks noChangeAspect="1"/>
-          </p:cNvPicPr>
-          <p:nvPr/>
-        </p:nvPicPr>
-        <p:blipFill rotWithShape="1">
-          <a:blip r:embed="rId6"/>
-          <a:srcRect l="50000" t="0" r="0" b="0"/>
-          <a:stretch/>
-        </p:blipFill>
-        <p:spPr bwMode="auto">
-          <a:xfrm flipH="0" flipV="0">
-            <a:off x="6481328" y="5783385"/>
-            <a:ext cx="561458" cy="752913"/>
-          </a:xfrm>
-          <a:prstGeom prst="rect">
-            <a:avLst/>
-          </a:prstGeom>
-        </p:spPr>
-      </p:pic>
       <p:grpSp>
         <p:nvGrpSpPr>
-          <p:cNvPr id="1831908010" name="Group 106"/>
+          <p:cNvPr id="1364174869" name="Group 106"/>
           <p:cNvGrpSpPr/>
           <p:nvPr/>
         </p:nvGrpSpPr>
@@ -8931,14 +8677,14 @@
       </p:grpSp>
       <p:sp>
         <p:nvSpPr>
-          <p:cNvPr id="1459181756" name="Rectangle 108"/>
+          <p:cNvPr id="1752213649" name="Rectangle 108"/>
           <p:cNvSpPr txBox="1"/>
           <p:nvPr/>
         </p:nvSpPr>
         <p:spPr bwMode="auto">
           <a:xfrm rot="0" flipH="0" flipV="0">
-            <a:off x="7257872" y="5017485"/>
-            <a:ext cx="4559691" cy="366119"/>
+            <a:off x="7257871" y="5017484"/>
+            <a:ext cx="4560050" cy="366119"/>
           </a:xfrm>
           <a:prstGeom prst="rect">
             <a:avLst/>
@@ -8960,7 +8706,7 @@
                 </a:solidFill>
                 <a:latin typeface="Michroma"/>
                 <a:cs typeface="Michroma"/>
-                <a:hlinkClick r:id="rId7" tooltip=""/>
+                <a:hlinkClick r:id="rId6" tooltip=""/>
               </a:rPr>
               <a:t>Call interna: 2 </a:t>
             </a:r>
@@ -8976,21 +8722,334 @@
       </p:sp>
       <p:pic>
         <p:nvPicPr>
-          <p:cNvPr id="529429840" name="Picture 109"/>
+          <p:cNvPr id="459355405" name="Picture 52"/>
           <p:cNvPicPr>
             <a:picLocks noChangeAspect="1"/>
           </p:cNvPicPr>
           <p:nvPr/>
         </p:nvPicPr>
         <p:blipFill rotWithShape="1">
-          <a:blip r:embed="rId6"/>
-          <a:srcRect l="0" t="0" r="43292" b="0"/>
+          <a:blip r:embed="rId7">
+            <a:extLst>
+              <a:ext uri="{96DAC541-7B7A-43D3-8B79-37D633B846F1}">
+                <asvg:svgBlip xmlns:asvg="http://schemas.microsoft.com/office/drawing/2016/SVG/main" r:embed="rId8"/>
+              </a:ext>
+            </a:extLst>
+          </a:blip>
           <a:stretch/>
         </p:blipFill>
         <p:spPr bwMode="auto">
           <a:xfrm flipH="0" flipV="0">
-            <a:off x="6484899" y="4835526"/>
-            <a:ext cx="617432" cy="730033"/>
+            <a:off x="457333" y="1201664"/>
+            <a:ext cx="467431" cy="467431"/>
+          </a:xfrm>
+          <a:prstGeom prst="rect">
+            <a:avLst/>
+          </a:prstGeom>
+        </p:spPr>
+      </p:pic>
+      <p:pic>
+        <p:nvPicPr>
+          <p:cNvPr id="427500807" name="Picture 53"/>
+          <p:cNvPicPr>
+            <a:picLocks noChangeAspect="1"/>
+          </p:cNvPicPr>
+          <p:nvPr/>
+        </p:nvPicPr>
+        <p:blipFill rotWithShape="1">
+          <a:blip r:embed="rId7">
+            <a:extLst>
+              <a:ext uri="{96DAC541-7B7A-43D3-8B79-37D633B846F1}">
+                <asvg:svgBlip xmlns:asvg="http://schemas.microsoft.com/office/drawing/2016/SVG/main" r:embed="rId8"/>
+              </a:ext>
+            </a:extLst>
+          </a:blip>
+          <a:stretch/>
+        </p:blipFill>
+        <p:spPr bwMode="auto">
+          <a:xfrm flipH="0" flipV="0">
+            <a:off x="457333" y="2150534"/>
+            <a:ext cx="467430" cy="467430"/>
+          </a:xfrm>
+          <a:prstGeom prst="rect">
+            <a:avLst/>
+          </a:prstGeom>
+          <a:noFill/>
+        </p:spPr>
+      </p:pic>
+      <p:pic>
+        <p:nvPicPr>
+          <p:cNvPr id="745128772" name="Picture 54"/>
+          <p:cNvPicPr>
+            <a:picLocks noChangeAspect="1"/>
+          </p:cNvPicPr>
+          <p:nvPr/>
+        </p:nvPicPr>
+        <p:blipFill rotWithShape="1">
+          <a:blip r:embed="rId7">
+            <a:extLst>
+              <a:ext uri="{96DAC541-7B7A-43D3-8B79-37D633B846F1}">
+                <asvg:svgBlip xmlns:asvg="http://schemas.microsoft.com/office/drawing/2016/SVG/main" r:embed="rId8"/>
+              </a:ext>
+            </a:extLst>
+          </a:blip>
+          <a:stretch/>
+        </p:blipFill>
+        <p:spPr bwMode="auto">
+          <a:xfrm flipH="0" flipV="0">
+            <a:off x="457333" y="3012223"/>
+            <a:ext cx="467430" cy="467430"/>
+          </a:xfrm>
+          <a:prstGeom prst="rect">
+            <a:avLst/>
+          </a:prstGeom>
+        </p:spPr>
+      </p:pic>
+      <p:pic>
+        <p:nvPicPr>
+          <p:cNvPr id="180991575" name="Picture 55"/>
+          <p:cNvPicPr>
+            <a:picLocks noChangeAspect="1"/>
+          </p:cNvPicPr>
+          <p:nvPr/>
+        </p:nvPicPr>
+        <p:blipFill rotWithShape="1">
+          <a:blip r:embed="rId7">
+            <a:extLst>
+              <a:ext uri="{96DAC541-7B7A-43D3-8B79-37D633B846F1}">
+                <asvg:svgBlip xmlns:asvg="http://schemas.microsoft.com/office/drawing/2016/SVG/main" r:embed="rId8"/>
+              </a:ext>
+            </a:extLst>
+          </a:blip>
+          <a:stretch/>
+        </p:blipFill>
+        <p:spPr bwMode="auto">
+          <a:xfrm flipH="0" flipV="0">
+            <a:off x="467916" y="3980992"/>
+            <a:ext cx="467430" cy="467430"/>
+          </a:xfrm>
+          <a:prstGeom prst="rect">
+            <a:avLst/>
+          </a:prstGeom>
+        </p:spPr>
+      </p:pic>
+      <p:pic>
+        <p:nvPicPr>
+          <p:cNvPr id="293418017" name="Picture 56"/>
+          <p:cNvPicPr>
+            <a:picLocks noChangeAspect="1"/>
+          </p:cNvPicPr>
+          <p:nvPr/>
+        </p:nvPicPr>
+        <p:blipFill rotWithShape="1">
+          <a:blip r:embed="rId7">
+            <a:extLst>
+              <a:ext uri="{96DAC541-7B7A-43D3-8B79-37D633B846F1}">
+                <asvg:svgBlip xmlns:asvg="http://schemas.microsoft.com/office/drawing/2016/SVG/main" r:embed="rId8"/>
+              </a:ext>
+            </a:extLst>
+          </a:blip>
+          <a:stretch/>
+        </p:blipFill>
+        <p:spPr bwMode="auto">
+          <a:xfrm flipH="0" flipV="0">
+            <a:off x="446750" y="4980057"/>
+            <a:ext cx="467430" cy="467430"/>
+          </a:xfrm>
+          <a:prstGeom prst="rect">
+            <a:avLst/>
+          </a:prstGeom>
+        </p:spPr>
+      </p:pic>
+      <p:pic>
+        <p:nvPicPr>
+          <p:cNvPr id="682106234" name="Picture 57"/>
+          <p:cNvPicPr>
+            <a:picLocks noChangeAspect="1"/>
+          </p:cNvPicPr>
+          <p:nvPr/>
+        </p:nvPicPr>
+        <p:blipFill rotWithShape="1">
+          <a:blip r:embed="rId7">
+            <a:extLst>
+              <a:ext uri="{96DAC541-7B7A-43D3-8B79-37D633B846F1}">
+                <asvg:svgBlip xmlns:asvg="http://schemas.microsoft.com/office/drawing/2016/SVG/main" r:embed="rId8"/>
+              </a:ext>
+            </a:extLst>
+          </a:blip>
+          <a:stretch/>
+        </p:blipFill>
+        <p:spPr bwMode="auto">
+          <a:xfrm flipH="0" flipV="0">
+            <a:off x="446750" y="5966198"/>
+            <a:ext cx="467430" cy="467430"/>
+          </a:xfrm>
+          <a:prstGeom prst="rect">
+            <a:avLst/>
+          </a:prstGeom>
+        </p:spPr>
+      </p:pic>
+      <p:pic>
+        <p:nvPicPr>
+          <p:cNvPr id="751797394" name="Picture 58"/>
+          <p:cNvPicPr>
+            <a:picLocks noChangeAspect="1"/>
+          </p:cNvPicPr>
+          <p:nvPr/>
+        </p:nvPicPr>
+        <p:blipFill rotWithShape="1">
+          <a:blip r:embed="rId7">
+            <a:extLst>
+              <a:ext uri="{96DAC541-7B7A-43D3-8B79-37D633B846F1}">
+                <asvg:svgBlip xmlns:asvg="http://schemas.microsoft.com/office/drawing/2016/SVG/main" r:embed="rId8"/>
+              </a:ext>
+            </a:extLst>
+          </a:blip>
+          <a:stretch/>
+        </p:blipFill>
+        <p:spPr bwMode="auto">
+          <a:xfrm flipH="0" flipV="0">
+            <a:off x="6549508" y="1201664"/>
+            <a:ext cx="467430" cy="467430"/>
+          </a:xfrm>
+          <a:prstGeom prst="rect">
+            <a:avLst/>
+          </a:prstGeom>
+        </p:spPr>
+      </p:pic>
+      <p:pic>
+        <p:nvPicPr>
+          <p:cNvPr id="1923797684" name="Picture 59"/>
+          <p:cNvPicPr>
+            <a:picLocks noChangeAspect="1"/>
+          </p:cNvPicPr>
+          <p:nvPr/>
+        </p:nvPicPr>
+        <p:blipFill rotWithShape="1">
+          <a:blip r:embed="rId7">
+            <a:extLst>
+              <a:ext uri="{96DAC541-7B7A-43D3-8B79-37D633B846F1}">
+                <asvg:svgBlip xmlns:asvg="http://schemas.microsoft.com/office/drawing/2016/SVG/main" r:embed="rId8"/>
+              </a:ext>
+            </a:extLst>
+          </a:blip>
+          <a:stretch/>
+        </p:blipFill>
+        <p:spPr bwMode="auto">
+          <a:xfrm flipH="0" flipV="0">
+            <a:off x="6560091" y="2119873"/>
+            <a:ext cx="467430" cy="467430"/>
+          </a:xfrm>
+          <a:prstGeom prst="rect">
+            <a:avLst/>
+          </a:prstGeom>
+        </p:spPr>
+      </p:pic>
+      <p:pic>
+        <p:nvPicPr>
+          <p:cNvPr id="1314901434" name="Picture 60"/>
+          <p:cNvPicPr>
+            <a:picLocks noChangeAspect="1"/>
+          </p:cNvPicPr>
+          <p:nvPr/>
+        </p:nvPicPr>
+        <p:blipFill rotWithShape="1">
+          <a:blip r:embed="rId7">
+            <a:extLst>
+              <a:ext uri="{96DAC541-7B7A-43D3-8B79-37D633B846F1}">
+                <asvg:svgBlip xmlns:asvg="http://schemas.microsoft.com/office/drawing/2016/SVG/main" r:embed="rId8"/>
+              </a:ext>
+            </a:extLst>
+          </a:blip>
+          <a:stretch/>
+        </p:blipFill>
+        <p:spPr bwMode="auto">
+          <a:xfrm flipH="0" flipV="0">
+            <a:off x="6575355" y="3012223"/>
+            <a:ext cx="467430" cy="467430"/>
+          </a:xfrm>
+          <a:prstGeom prst="rect">
+            <a:avLst/>
+          </a:prstGeom>
+        </p:spPr>
+      </p:pic>
+      <p:pic>
+        <p:nvPicPr>
+          <p:cNvPr id="1560285736" name="Picture 61"/>
+          <p:cNvPicPr>
+            <a:picLocks noChangeAspect="1"/>
+          </p:cNvPicPr>
+          <p:nvPr/>
+        </p:nvPicPr>
+        <p:blipFill rotWithShape="1">
+          <a:blip r:embed="rId7">
+            <a:extLst>
+              <a:ext uri="{96DAC541-7B7A-43D3-8B79-37D633B846F1}">
+                <asvg:svgBlip xmlns:asvg="http://schemas.microsoft.com/office/drawing/2016/SVG/main" r:embed="rId8"/>
+              </a:ext>
+            </a:extLst>
+          </a:blip>
+          <a:stretch/>
+        </p:blipFill>
+        <p:spPr bwMode="auto">
+          <a:xfrm flipH="0" flipV="0">
+            <a:off x="6549508" y="3980992"/>
+            <a:ext cx="467430" cy="467430"/>
+          </a:xfrm>
+          <a:prstGeom prst="rect">
+            <a:avLst/>
+          </a:prstGeom>
+        </p:spPr>
+      </p:pic>
+      <p:pic>
+        <p:nvPicPr>
+          <p:cNvPr id="149730836" name="Picture 62"/>
+          <p:cNvPicPr>
+            <a:picLocks noChangeAspect="1"/>
+          </p:cNvPicPr>
+          <p:nvPr/>
+        </p:nvPicPr>
+        <p:blipFill rotWithShape="1">
+          <a:blip r:embed="rId7">
+            <a:extLst>
+              <a:ext uri="{96DAC541-7B7A-43D3-8B79-37D633B846F1}">
+                <asvg:svgBlip xmlns:asvg="http://schemas.microsoft.com/office/drawing/2016/SVG/main" r:embed="rId8"/>
+              </a:ext>
+            </a:extLst>
+          </a:blip>
+          <a:stretch/>
+        </p:blipFill>
+        <p:spPr bwMode="auto">
+          <a:xfrm flipH="0" flipV="0">
+            <a:off x="6560091" y="4980057"/>
+            <a:ext cx="467430" cy="467430"/>
+          </a:xfrm>
+          <a:prstGeom prst="rect">
+            <a:avLst/>
+          </a:prstGeom>
+        </p:spPr>
+      </p:pic>
+      <p:pic>
+        <p:nvPicPr>
+          <p:cNvPr id="1716461639" name="Picture 65"/>
+          <p:cNvPicPr>
+            <a:picLocks noChangeAspect="1"/>
+          </p:cNvPicPr>
+          <p:nvPr/>
+        </p:nvPicPr>
+        <p:blipFill rotWithShape="1">
+          <a:blip r:embed="rId9">
+            <a:extLst>
+              <a:ext uri="{96DAC541-7B7A-43D3-8B79-37D633B846F1}">
+                <asvg:svgBlip xmlns:asvg="http://schemas.microsoft.com/office/drawing/2016/SVG/main" r:embed="rId10"/>
+              </a:ext>
+            </a:extLst>
+          </a:blip>
+        </p:blipFill>
+        <p:spPr bwMode="auto">
+          <a:xfrm flipH="0" flipV="0">
+            <a:off x="6549508" y="5936790"/>
+            <a:ext cx="467430" cy="467430"/>
           </a:xfrm>
           <a:prstGeom prst="rect">
             <a:avLst/>
@@ -9037,7 +9096,7 @@
       </p:grpSpPr>
       <p:sp>
         <p:nvSpPr>
-          <p:cNvPr id="1167260803" name="Title 1"/>
+          <p:cNvPr id="1806529226" name="Title 1"/>
           <p:cNvSpPr>
             <a:spLocks noGrp="1"/>
           </p:cNvSpPr>
@@ -9089,7 +9148,7 @@
       </p:sp>
       <p:grpSp>
         <p:nvGrpSpPr>
-          <p:cNvPr id="329392342" name="Group 2"/>
+          <p:cNvPr id="2092392161" name="Group 2"/>
           <p:cNvGrpSpPr/>
           <p:nvPr/>
         </p:nvGrpSpPr>
@@ -9255,7 +9314,7 @@
       </p:grpSp>
       <p:grpSp>
         <p:nvGrpSpPr>
-          <p:cNvPr id="1304517785" name="Group 5"/>
+          <p:cNvPr id="1389490761" name="Group 5"/>
           <p:cNvGrpSpPr/>
           <p:nvPr/>
         </p:nvGrpSpPr>
@@ -9421,7 +9480,7 @@
       </p:grpSp>
       <p:grpSp>
         <p:nvGrpSpPr>
-          <p:cNvPr id="1903427850" name="Group 8"/>
+          <p:cNvPr id="207948949" name="Group 8"/>
           <p:cNvGrpSpPr/>
           <p:nvPr/>
         </p:nvGrpSpPr>
@@ -9587,7 +9646,7 @@
       </p:grpSp>
       <p:sp>
         <p:nvSpPr>
-          <p:cNvPr id="1475199515" name="Rectangle 14"/>
+          <p:cNvPr id="955177371" name="Rectangle 14"/>
           <p:cNvSpPr txBox="1"/>
           <p:nvPr/>
         </p:nvSpPr>
@@ -9631,7 +9690,7 @@
       </p:sp>
       <p:sp>
         <p:nvSpPr>
-          <p:cNvPr id="1939174329" name="Rectangle 15"/>
+          <p:cNvPr id="1867144911" name="Rectangle 15"/>
           <p:cNvSpPr txBox="1"/>
           <p:nvPr/>
         </p:nvSpPr>
@@ -9675,7 +9734,7 @@
       </p:sp>
       <p:sp>
         <p:nvSpPr>
-          <p:cNvPr id="807879020" name="Rectangle 16"/>
+          <p:cNvPr id="66288052" name="Rectangle 16"/>
           <p:cNvSpPr txBox="1"/>
           <p:nvPr/>
         </p:nvSpPr>
@@ -9725,7 +9784,7 @@
       </p:sp>
       <p:grpSp>
         <p:nvGrpSpPr>
-          <p:cNvPr id="1612400785" name="Group 56"/>
+          <p:cNvPr id="117134496" name="Group 56"/>
           <p:cNvGrpSpPr/>
           <p:nvPr/>
         </p:nvGrpSpPr>
@@ -9891,7 +9950,7 @@
       </p:grpSp>
       <p:sp>
         <p:nvSpPr>
-          <p:cNvPr id="145868224" name="Rectangle 58"/>
+          <p:cNvPr id="2088708978" name="Rectangle 58"/>
           <p:cNvSpPr txBox="1"/>
           <p:nvPr/>
         </p:nvSpPr>
@@ -9936,7 +9995,7 @@
       </p:sp>
       <p:sp>
         <p:nvSpPr>
-          <p:cNvPr id="248014064" name="Flowchart: Alternate process 64"/>
+          <p:cNvPr id="570454122" name="Flowchart: Alternate process 64"/>
           <p:cNvSpPr/>
           <p:nvPr/>
         </p:nvSpPr>
@@ -10030,14 +10089,14 @@
       </p:sp>
       <p:sp>
         <p:nvSpPr>
-          <p:cNvPr id="2079465567" name="Rectangle 65"/>
+          <p:cNvPr id="836314845" name="Rectangle 65"/>
           <p:cNvSpPr txBox="1"/>
           <p:nvPr/>
         </p:nvSpPr>
         <p:spPr bwMode="auto">
           <a:xfrm rot="0" flipH="0" flipV="0">
-            <a:off x="299017" y="1480790"/>
-            <a:ext cx="825231" cy="701399"/>
+            <a:off x="299015" y="1480789"/>
+            <a:ext cx="825590" cy="701399"/>
           </a:xfrm>
           <a:prstGeom prst="rect">
             <a:avLst/>
@@ -10071,7 +10130,7 @@
               <a:defRPr/>
             </a:pPr>
             <a:r>
-              <a:rPr lang="fr-FR" sz="2800">
+              <a:rPr lang="fr-FR" sz="2800" b="1">
                 <a:solidFill>
                   <a:srgbClr val="FF0000"/>
                 </a:solidFill>
@@ -10084,14 +10143,14 @@
       </p:sp>
       <p:sp>
         <p:nvSpPr>
-          <p:cNvPr id="2068392413" name="Rectangle 66"/>
+          <p:cNvPr id="2011513972" name="Rectangle 66"/>
           <p:cNvSpPr txBox="1"/>
           <p:nvPr/>
         </p:nvSpPr>
         <p:spPr bwMode="auto">
           <a:xfrm rot="0" flipH="0" flipV="0">
-            <a:off x="296031" y="2215767"/>
-            <a:ext cx="818751" cy="701399"/>
+            <a:off x="296030" y="2215766"/>
+            <a:ext cx="819110" cy="701399"/>
           </a:xfrm>
           <a:prstGeom prst="rect">
             <a:avLst/>
@@ -10125,27 +10184,27 @@
               <a:defRPr/>
             </a:pPr>
             <a:r>
-              <a:rPr lang="fr-FR" sz="2800">
+              <a:rPr lang="fr-FR" sz="2800" b="1">
                 <a:solidFill>
                   <a:srgbClr val="FF0000"/>
                 </a:solidFill>
               </a:rPr>
               <a:t>30</a:t>
             </a:r>
-            <a:endParaRPr sz="1400"/>
+            <a:endParaRPr sz="1400" b="1"/>
           </a:p>
         </p:txBody>
       </p:sp>
       <p:sp>
         <p:nvSpPr>
-          <p:cNvPr id="1202899423" name="Rectangle 67"/>
+          <p:cNvPr id="111336389" name="Rectangle 67"/>
           <p:cNvSpPr txBox="1"/>
           <p:nvPr/>
         </p:nvSpPr>
         <p:spPr bwMode="auto">
           <a:xfrm rot="0" flipH="0" flipV="0">
-            <a:off x="312622" y="2929288"/>
-            <a:ext cx="818751" cy="701399"/>
+            <a:off x="312621" y="2929287"/>
+            <a:ext cx="819110" cy="701399"/>
           </a:xfrm>
           <a:prstGeom prst="rect">
             <a:avLst/>
@@ -10179,27 +10238,27 @@
               <a:defRPr/>
             </a:pPr>
             <a:r>
-              <a:rPr lang="fr-FR" sz="2800">
+              <a:rPr lang="fr-FR" sz="2800" b="1">
                 <a:solidFill>
                   <a:srgbClr val="FF0000"/>
                 </a:solidFill>
               </a:rPr>
               <a:t>29</a:t>
             </a:r>
-            <a:endParaRPr sz="1400"/>
+            <a:endParaRPr sz="1400" b="1"/>
           </a:p>
         </p:txBody>
       </p:sp>
       <p:sp>
         <p:nvSpPr>
-          <p:cNvPr id="1603513704" name="Rectangle 68"/>
+          <p:cNvPr id="348968607" name="Rectangle 68"/>
           <p:cNvSpPr txBox="1"/>
           <p:nvPr/>
         </p:nvSpPr>
         <p:spPr bwMode="auto">
           <a:xfrm rot="0" flipH="0" flipV="0">
-            <a:off x="297937" y="3652973"/>
-            <a:ext cx="818751" cy="701399"/>
+            <a:off x="297936" y="3652972"/>
+            <a:ext cx="819110" cy="701399"/>
           </a:xfrm>
           <a:prstGeom prst="rect">
             <a:avLst/>
@@ -10233,20 +10292,20 @@
               <a:defRPr/>
             </a:pPr>
             <a:r>
-              <a:rPr lang="fr-FR" sz="2800">
+              <a:rPr lang="fr-FR" sz="2800" b="1">
                 <a:solidFill>
                   <a:srgbClr val="FF0000"/>
                 </a:solidFill>
               </a:rPr>
               <a:t>30</a:t>
             </a:r>
-            <a:endParaRPr sz="1400"/>
+            <a:endParaRPr sz="1400" b="1"/>
           </a:p>
         </p:txBody>
       </p:sp>
       <p:grpSp>
         <p:nvGrpSpPr>
-          <p:cNvPr id="1297858915" name="Group 69"/>
+          <p:cNvPr id="1640176449" name="Group 69"/>
           <p:cNvGrpSpPr/>
           <p:nvPr/>
         </p:nvGrpSpPr>
@@ -10412,7 +10471,7 @@
       </p:grpSp>
       <p:grpSp>
         <p:nvGrpSpPr>
-          <p:cNvPr id="742257913" name="Group 71"/>
+          <p:cNvPr id="364873856" name="Group 71"/>
           <p:cNvGrpSpPr/>
           <p:nvPr/>
         </p:nvGrpSpPr>
@@ -10578,7 +10637,7 @@
       </p:grpSp>
       <p:sp>
         <p:nvSpPr>
-          <p:cNvPr id="1298329246" name="Rectangle 75"/>
+          <p:cNvPr id="1744562795" name="Rectangle 75"/>
           <p:cNvSpPr txBox="1"/>
           <p:nvPr/>
         </p:nvSpPr>
@@ -10617,7 +10676,7 @@
       </p:sp>
       <p:sp>
         <p:nvSpPr>
-          <p:cNvPr id="164778092" name="Rectangle 76"/>
+          <p:cNvPr id="110269571" name="Rectangle 76"/>
           <p:cNvSpPr txBox="1"/>
           <p:nvPr/>
         </p:nvSpPr>
@@ -10661,14 +10720,14 @@
       </p:sp>
       <p:sp>
         <p:nvSpPr>
-          <p:cNvPr id="1336530540" name="Rectangle 82"/>
+          <p:cNvPr id="706944115" name="Rectangle 82"/>
           <p:cNvSpPr txBox="1"/>
           <p:nvPr/>
         </p:nvSpPr>
         <p:spPr bwMode="auto">
           <a:xfrm rot="0" flipH="0" flipV="0">
-            <a:off x="6431000" y="1474439"/>
-            <a:ext cx="827031" cy="701399"/>
+            <a:off x="6430999" y="1474438"/>
+            <a:ext cx="827390" cy="701399"/>
           </a:xfrm>
           <a:prstGeom prst="rect">
             <a:avLst/>
@@ -10702,20 +10761,20 @@
               <a:defRPr/>
             </a:pPr>
             <a:r>
-              <a:rPr lang="fr-FR" sz="2800">
+              <a:rPr lang="fr-FR" sz="2800" b="1">
                 <a:solidFill>
                   <a:srgbClr val="FF0000"/>
                 </a:solidFill>
               </a:rPr>
               <a:t> 2</a:t>
             </a:r>
-            <a:endParaRPr sz="1400"/>
+            <a:endParaRPr sz="1400" b="1"/>
           </a:p>
         </p:txBody>
       </p:sp>
       <p:sp>
         <p:nvSpPr>
-          <p:cNvPr id="1277288408" name="Flowchart: Alternate process 103"/>
+          <p:cNvPr id="1407959408" name="Flowchart: Alternate process 103"/>
           <p:cNvSpPr/>
           <p:nvPr/>
         </p:nvSpPr>
@@ -10805,7 +10864,7 @@
       </p:sp>
       <p:grpSp>
         <p:nvGrpSpPr>
-          <p:cNvPr id="1946481036" name="Group 110"/>
+          <p:cNvPr id="1976380679" name="Group 110"/>
           <p:cNvGrpSpPr/>
           <p:nvPr/>
         </p:nvGrpSpPr>
@@ -10971,7 +11030,7 @@
       </p:grpSp>
       <p:grpSp>
         <p:nvGrpSpPr>
-          <p:cNvPr id="1213020452" name="Group 112"/>
+          <p:cNvPr id="1475549340" name="Group 112"/>
           <p:cNvGrpSpPr/>
           <p:nvPr/>
         </p:nvGrpSpPr>
@@ -11137,7 +11196,7 @@
       </p:grpSp>
       <p:sp>
         <p:nvSpPr>
-          <p:cNvPr id="1814794617" name="Rectangle 114"/>
+          <p:cNvPr id="1832354937" name="Rectangle 114"/>
           <p:cNvSpPr txBox="1"/>
           <p:nvPr/>
         </p:nvSpPr>
@@ -11188,7 +11247,7 @@
       </p:sp>
       <p:sp>
         <p:nvSpPr>
-          <p:cNvPr id="1849289592" name="Rectangle 115"/>
+          <p:cNvPr id="1227451409" name="Rectangle 115"/>
           <p:cNvSpPr txBox="1"/>
           <p:nvPr/>
         </p:nvSpPr>
@@ -11239,14 +11298,14 @@
       </p:sp>
       <p:sp>
         <p:nvSpPr>
-          <p:cNvPr id="818809121" name="Rectangle 116"/>
+          <p:cNvPr id="156510923" name="Rectangle 116"/>
           <p:cNvSpPr txBox="1"/>
           <p:nvPr/>
         </p:nvSpPr>
         <p:spPr bwMode="auto">
           <a:xfrm rot="0" flipH="0" flipV="0">
-            <a:off x="298521" y="5159637"/>
-            <a:ext cx="828111" cy="701399"/>
+            <a:off x="298520" y="5159637"/>
+            <a:ext cx="828470" cy="701399"/>
           </a:xfrm>
           <a:prstGeom prst="rect">
             <a:avLst/>
@@ -11280,27 +11339,27 @@
               <a:defRPr/>
             </a:pPr>
             <a:r>
-              <a:rPr lang="fr-FR" sz="2800">
+              <a:rPr lang="fr-FR" sz="2800" b="1">
                 <a:solidFill>
                   <a:srgbClr val="FF0000"/>
                 </a:solidFill>
               </a:rPr>
               <a:t> 1</a:t>
             </a:r>
-            <a:endParaRPr sz="1400"/>
+            <a:endParaRPr sz="1400" b="1"/>
           </a:p>
         </p:txBody>
       </p:sp>
       <p:sp>
         <p:nvSpPr>
-          <p:cNvPr id="1910104860" name="Rectangle 117"/>
+          <p:cNvPr id="1456918560" name="Rectangle 117"/>
           <p:cNvSpPr txBox="1"/>
           <p:nvPr/>
         </p:nvSpPr>
         <p:spPr bwMode="auto">
           <a:xfrm rot="0" flipH="0" flipV="0">
-            <a:off x="295535" y="5905197"/>
-            <a:ext cx="823071" cy="701399"/>
+            <a:off x="295534" y="5905197"/>
+            <a:ext cx="823430" cy="701399"/>
           </a:xfrm>
           <a:prstGeom prst="rect">
             <a:avLst/>
@@ -11334,20 +11393,20 @@
               <a:defRPr/>
             </a:pPr>
             <a:r>
-              <a:rPr lang="fr-FR" sz="2800">
+              <a:rPr lang="fr-FR" sz="2800" b="1">
                 <a:solidFill>
                   <a:srgbClr val="FF0000"/>
                 </a:solidFill>
               </a:rPr>
               <a:t> 1</a:t>
             </a:r>
-            <a:endParaRPr sz="1400"/>
+            <a:endParaRPr sz="1400" b="1"/>
           </a:p>
         </p:txBody>
       </p:sp>
       <p:sp>
         <p:nvSpPr>
-          <p:cNvPr id="1793403897" name="Flowchart: Alternate process 118"/>
+          <p:cNvPr id="422265623" name="Flowchart: Alternate process 118"/>
           <p:cNvSpPr/>
           <p:nvPr/>
         </p:nvSpPr>
@@ -11437,14 +11496,14 @@
       </p:sp>
       <p:sp>
         <p:nvSpPr>
-          <p:cNvPr id="685091081" name="Rectangle 119"/>
+          <p:cNvPr id="319321418" name="Rectangle 119"/>
           <p:cNvSpPr txBox="1"/>
           <p:nvPr/>
         </p:nvSpPr>
         <p:spPr bwMode="auto">
           <a:xfrm rot="0" flipH="0" flipV="0">
-            <a:off x="6431000" y="2189644"/>
-            <a:ext cx="828111" cy="701399"/>
+            <a:off x="6430999" y="2189643"/>
+            <a:ext cx="828470" cy="701399"/>
           </a:xfrm>
           <a:prstGeom prst="rect">
             <a:avLst/>
@@ -11478,14 +11537,14 @@
               <a:defRPr/>
             </a:pPr>
             <a:r>
-              <a:rPr lang="fr-FR" sz="2800">
+              <a:rPr lang="fr-FR" sz="2800" b="1">
                 <a:solidFill>
                   <a:srgbClr val="FF0000"/>
                 </a:solidFill>
               </a:rPr>
               <a:t> 3</a:t>
             </a:r>
-            <a:endParaRPr sz="1400"/>
+            <a:endParaRPr sz="1400" b="1"/>
           </a:p>
         </p:txBody>
       </p:sp>
@@ -11528,7 +11587,7 @@
       </p:grpSpPr>
       <p:sp>
         <p:nvSpPr>
-          <p:cNvPr id="1497096974" name="Title 1"/>
+          <p:cNvPr id="2099588267" name="Title 1"/>
           <p:cNvSpPr>
             <a:spLocks noGrp="1"/>
           </p:cNvSpPr>
@@ -11580,7 +11639,7 @@
       </p:sp>
       <p:grpSp>
         <p:nvGrpSpPr>
-          <p:cNvPr id="656184688" name="Group 2"/>
+          <p:cNvPr id="1642813831" name="Group 2"/>
           <p:cNvGrpSpPr/>
           <p:nvPr/>
         </p:nvGrpSpPr>
@@ -11746,7 +11805,7 @@
       </p:grpSp>
       <p:grpSp>
         <p:nvGrpSpPr>
-          <p:cNvPr id="276200236" name="Group 5"/>
+          <p:cNvPr id="615621734" name="Group 5"/>
           <p:cNvGrpSpPr/>
           <p:nvPr/>
         </p:nvGrpSpPr>
@@ -11912,7 +11971,7 @@
       </p:grpSp>
       <p:grpSp>
         <p:nvGrpSpPr>
-          <p:cNvPr id="879380141" name="Group 8"/>
+          <p:cNvPr id="101935286" name="Group 8"/>
           <p:cNvGrpSpPr/>
           <p:nvPr/>
         </p:nvGrpSpPr>
@@ -12078,7 +12137,7 @@
       </p:grpSp>
       <p:sp>
         <p:nvSpPr>
-          <p:cNvPr id="2100208188" name="Rectangle 14"/>
+          <p:cNvPr id="1893463342" name="Rectangle 14"/>
           <p:cNvSpPr txBox="1"/>
           <p:nvPr/>
         </p:nvSpPr>
@@ -12122,7 +12181,7 @@
       </p:sp>
       <p:sp>
         <p:nvSpPr>
-          <p:cNvPr id="534255268" name="Rectangle 15"/>
+          <p:cNvPr id="515025448" name="Rectangle 15"/>
           <p:cNvSpPr txBox="1"/>
           <p:nvPr/>
         </p:nvSpPr>
@@ -12167,7 +12226,7 @@
       </p:sp>
       <p:sp>
         <p:nvSpPr>
-          <p:cNvPr id="1976866735" name="Rectangle 16"/>
+          <p:cNvPr id="1257531497" name="Rectangle 16"/>
           <p:cNvSpPr txBox="1"/>
           <p:nvPr/>
         </p:nvSpPr>
@@ -12211,7 +12270,7 @@
       </p:sp>
       <p:grpSp>
         <p:nvGrpSpPr>
-          <p:cNvPr id="1476013443" name="Group 66"/>
+          <p:cNvPr id="1418125491" name="Group 66"/>
           <p:cNvGrpSpPr/>
           <p:nvPr/>
         </p:nvGrpSpPr>
@@ -12377,7 +12436,7 @@
       </p:grpSp>
       <p:sp>
         <p:nvSpPr>
-          <p:cNvPr id="1831865806" name="Rectangle 68"/>
+          <p:cNvPr id="391309709" name="Rectangle 68"/>
           <p:cNvSpPr txBox="1"/>
           <p:nvPr/>
         </p:nvSpPr>
@@ -12421,7 +12480,7 @@
       </p:sp>
       <p:grpSp>
         <p:nvGrpSpPr>
-          <p:cNvPr id="1230626305" name="Group 118"/>
+          <p:cNvPr id="1274811468" name="Group 118"/>
           <p:cNvGrpSpPr/>
           <p:nvPr/>
         </p:nvGrpSpPr>
@@ -12587,7 +12646,7 @@
       </p:grpSp>
       <p:sp>
         <p:nvSpPr>
-          <p:cNvPr id="712852362" name="Rectangle 120"/>
+          <p:cNvPr id="1923620486" name="Rectangle 120"/>
           <p:cNvSpPr txBox="1"/>
           <p:nvPr/>
         </p:nvSpPr>
@@ -12631,20 +12690,25 @@
       </p:sp>
       <p:pic>
         <p:nvPicPr>
-          <p:cNvPr id="2033801309" name="Picture 122"/>
+          <p:cNvPr id="1650781369" name="Picture 22"/>
           <p:cNvPicPr>
             <a:picLocks noChangeAspect="1"/>
           </p:cNvPicPr>
           <p:nvPr/>
         </p:nvPicPr>
         <p:blipFill rotWithShape="1">
-          <a:blip r:embed="rId3"/>
-          <a:stretch/>
+          <a:blip r:embed="rId3">
+            <a:extLst>
+              <a:ext uri="{96DAC541-7B7A-43D3-8B79-37D633B846F1}">
+                <asvg:svgBlip xmlns:asvg="http://schemas.microsoft.com/office/drawing/2016/SVG/main" r:embed="rId4"/>
+              </a:ext>
+            </a:extLst>
+          </a:blip>
         </p:blipFill>
         <p:spPr bwMode="auto">
           <a:xfrm flipH="0" flipV="0">
-            <a:off x="3320804" y="1147892"/>
-            <a:ext cx="766528" cy="572341"/>
+            <a:off x="3477816" y="1209734"/>
+            <a:ext cx="467430" cy="467430"/>
           </a:xfrm>
           <a:prstGeom prst="rect">
             <a:avLst/>
@@ -12653,20 +12717,25 @@
       </p:pic>
       <p:pic>
         <p:nvPicPr>
-          <p:cNvPr id="990737872" name="Picture 123"/>
+          <p:cNvPr id="708677029" name="Picture 25"/>
           <p:cNvPicPr>
             <a:picLocks noChangeAspect="1"/>
           </p:cNvPicPr>
           <p:nvPr/>
         </p:nvPicPr>
         <p:blipFill rotWithShape="1">
-          <a:blip r:embed="rId3"/>
-          <a:stretch/>
+          <a:blip r:embed="rId3">
+            <a:extLst>
+              <a:ext uri="{96DAC541-7B7A-43D3-8B79-37D633B846F1}">
+                <asvg:svgBlip xmlns:asvg="http://schemas.microsoft.com/office/drawing/2016/SVG/main" r:embed="rId4"/>
+              </a:ext>
+            </a:extLst>
+          </a:blip>
         </p:blipFill>
         <p:spPr bwMode="auto">
           <a:xfrm flipH="0" flipV="0">
-            <a:off x="3329001" y="2037848"/>
-            <a:ext cx="766527" cy="572340"/>
+            <a:off x="3488399" y="2097618"/>
+            <a:ext cx="467430" cy="467430"/>
           </a:xfrm>
           <a:prstGeom prst="rect">
             <a:avLst/>
@@ -12675,20 +12744,25 @@
       </p:pic>
       <p:pic>
         <p:nvPicPr>
-          <p:cNvPr id="1219760571" name="Picture 124"/>
+          <p:cNvPr id="1755164147" name="Picture 26"/>
           <p:cNvPicPr>
             <a:picLocks noChangeAspect="1"/>
           </p:cNvPicPr>
           <p:nvPr/>
         </p:nvPicPr>
         <p:blipFill rotWithShape="1">
-          <a:blip r:embed="rId3"/>
-          <a:stretch/>
+          <a:blip r:embed="rId3">
+            <a:extLst>
+              <a:ext uri="{96DAC541-7B7A-43D3-8B79-37D633B846F1}">
+                <asvg:svgBlip xmlns:asvg="http://schemas.microsoft.com/office/drawing/2016/SVG/main" r:embed="rId4"/>
+              </a:ext>
+            </a:extLst>
+          </a:blip>
         </p:blipFill>
         <p:spPr bwMode="auto">
           <a:xfrm flipH="0" flipV="0">
-            <a:off x="3329001" y="2917436"/>
-            <a:ext cx="766527" cy="572340"/>
+            <a:off x="3488399" y="2972152"/>
+            <a:ext cx="467430" cy="467430"/>
           </a:xfrm>
           <a:prstGeom prst="rect">
             <a:avLst/>
@@ -12697,20 +12771,25 @@
       </p:pic>
       <p:pic>
         <p:nvPicPr>
-          <p:cNvPr id="163391132" name="Picture 125"/>
+          <p:cNvPr id="1770250824" name="Picture 27"/>
           <p:cNvPicPr>
             <a:picLocks noChangeAspect="1"/>
           </p:cNvPicPr>
           <p:nvPr/>
         </p:nvPicPr>
         <p:blipFill rotWithShape="1">
-          <a:blip r:embed="rId3"/>
-          <a:stretch/>
+          <a:blip r:embed="rId3">
+            <a:extLst>
+              <a:ext uri="{96DAC541-7B7A-43D3-8B79-37D633B846F1}">
+                <asvg:svgBlip xmlns:asvg="http://schemas.microsoft.com/office/drawing/2016/SVG/main" r:embed="rId4"/>
+              </a:ext>
+            </a:extLst>
+          </a:blip>
         </p:blipFill>
         <p:spPr bwMode="auto">
           <a:xfrm flipH="0" flipV="0">
-            <a:off x="3331387" y="3789502"/>
-            <a:ext cx="766527" cy="572340"/>
+            <a:off x="3488399" y="3841956"/>
+            <a:ext cx="467430" cy="467430"/>
           </a:xfrm>
           <a:prstGeom prst="rect">
             <a:avLst/>
@@ -12719,20 +12798,25 @@
       </p:pic>
       <p:pic>
         <p:nvPicPr>
-          <p:cNvPr id="1842516214" name="Picture 126"/>
+          <p:cNvPr id="1866091378" name="Picture 28"/>
           <p:cNvPicPr>
             <a:picLocks noChangeAspect="1"/>
           </p:cNvPicPr>
           <p:nvPr/>
         </p:nvPicPr>
         <p:blipFill rotWithShape="1">
-          <a:blip r:embed="rId3"/>
-          <a:stretch/>
+          <a:blip r:embed="rId3">
+            <a:extLst>
+              <a:ext uri="{96DAC541-7B7A-43D3-8B79-37D633B846F1}">
+                <asvg:svgBlip xmlns:asvg="http://schemas.microsoft.com/office/drawing/2016/SVG/main" r:embed="rId4"/>
+              </a:ext>
+            </a:extLst>
+          </a:blip>
         </p:blipFill>
         <p:spPr bwMode="auto">
           <a:xfrm flipH="0" flipV="0">
-            <a:off x="3329001" y="4637122"/>
-            <a:ext cx="766527" cy="572340"/>
+            <a:off x="3477816" y="4692855"/>
+            <a:ext cx="467430" cy="467430"/>
           </a:xfrm>
           <a:prstGeom prst="rect">
             <a:avLst/>
@@ -12778,7 +12862,7 @@
       </p:grpSpPr>
       <p:sp>
         <p:nvSpPr>
-          <p:cNvPr id="1916984170" name="Title 1"/>
+          <p:cNvPr id="1895258920" name="Title 1"/>
           <p:cNvSpPr>
             <a:spLocks noGrp="1"/>
           </p:cNvSpPr>
@@ -12830,7 +12914,7 @@
       </p:sp>
       <p:grpSp>
         <p:nvGrpSpPr>
-          <p:cNvPr id="1593935840" name="Group 22"/>
+          <p:cNvPr id="1271397403" name="Group 22"/>
           <p:cNvGrpSpPr/>
           <p:nvPr/>
         </p:nvGrpSpPr>
@@ -12996,7 +13080,7 @@
       </p:grpSp>
       <p:grpSp>
         <p:nvGrpSpPr>
-          <p:cNvPr id="1828164406" name="Group 24"/>
+          <p:cNvPr id="1895012621" name="Group 24"/>
           <p:cNvGrpSpPr/>
           <p:nvPr/>
         </p:nvGrpSpPr>
@@ -13162,7 +13246,7 @@
       </p:grpSp>
       <p:grpSp>
         <p:nvGrpSpPr>
-          <p:cNvPr id="926095326" name="Group 26"/>
+          <p:cNvPr id="1332884706" name="Group 26"/>
           <p:cNvGrpSpPr/>
           <p:nvPr/>
         </p:nvGrpSpPr>
@@ -13328,7 +13412,7 @@
       </p:grpSp>
       <p:grpSp>
         <p:nvGrpSpPr>
-          <p:cNvPr id="1159892838" name="Group 28"/>
+          <p:cNvPr id="814642713" name="Group 28"/>
           <p:cNvGrpSpPr/>
           <p:nvPr/>
         </p:nvGrpSpPr>
@@ -13494,7 +13578,7 @@
       </p:grpSp>
       <p:sp>
         <p:nvSpPr>
-          <p:cNvPr id="371008325" name="Rectangle 30"/>
+          <p:cNvPr id="1398838450" name="Rectangle 30"/>
           <p:cNvSpPr txBox="1"/>
           <p:nvPr/>
         </p:nvSpPr>
@@ -13549,7 +13633,7 @@
       </p:sp>
       <p:sp>
         <p:nvSpPr>
-          <p:cNvPr id="1888965978" name="Rectangle 31"/>
+          <p:cNvPr id="918774975" name="Rectangle 31"/>
           <p:cNvSpPr txBox="1"/>
           <p:nvPr/>
         </p:nvSpPr>
@@ -13594,7 +13678,7 @@
       </p:sp>
       <p:sp>
         <p:nvSpPr>
-          <p:cNvPr id="233223489" name="Rectangle 32"/>
+          <p:cNvPr id="1241125804" name="Rectangle 32"/>
           <p:cNvSpPr txBox="1"/>
           <p:nvPr/>
         </p:nvSpPr>
@@ -13639,7 +13723,7 @@
       </p:sp>
       <p:sp>
         <p:nvSpPr>
-          <p:cNvPr id="726540228" name="Rectangle 33"/>
+          <p:cNvPr id="240544430" name="Rectangle 33"/>
           <p:cNvSpPr txBox="1"/>
           <p:nvPr/>
         </p:nvSpPr>
@@ -13696,7 +13780,7 @@
       </p:sp>
       <p:grpSp>
         <p:nvGrpSpPr>
-          <p:cNvPr id="987559156" name="Group 34"/>
+          <p:cNvPr id="210765346" name="Group 34"/>
           <p:cNvGrpSpPr/>
           <p:nvPr/>
         </p:nvGrpSpPr>
@@ -13862,13 +13946,13 @@
       </p:grpSp>
       <p:sp>
         <p:nvSpPr>
-          <p:cNvPr id="2121874749" name="Rectangle 36"/>
+          <p:cNvPr id="837646164" name="Rectangle 36"/>
           <p:cNvSpPr txBox="1"/>
           <p:nvPr/>
         </p:nvSpPr>
         <p:spPr bwMode="auto">
           <a:xfrm rot="0" flipH="0" flipV="0">
-            <a:off x="4193069" y="4812314"/>
+            <a:off x="4193069" y="4812313"/>
             <a:ext cx="4560051" cy="366119"/>
           </a:xfrm>
           <a:prstGeom prst="rect">
@@ -13906,19 +13990,25 @@
       </p:sp>
       <p:pic>
         <p:nvPicPr>
-          <p:cNvPr id="949919050" name="Picture 70"/>
+          <p:cNvPr id="891538462" name="Picture 22"/>
           <p:cNvPicPr>
             <a:picLocks noChangeAspect="1"/>
           </p:cNvPicPr>
           <p:nvPr/>
         </p:nvPicPr>
         <p:blipFill rotWithShape="1">
-          <a:blip r:embed="rId3"/>
+          <a:blip r:embed="rId3">
+            <a:extLst>
+              <a:ext uri="{96DAC541-7B7A-43D3-8B79-37D633B846F1}">
+                <asvg:svgBlip xmlns:asvg="http://schemas.microsoft.com/office/drawing/2016/SVG/main" r:embed="rId4"/>
+              </a:ext>
+            </a:extLst>
+          </a:blip>
         </p:blipFill>
         <p:spPr bwMode="auto">
           <a:xfrm flipH="0" flipV="0">
-            <a:off x="3322729" y="1140701"/>
-            <a:ext cx="764547" cy="570861"/>
+            <a:off x="3477816" y="1199150"/>
+            <a:ext cx="467430" cy="467430"/>
           </a:xfrm>
           <a:prstGeom prst="rect">
             <a:avLst/>
@@ -13927,19 +14017,25 @@
       </p:pic>
       <p:pic>
         <p:nvPicPr>
-          <p:cNvPr id="1122531296" name="Picture 71"/>
+          <p:cNvPr id="934220758" name="Picture 23"/>
           <p:cNvPicPr>
             <a:picLocks noChangeAspect="1"/>
           </p:cNvPicPr>
           <p:nvPr/>
         </p:nvPicPr>
         <p:blipFill rotWithShape="1">
-          <a:blip r:embed="rId3"/>
+          <a:blip r:embed="rId3">
+            <a:extLst>
+              <a:ext uri="{96DAC541-7B7A-43D3-8B79-37D633B846F1}">
+                <asvg:svgBlip xmlns:asvg="http://schemas.microsoft.com/office/drawing/2016/SVG/main" r:embed="rId4"/>
+              </a:ext>
+            </a:extLst>
+          </a:blip>
         </p:blipFill>
         <p:spPr bwMode="auto">
           <a:xfrm flipH="0" flipV="0">
-            <a:off x="3322729" y="2070920"/>
-            <a:ext cx="764547" cy="570861"/>
+            <a:off x="3477816" y="2122634"/>
+            <a:ext cx="467430" cy="467430"/>
           </a:xfrm>
           <a:prstGeom prst="rect">
             <a:avLst/>
@@ -13948,19 +14044,25 @@
       </p:pic>
       <p:pic>
         <p:nvPicPr>
-          <p:cNvPr id="1562379801" name="Picture 72"/>
+          <p:cNvPr id="2087555763" name="Picture 24"/>
           <p:cNvPicPr>
             <a:picLocks noChangeAspect="1"/>
           </p:cNvPicPr>
           <p:nvPr/>
         </p:nvPicPr>
         <p:blipFill rotWithShape="1">
-          <a:blip r:embed="rId3"/>
+          <a:blip r:embed="rId3">
+            <a:extLst>
+              <a:ext uri="{96DAC541-7B7A-43D3-8B79-37D633B846F1}">
+                <asvg:svgBlip xmlns:asvg="http://schemas.microsoft.com/office/drawing/2016/SVG/main" r:embed="rId4"/>
+              </a:ext>
+            </a:extLst>
+          </a:blip>
         </p:blipFill>
         <p:spPr bwMode="auto">
           <a:xfrm flipH="0" flipV="0">
-            <a:off x="3322729" y="2932608"/>
-            <a:ext cx="764547" cy="570861"/>
+            <a:off x="3477816" y="2982062"/>
+            <a:ext cx="467430" cy="467430"/>
           </a:xfrm>
           <a:prstGeom prst="rect">
             <a:avLst/>
@@ -13969,19 +14071,25 @@
       </p:pic>
       <p:pic>
         <p:nvPicPr>
-          <p:cNvPr id="326190177" name="Picture 73"/>
+          <p:cNvPr id="1046039785" name="Picture 25"/>
           <p:cNvPicPr>
             <a:picLocks noChangeAspect="1"/>
           </p:cNvPicPr>
           <p:nvPr/>
         </p:nvPicPr>
         <p:blipFill rotWithShape="1">
-          <a:blip r:embed="rId3"/>
+          <a:blip r:embed="rId3">
+            <a:extLst>
+              <a:ext uri="{96DAC541-7B7A-43D3-8B79-37D633B846F1}">
+                <asvg:svgBlip xmlns:asvg="http://schemas.microsoft.com/office/drawing/2016/SVG/main" r:embed="rId4"/>
+              </a:ext>
+            </a:extLst>
+          </a:blip>
         </p:blipFill>
         <p:spPr bwMode="auto">
           <a:xfrm flipH="0" flipV="0">
-            <a:off x="3322729" y="3827287"/>
-            <a:ext cx="764547" cy="570861"/>
+            <a:off x="3488399" y="3870383"/>
+            <a:ext cx="467430" cy="467430"/>
           </a:xfrm>
           <a:prstGeom prst="rect">
             <a:avLst/>
@@ -13990,19 +14098,25 @@
       </p:pic>
       <p:pic>
         <p:nvPicPr>
-          <p:cNvPr id="408431408" name="Picture 74"/>
+          <p:cNvPr id="1744546781" name="Picture 26"/>
           <p:cNvPicPr>
             <a:picLocks noChangeAspect="1"/>
           </p:cNvPicPr>
           <p:nvPr/>
         </p:nvPicPr>
         <p:blipFill rotWithShape="1">
-          <a:blip r:embed="rId3"/>
+          <a:blip r:embed="rId3">
+            <a:extLst>
+              <a:ext uri="{96DAC541-7B7A-43D3-8B79-37D633B846F1}">
+                <asvg:svgBlip xmlns:asvg="http://schemas.microsoft.com/office/drawing/2016/SVG/main" r:embed="rId4"/>
+              </a:ext>
+            </a:extLst>
+          </a:blip>
         </p:blipFill>
         <p:spPr bwMode="auto">
           <a:xfrm flipH="0" flipV="0">
-            <a:off x="3354479" y="4709943"/>
-            <a:ext cx="764547" cy="570861"/>
+            <a:off x="3477816" y="4761657"/>
+            <a:ext cx="467430" cy="467430"/>
           </a:xfrm>
           <a:prstGeom prst="rect">
             <a:avLst/>
@@ -14048,7 +14162,7 @@
       </p:grpSpPr>
       <p:sp>
         <p:nvSpPr>
-          <p:cNvPr id="972704913" name="Title 1"/>
+          <p:cNvPr id="1924796314" name="Title 1"/>
           <p:cNvSpPr>
             <a:spLocks noGrp="1"/>
           </p:cNvSpPr>
@@ -14058,7 +14172,7 @@
         </p:nvSpPr>
         <p:spPr bwMode="auto">
           <a:xfrm flipH="0" flipV="0">
-            <a:off x="3739004" y="2514948"/>
+            <a:off x="3886940" y="2514946"/>
             <a:ext cx="4703581" cy="1294743"/>
           </a:xfrm>
         </p:spPr>
@@ -14080,7 +14194,7 @@
                 <a:ea typeface="Michroma"/>
                 <a:cs typeface="Michroma"/>
               </a:rPr>
-              <a:t>Grazie per l’attenzione !</a:t>
+              <a:t>Grazie per l’attenzione!</a:t>
             </a:r>
             <a:endParaRPr sz="3200">
               <a:solidFill>
@@ -14094,7 +14208,7 @@
       </p:sp>
       <p:sp>
         <p:nvSpPr>
-          <p:cNvPr id="1490949826" name="Subtitle 2"/>
+          <p:cNvPr id="1783184892" name="Subtitle 2"/>
           <p:cNvSpPr>
             <a:spLocks noGrp="1"/>
           </p:cNvSpPr>
@@ -14104,7 +14218,7 @@
         </p:nvSpPr>
         <p:spPr bwMode="auto">
           <a:xfrm flipH="0" flipV="0">
-            <a:off x="4082664" y="3896105"/>
+            <a:off x="4056664" y="3896103"/>
             <a:ext cx="4143864" cy="394222"/>
           </a:xfrm>
         </p:spPr>
@@ -14148,9 +14262,35 @@
           </a:p>
         </p:txBody>
       </p:sp>
+      <p:sp>
+        <p:nvSpPr>
+          <p:cNvPr id="2084687338" name="Slide Number Placeholder 5"/>
+          <p:cNvSpPr>
+            <a:spLocks noGrp="1"/>
+          </p:cNvSpPr>
+          <p:nvPr>
+            <p:ph type="sldNum" sz="quarter" idx="12"/>
+          </p:nvPr>
+        </p:nvSpPr>
+        <p:spPr bwMode="auto"/>
+        <p:txBody>
+          <a:bodyPr/>
+          <a:lstStyle/>
+          <a:p>
+            <a:pPr>
+              <a:defRPr/>
+            </a:pPr>
+            <a:fld id="{831E1D6D-2301-946D-6050-67FB814A68C9}" type="slidenum">
+              <a:rPr/>
+              <a:t>1</a:t>
+            </a:fld>
+            <a:endParaRPr/>
+          </a:p>
+        </p:txBody>
+      </p:sp>
       <p:pic>
         <p:nvPicPr>
-          <p:cNvPr id="698572564" name=""/>
+          <p:cNvPr id="1625931233" name="Picture 5"/>
           <p:cNvPicPr>
             <a:picLocks noChangeAspect="1"/>
           </p:cNvPicPr>
@@ -14158,72 +14298,46 @@
         </p:nvPicPr>
         <p:blipFill rotWithShape="1">
           <a:blip r:embed="rId4"/>
-          <a:stretch/>
         </p:blipFill>
         <p:spPr bwMode="auto">
           <a:xfrm flipH="0" flipV="0">
-            <a:off x="3941385" y="1029468"/>
-            <a:ext cx="4298815" cy="1485478"/>
+            <a:off x="4710366" y="1480118"/>
+            <a:ext cx="3003154" cy="993722"/>
           </a:xfrm>
           <a:prstGeom prst="rect">
             <a:avLst/>
           </a:prstGeom>
         </p:spPr>
       </p:pic>
-      <p:sp>
-        <p:nvSpPr>
-          <p:cNvPr id="1509156523" name="Slide Number Placeholder 5"/>
-          <p:cNvSpPr>
-            <a:spLocks noGrp="1"/>
-          </p:cNvSpPr>
-          <p:nvPr>
-            <p:ph type="sldNum" sz="quarter" idx="12"/>
-          </p:nvPr>
-        </p:nvSpPr>
-        <p:spPr bwMode="auto"/>
-        <p:txBody>
-          <a:bodyPr/>
-          <a:lstStyle/>
-          <a:p>
-            <a:pPr>
-              <a:defRPr/>
-            </a:pPr>
-            <a:fld id="{831E1D6D-2301-946D-6050-67FB814A68C9}" type="slidenum">
-              <a:rPr/>
-              <a:t>1</a:t>
-            </a:fld>
-            <a:endParaRPr/>
-          </a:p>
-        </p:txBody>
-      </p:sp>
-      <p:sp>
-        <p:nvSpPr>
-          <p:cNvPr id="419069902" name="Rectangle 9"/>
-          <p:cNvSpPr txBox="1"/>
+      <p:pic>
+        <p:nvPicPr>
+          <p:cNvPr id="911191967" name="Picture 7"/>
+          <p:cNvPicPr>
+            <a:picLocks noChangeAspect="1"/>
+          </p:cNvPicPr>
           <p:nvPr/>
-        </p:nvSpPr>
+        </p:nvPicPr>
+        <p:blipFill rotWithShape="1">
+          <a:blip r:embed="rId5">
+            <a:alphaModFix amt="99999"/>
+            <a:extLst>
+              <a:ext uri="{96DAC541-7B7A-43D3-8B79-37D633B846F1}">
+                <asvg:svgBlip xmlns:asvg="http://schemas.microsoft.com/office/drawing/2016/SVG/main" r:embed="rId6"/>
+              </a:ext>
+            </a:extLst>
+          </a:blip>
+          <a:stretch/>
+        </p:blipFill>
         <p:spPr bwMode="auto">
-          <a:xfrm rot="0" flipH="0" flipV="0">
-            <a:off x="5889468" y="3062880"/>
-            <a:ext cx="914400" cy="366118"/>
+          <a:xfrm flipH="0" flipV="0">
+            <a:off x="7691558" y="3940449"/>
+            <a:ext cx="166403" cy="162081"/>
           </a:xfrm>
           <a:prstGeom prst="rect">
             <a:avLst/>
           </a:prstGeom>
-          <a:noFill/>
         </p:spPr>
-        <p:txBody>
-          <a:bodyPr vertOverflow="overflow" horzOverflow="overflow" vert="horz" wrap="none" lIns="91440" tIns="45720" rIns="91440" bIns="45720" numCol="1" spcCol="0" rtlCol="0" fromWordArt="0" anchor="t" anchorCtr="0" forceAA="0" upright="0" compatLnSpc="0">
-            <a:spAutoFit/>
-          </a:bodyPr>
-          <a:p>
-            <a:pPr>
-              <a:defRPr/>
-            </a:pPr>
-            <a:endParaRPr/>
-          </a:p>
-        </p:txBody>
-      </p:sp>
+      </p:pic>
     </p:spTree>
   </p:cSld>
   <p:clrMapOvr>
@@ -14237,89 +14351,7 @@
       <p:transition advClick="1"/>
     </mc:Fallback>
   </mc:AlternateContent>
-  <p:timing>
-    <p:tnLst>
-      <p:par>
-        <p:cTn id="1" dur="indefinite" restart="never" nodeType="tmRoot">
-          <p:childTnLst>
-            <p:seq concurrent="1" nextAc="seek">
-              <p:cTn id="2" dur="indefinite" nodeType="mainSeq">
-                <p:childTnLst>
-                  <p:par>
-                    <p:cTn id="3" fill="hold">
-                      <p:stCondLst>
-                        <p:cond delay="indefinite"/>
-                      </p:stCondLst>
-                      <p:childTnLst>
-                        <p:par>
-                          <p:cTn id="4" fill="hold">
-                            <p:stCondLst>
-                              <p:cond delay="0"/>
-                            </p:stCondLst>
-                            <p:childTnLst>
-                              <p:par>
-                                <p:cTn id="41" presetID="10" presetClass="entr" presetSubtype="0" fill="hold" grpId="0" nodeType="withEffect">
-                                  <p:stCondLst>
-                                    <p:cond delay="0"/>
-                                  </p:stCondLst>
-                                  <p:childTnLst>
-                                    <p:set>
-                                      <p:cBhvr>
-                                        <p:cTn id="43" dur="1" fill="hold">
-                                          <p:stCondLst>
-                                            <p:cond delay="0"/>
-                                          </p:stCondLst>
-                                        </p:cTn>
-                                        <p:tgtEl>
-                                          <p:spTgt spid="419069902"/>
-                                        </p:tgtEl>
-                                        <p:attrNameLst>
-                                          <p:attrName>style.visibility</p:attrName>
-                                        </p:attrNameLst>
-                                      </p:cBhvr>
-                                      <p:to>
-                                        <p:strVal val="visible"/>
-                                      </p:to>
-                                    </p:set>
-                                    <p:animEffect transition="in" filter="fade">
-                                      <p:cBhvr>
-                                        <p:cTn id="42" dur="500"/>
-                                        <p:tgtEl>
-                                          <p:spTgt spid="419069902"/>
-                                        </p:tgtEl>
-                                      </p:cBhvr>
-                                    </p:animEffect>
-                                  </p:childTnLst>
-                                </p:cTn>
-                              </p:par>
-                            </p:childTnLst>
-                          </p:cTn>
-                        </p:par>
-                      </p:childTnLst>
-                    </p:cTn>
-                  </p:par>
-                </p:childTnLst>
-              </p:cTn>
-              <p:prevCondLst>
-                <p:cond evt="onPrev" delay="0">
-                  <p:tgtEl>
-                    <p:sldTgt/>
-                  </p:tgtEl>
-                </p:cond>
-              </p:prevCondLst>
-              <p:nextCondLst>
-                <p:cond evt="onNext" delay="0">
-                  <p:tgtEl>
-                    <p:sldTgt/>
-                  </p:tgtEl>
-                </p:cond>
-              </p:nextCondLst>
-            </p:seq>
-          </p:childTnLst>
-        </p:cTn>
-      </p:par>
-    </p:tnLst>
-  </p:timing>
+  <p:timing/>
 </p:sld>
 </file>
 

</xml_diff>